<commit_message>
Add submission detail placeholders
</commit_message>
<xml_diff>
--- a/deliverables/MietCheck_Praesentation.pptx
+++ b/deliverables/MietCheck_Praesentation.pptx
@@ -2,26 +2,26 @@
 <file path=ppt/presentation.xml><?xml version="1.0" encoding="utf-8"?>
 <p:presentation xmlns:p="http://schemas.openxmlformats.org/presentationml/2006/main">
   <p:sldMasterIdLst>
-    <p:sldMasterId xmlns:r="http://schemas.openxmlformats.org/officeDocument/2006/relationships" id="2147483648" r:id="R75324078bb3946eb"/>
+    <p:sldMasterId xmlns:r="http://schemas.openxmlformats.org/officeDocument/2006/relationships" id="2147483648" r:id="R2ed3c811527a48a4"/>
   </p:sldMasterIdLst>
   <p:notesMasterIdLst>
-    <p:notesMasterId xmlns:r="http://schemas.openxmlformats.org/officeDocument/2006/relationships" r:id="Rc88d52f636064f83"/>
+    <p:notesMasterId xmlns:r="http://schemas.openxmlformats.org/officeDocument/2006/relationships" r:id="R6e5b81aac8b64d54"/>
   </p:notesMasterIdLst>
   <p:sldIdLst>
-    <p:sldId xmlns:r="http://schemas.openxmlformats.org/officeDocument/2006/relationships" id="256" r:id="Raefb9e3d115e42a5"/>
-    <p:sldId xmlns:r="http://schemas.openxmlformats.org/officeDocument/2006/relationships" id="257" r:id="R0c587ce39be94f38"/>
-    <p:sldId xmlns:r="http://schemas.openxmlformats.org/officeDocument/2006/relationships" id="258" r:id="R3adbdf37452548a0"/>
-    <p:sldId xmlns:r="http://schemas.openxmlformats.org/officeDocument/2006/relationships" id="259" r:id="Rcba21ef9a72b478b"/>
-    <p:sldId xmlns:r="http://schemas.openxmlformats.org/officeDocument/2006/relationships" id="260" r:id="R82ddeb0468324f48"/>
-    <p:sldId xmlns:r="http://schemas.openxmlformats.org/officeDocument/2006/relationships" id="261" r:id="R2dc2a4cb7146437e"/>
-    <p:sldId xmlns:r="http://schemas.openxmlformats.org/officeDocument/2006/relationships" id="262" r:id="R7731acd1ad27433b"/>
-    <p:sldId xmlns:r="http://schemas.openxmlformats.org/officeDocument/2006/relationships" id="263" r:id="Rbea6ca6a1a8f4494"/>
-    <p:sldId xmlns:r="http://schemas.openxmlformats.org/officeDocument/2006/relationships" id="264" r:id="Rc807cf6e4487470e"/>
-    <p:sldId xmlns:r="http://schemas.openxmlformats.org/officeDocument/2006/relationships" id="265" r:id="R9b4c01135850469d"/>
-    <p:sldId xmlns:r="http://schemas.openxmlformats.org/officeDocument/2006/relationships" id="266" r:id="R4fab4fe5c88642f7"/>
-    <p:sldId xmlns:r="http://schemas.openxmlformats.org/officeDocument/2006/relationships" id="267" r:id="R4380dbda21f74c65"/>
-    <p:sldId xmlns:r="http://schemas.openxmlformats.org/officeDocument/2006/relationships" id="268" r:id="R0da7e247681840a3"/>
-    <p:sldId xmlns:r="http://schemas.openxmlformats.org/officeDocument/2006/relationships" id="269" r:id="R3b57737208c04035"/>
+    <p:sldId xmlns:r="http://schemas.openxmlformats.org/officeDocument/2006/relationships" id="256" r:id="R7eef9dd699f24630"/>
+    <p:sldId xmlns:r="http://schemas.openxmlformats.org/officeDocument/2006/relationships" id="257" r:id="Rac611ec249a64d37"/>
+    <p:sldId xmlns:r="http://schemas.openxmlformats.org/officeDocument/2006/relationships" id="258" r:id="R08b4ba35de2e4d51"/>
+    <p:sldId xmlns:r="http://schemas.openxmlformats.org/officeDocument/2006/relationships" id="259" r:id="Rc4fbcc0abfed4b58"/>
+    <p:sldId xmlns:r="http://schemas.openxmlformats.org/officeDocument/2006/relationships" id="260" r:id="Re2a3bbff5997465e"/>
+    <p:sldId xmlns:r="http://schemas.openxmlformats.org/officeDocument/2006/relationships" id="261" r:id="Rf1b16a4d14f548a2"/>
+    <p:sldId xmlns:r="http://schemas.openxmlformats.org/officeDocument/2006/relationships" id="262" r:id="Rde7e3db2fd1e4aa7"/>
+    <p:sldId xmlns:r="http://schemas.openxmlformats.org/officeDocument/2006/relationships" id="263" r:id="R6d325a275fc044c9"/>
+    <p:sldId xmlns:r="http://schemas.openxmlformats.org/officeDocument/2006/relationships" id="264" r:id="R6fc18b977f134eff"/>
+    <p:sldId xmlns:r="http://schemas.openxmlformats.org/officeDocument/2006/relationships" id="265" r:id="Rc3bcdf1881244a76"/>
+    <p:sldId xmlns:r="http://schemas.openxmlformats.org/officeDocument/2006/relationships" id="266" r:id="Rd900c21d899847ec"/>
+    <p:sldId xmlns:r="http://schemas.openxmlformats.org/officeDocument/2006/relationships" id="267" r:id="R12d77845039e4c42"/>
+    <p:sldId xmlns:r="http://schemas.openxmlformats.org/officeDocument/2006/relationships" id="268" r:id="Rfec8690f2e104059"/>
+    <p:sldId xmlns:r="http://schemas.openxmlformats.org/officeDocument/2006/relationships" id="269" r:id="R4ef482a192824939"/>
   </p:sldIdLst>
   <p:sldSz cx="12192000" cy="6858000"/>
   <p:notesSz cx="6858000" cy="9144000"/>
@@ -1668,7 +1668,7 @@
   </p:cSld>
   <p:clrMap bg1="lt1" tx1="dk1" bg2="lt2" tx2="dk2" accent1="accent1" accent2="accent2" accent3="accent3" accent4="accent4" accent5="accent5" accent6="accent6" hlink="hlink" folHlink="folHlink"/>
   <p:sldLayoutIdLst>
-    <p:sldLayoutId xmlns:r="http://schemas.openxmlformats.org/officeDocument/2006/relationships" id="2147483649" r:id="R53a3f5236ca54f66"/>
+    <p:sldLayoutId xmlns:r="http://schemas.openxmlformats.org/officeDocument/2006/relationships" id="2147483649" r:id="Rb8e7f79ecff4448f"/>
   </p:sldLayoutIdLst>
   <p:txStyles>
     <p:titleStyle>
@@ -2910,7 +2910,7 @@
           <p:cNvPr id="8" name="cover-accent">
             <a:extLst xmlns:a="http://schemas.openxmlformats.org/drawingml/2006/main">
               <a:ext uri="{FF2B5EF4-FFF2-40B4-BE49-F238E27FC236}">
-                <a16:creationId xmlns:a16="http://schemas.microsoft.com/office/drawing/2014/main" id="{F1F1316B-D515-4648-A459-EA877B85AAF0}"/>
+                <a16:creationId xmlns:a16="http://schemas.microsoft.com/office/drawing/2014/main" id="{2F5CE8BC-A1CB-46BC-B1FB-603D55B6C5D5}"/>
               </a:ext>
             </a:extLst>
           </p:cNvPr>
@@ -2943,7 +2943,7 @@
           <p:cNvPr id="2" name="cover-brand">
             <a:extLst xmlns:a="http://schemas.openxmlformats.org/drawingml/2006/main">
               <a:ext uri="{FF2B5EF4-FFF2-40B4-BE49-F238E27FC236}">
-                <a16:creationId xmlns:a16="http://schemas.microsoft.com/office/drawing/2014/main" id="{14946499-5AA2-4443-9570-4E7991512C3B}"/>
+                <a16:creationId xmlns:a16="http://schemas.microsoft.com/office/drawing/2014/main" id="{B80C002B-F0E5-400E-8896-4883E691D752}"/>
               </a:ext>
             </a:extLst>
           </p:cNvPr>
@@ -2988,7 +2988,7 @@
           <p:cNvPr id="3" name="cover-title">
             <a:extLst xmlns:a="http://schemas.openxmlformats.org/drawingml/2006/main">
               <a:ext uri="{FF2B5EF4-FFF2-40B4-BE49-F238E27FC236}">
-                <a16:creationId xmlns:a16="http://schemas.microsoft.com/office/drawing/2014/main" id="{8841AD42-A1BC-4705-A78A-39496CE04572}"/>
+                <a16:creationId xmlns:a16="http://schemas.microsoft.com/office/drawing/2014/main" id="{24B7092F-4920-4B1E-AC59-85D79D6E9530}"/>
               </a:ext>
             </a:extLst>
           </p:cNvPr>
@@ -3035,7 +3035,7 @@
           <p:cNvPr id="4" name="cover-subtitle">
             <a:extLst xmlns:a="http://schemas.openxmlformats.org/drawingml/2006/main">
               <a:ext uri="{FF2B5EF4-FFF2-40B4-BE49-F238E27FC236}">
-                <a16:creationId xmlns:a16="http://schemas.microsoft.com/office/drawing/2014/main" id="{49659566-A5F0-4C00-B92C-3D082B57026D}"/>
+                <a16:creationId xmlns:a16="http://schemas.microsoft.com/office/drawing/2014/main" id="{4FF374D0-E1D6-49B6-8C83-D764572BA01A}"/>
               </a:ext>
             </a:extLst>
           </p:cNvPr>
@@ -3080,19 +3080,19 @@
           <p:cNvPr id="5" name="cover-meta">
             <a:extLst xmlns:a="http://schemas.openxmlformats.org/drawingml/2006/main">
               <a:ext uri="{FF2B5EF4-FFF2-40B4-BE49-F238E27FC236}">
-                <a16:creationId xmlns:a16="http://schemas.microsoft.com/office/drawing/2014/main" id="{D48E3171-14C8-40F7-AAE2-DC5E9D247063}"/>
-              </a:ext>
-            </a:extLst>
-          </p:cNvPr>
-          <p:cNvSpPr>
-            <a:spLocks xmlns:a="http://schemas.openxmlformats.org/drawingml/2006/main" noGrp="1"/>
-          </p:cNvSpPr>
-          <p:nvPr/>
-        </p:nvSpPr>
-        <p:spPr>
-          <a:xfrm xmlns:a="http://schemas.openxmlformats.org/drawingml/2006/main">
-            <a:off x="533400" y="5924550"/>
-            <a:ext cx="5334000" cy="304800"/>
+                <a16:creationId xmlns:a16="http://schemas.microsoft.com/office/drawing/2014/main" id="{111E5189-12F0-4C5E-BCCF-624AD098A6A1}"/>
+              </a:ext>
+            </a:extLst>
+          </p:cNvPr>
+          <p:cNvSpPr>
+            <a:spLocks xmlns:a="http://schemas.openxmlformats.org/drawingml/2006/main" noGrp="1"/>
+          </p:cNvSpPr>
+          <p:nvPr/>
+        </p:nvSpPr>
+        <p:spPr>
+          <a:xfrm xmlns:a="http://schemas.openxmlformats.org/drawingml/2006/main">
+            <a:off x="533400" y="5657850"/>
+            <a:ext cx="5334000" cy="609600"/>
           </a:xfrm>
           <a:prstGeom xmlns:a="http://schemas.openxmlformats.org/drawingml/2006/main" prst="rect">
             <a:avLst/>
@@ -3105,7 +3105,7 @@
           <a:lstStyle xmlns:a="http://schemas.openxmlformats.org/drawingml/2006/main"/>
           <a:p xmlns:a="http://schemas.openxmlformats.org/drawingml/2006/main">
             <a:pPr algn="l">
-              <a:defRPr sz="1350" b="0" i="0">
+              <a:defRPr sz="1200" b="0" i="0">
                 <a:solidFill>
                   <a:srgbClr val="667085"/>
                 </a:solidFill>
@@ -3115,7 +3115,8 @@
               </a:defRPr>
             </a:pPr>
             <a:r>
-              <a:t>Nele Knaak · Data Analytics &amp; Big Data · 2026</a:t>
+              <a:t>Nele Knaak · Matrikel-Nr.: [EINTRAGEN]
+Prüfer/in: [EINTRAGEN] · Abgabe: [TT.MM.JJJJ]</a:t>
             </a:r>
           </a:p>
         </p:txBody>
@@ -3125,7 +3126,7 @@
           <p:cNvPr id="6" name="cover-image-back">
             <a:extLst xmlns:a="http://schemas.openxmlformats.org/drawingml/2006/main">
               <a:ext uri="{FF2B5EF4-FFF2-40B4-BE49-F238E27FC236}">
-                <a16:creationId xmlns:a16="http://schemas.microsoft.com/office/drawing/2014/main" id="{E6CC6C6B-3A8D-468E-9928-E4F8C0B41014}"/>
+                <a16:creationId xmlns:a16="http://schemas.microsoft.com/office/drawing/2014/main" id="{66BF2759-A76D-4D09-8BB4-0661D2735632}"/>
               </a:ext>
             </a:extLst>
           </p:cNvPr>
@@ -3164,7 +3165,7 @@
           <p:nvPr/>
         </p:nvPicPr>
         <p:blipFill>
-          <a:blip xmlns:r="http://schemas.openxmlformats.org/officeDocument/2006/relationships" xmlns:a="http://schemas.openxmlformats.org/drawingml/2006/main" r:embed="Re18e8b7855a64dad"/>
+          <a:blip xmlns:r="http://schemas.openxmlformats.org/officeDocument/2006/relationships" xmlns:a="http://schemas.openxmlformats.org/drawingml/2006/main" r:embed="R051d8e8e304c4d25"/>
           <a:srcRect xmlns:a="http://schemas.openxmlformats.org/drawingml/2006/main" l="13781" t="0" r="13781" b="0"/>
           <a:stretch xmlns:a="http://schemas.openxmlformats.org/drawingml/2006/main">
             <a:fillRect l="0" t="0" r="0" b="0"/>
@@ -3185,7 +3186,7 @@
     </p:spTree>
     <p:extLst>
       <p:ext uri="{BB962C8B-B14F-4D97-AF65-F5344CB8AC3E}">
-        <p14:creationId xmlns:p14="http://schemas.microsoft.com/office/powerpoint/2010/main" val="477790122"/>
+        <p14:creationId xmlns:p14="http://schemas.microsoft.com/office/powerpoint/2010/main" val="387336420"/>
       </p:ext>
     </p:extLst>
   </p:cSld>
@@ -3216,7 +3217,7 @@
           <p:cNvPr id="12" name="title-10">
             <a:extLst xmlns:a="http://schemas.openxmlformats.org/drawingml/2006/main">
               <a:ext uri="{FF2B5EF4-FFF2-40B4-BE49-F238E27FC236}">
-                <a16:creationId xmlns:a16="http://schemas.microsoft.com/office/drawing/2014/main" id="{4B9364AA-F9A3-49E5-8436-F638A1C12AFF}"/>
+                <a16:creationId xmlns:a16="http://schemas.microsoft.com/office/drawing/2014/main" id="{A82E0B9D-6FC3-46A9-9433-330AC298750B}"/>
               </a:ext>
             </a:extLst>
           </p:cNvPr>
@@ -3261,7 +3262,7 @@
           <p:cNvPr id="2" name="source-10">
             <a:extLst xmlns:a="http://schemas.openxmlformats.org/drawingml/2006/main">
               <a:ext uri="{FF2B5EF4-FFF2-40B4-BE49-F238E27FC236}">
-                <a16:creationId xmlns:a16="http://schemas.microsoft.com/office/drawing/2014/main" id="{1DBA291C-AE64-4FE8-8428-A5E05977ACC4}"/>
+                <a16:creationId xmlns:a16="http://schemas.microsoft.com/office/drawing/2014/main" id="{2941ADB7-CAE3-4050-B6CF-FF7CBC487645}"/>
               </a:ext>
             </a:extLst>
           </p:cNvPr>
@@ -3306,7 +3307,7 @@
           <p:cNvPr id="3" name="page-10">
             <a:extLst xmlns:a="http://schemas.openxmlformats.org/drawingml/2006/main">
               <a:ext uri="{FF2B5EF4-FFF2-40B4-BE49-F238E27FC236}">
-                <a16:creationId xmlns:a16="http://schemas.microsoft.com/office/drawing/2014/main" id="{E2939921-442B-4265-B625-A56F3D36C437}"/>
+                <a16:creationId xmlns:a16="http://schemas.microsoft.com/office/drawing/2014/main" id="{471ADCF8-60BD-436F-89F4-A36B18ED571F}"/>
               </a:ext>
             </a:extLst>
           </p:cNvPr>
@@ -3351,7 +3352,7 @@
           <p:cNvPr id="4" name="screenshot-back">
             <a:extLst xmlns:a="http://schemas.openxmlformats.org/drawingml/2006/main">
               <a:ext uri="{FF2B5EF4-FFF2-40B4-BE49-F238E27FC236}">
-                <a16:creationId xmlns:a16="http://schemas.microsoft.com/office/drawing/2014/main" id="{17D67F0C-339F-47F4-9070-CA4B01C0F858}"/>
+                <a16:creationId xmlns:a16="http://schemas.microsoft.com/office/drawing/2014/main" id="{695226D4-076D-44D5-BAF5-64F4B814A595}"/>
               </a:ext>
             </a:extLst>
           </p:cNvPr>
@@ -3384,7 +3385,7 @@
           <p:cNvPr id="5" name="product-one">
             <a:extLst xmlns:a="http://schemas.openxmlformats.org/drawingml/2006/main">
               <a:ext uri="{FF2B5EF4-FFF2-40B4-BE49-F238E27FC236}">
-                <a16:creationId xmlns:a16="http://schemas.microsoft.com/office/drawing/2014/main" id="{18442B5D-D9C7-433D-B333-4FB435E2B6E9}"/>
+                <a16:creationId xmlns:a16="http://schemas.microsoft.com/office/drawing/2014/main" id="{0190F02F-E9AB-43DD-90A1-839E85AA8F1A}"/>
               </a:ext>
             </a:extLst>
           </p:cNvPr>
@@ -3429,7 +3430,7 @@
           <p:cNvPr id="6" name="product-two">
             <a:extLst xmlns:a="http://schemas.openxmlformats.org/drawingml/2006/main">
               <a:ext uri="{FF2B5EF4-FFF2-40B4-BE49-F238E27FC236}">
-                <a16:creationId xmlns:a16="http://schemas.microsoft.com/office/drawing/2014/main" id="{C7AB43F5-0FB0-465E-9B93-FE3965EA8CE2}"/>
+                <a16:creationId xmlns:a16="http://schemas.microsoft.com/office/drawing/2014/main" id="{5B70C3CB-487B-48B1-BF9B-E276143CA75E}"/>
               </a:ext>
             </a:extLst>
           </p:cNvPr>
@@ -3474,7 +3475,7 @@
           <p:cNvPr id="7" name="product-three">
             <a:extLst xmlns:a="http://schemas.openxmlformats.org/drawingml/2006/main">
               <a:ext uri="{FF2B5EF4-FFF2-40B4-BE49-F238E27FC236}">
-                <a16:creationId xmlns:a16="http://schemas.microsoft.com/office/drawing/2014/main" id="{43003FAB-111B-4EA5-876E-ADB5CC3DDE42}"/>
+                <a16:creationId xmlns:a16="http://schemas.microsoft.com/office/drawing/2014/main" id="{443561DE-82E1-4CC4-8FED-BF757928B12F}"/>
               </a:ext>
             </a:extLst>
           </p:cNvPr>
@@ -3523,7 +3524,7 @@
           <p:nvPr/>
         </p:nvPicPr>
         <p:blipFill>
-          <a:blip xmlns:r="http://schemas.openxmlformats.org/officeDocument/2006/relationships" xmlns:a="http://schemas.openxmlformats.org/drawingml/2006/main" r:embed="Rf4602a6bfaa14377"/>
+          <a:blip xmlns:r="http://schemas.openxmlformats.org/officeDocument/2006/relationships" xmlns:a="http://schemas.openxmlformats.org/drawingml/2006/main" r:embed="Re7efb069443a4cf6"/>
           <a:srcRect xmlns:a="http://schemas.openxmlformats.org/drawingml/2006/main" l="0" t="24967" r="0" b="24967"/>
           <a:stretch xmlns:a="http://schemas.openxmlformats.org/drawingml/2006/main">
             <a:fillRect l="0" t="0" r="0" b="0"/>
@@ -3544,7 +3545,7 @@
           <p:cNvPr id="9" name="product-mask">
             <a:extLst xmlns:a="http://schemas.openxmlformats.org/drawingml/2006/main">
               <a:ext uri="{FF2B5EF4-FFF2-40B4-BE49-F238E27FC236}">
-                <a16:creationId xmlns:a16="http://schemas.microsoft.com/office/drawing/2014/main" id="{EE2E2D41-5816-469E-AB5D-D2A53F1FBB7C}"/>
+                <a16:creationId xmlns:a16="http://schemas.microsoft.com/office/drawing/2014/main" id="{AF7F66EE-75AA-44DF-9131-63471C022582}"/>
               </a:ext>
             </a:extLst>
           </p:cNvPr>
@@ -3577,7 +3578,7 @@
           <p:cNvPr id="10" name="product-mask-copy">
             <a:extLst xmlns:a="http://schemas.openxmlformats.org/drawingml/2006/main">
               <a:ext uri="{FF2B5EF4-FFF2-40B4-BE49-F238E27FC236}">
-                <a16:creationId xmlns:a16="http://schemas.microsoft.com/office/drawing/2014/main" id="{3400BC87-1B46-4448-B5C2-268CA5127A41}"/>
+                <a16:creationId xmlns:a16="http://schemas.microsoft.com/office/drawing/2014/main" id="{93513561-D5A8-4F72-BC60-7A1F23FD2DAE}"/>
               </a:ext>
             </a:extLst>
           </p:cNvPr>
@@ -3622,7 +3623,7 @@
           <p:cNvPr id="11" name="product-mask-subcopy">
             <a:extLst xmlns:a="http://schemas.openxmlformats.org/drawingml/2006/main">
               <a:ext uri="{FF2B5EF4-FFF2-40B4-BE49-F238E27FC236}">
-                <a16:creationId xmlns:a16="http://schemas.microsoft.com/office/drawing/2014/main" id="{7AA43EFA-20C6-416D-BA01-7134A61DFB4B}"/>
+                <a16:creationId xmlns:a16="http://schemas.microsoft.com/office/drawing/2014/main" id="{F325C2DD-EFA2-43ED-B582-34DEF617C256}"/>
               </a:ext>
             </a:extLst>
           </p:cNvPr>
@@ -3665,7 +3666,7 @@
     </p:spTree>
     <p:extLst>
       <p:ext uri="{BB962C8B-B14F-4D97-AF65-F5344CB8AC3E}">
-        <p14:creationId xmlns:p14="http://schemas.microsoft.com/office/powerpoint/2010/main" val="1566091667"/>
+        <p14:creationId xmlns:p14="http://schemas.microsoft.com/office/powerpoint/2010/main" val="1554764577"/>
       </p:ext>
     </p:extLst>
   </p:cSld>
@@ -3696,7 +3697,7 @@
           <p:cNvPr id="26" name="title-11">
             <a:extLst xmlns:a="http://schemas.openxmlformats.org/drawingml/2006/main">
               <a:ext uri="{FF2B5EF4-FFF2-40B4-BE49-F238E27FC236}">
-                <a16:creationId xmlns:a16="http://schemas.microsoft.com/office/drawing/2014/main" id="{4BBFF05A-DB1A-43E9-B33F-3C6C32342FCB}"/>
+                <a16:creationId xmlns:a16="http://schemas.microsoft.com/office/drawing/2014/main" id="{F3B6E8D7-9739-4977-AD19-5AC32E782B0E}"/>
               </a:ext>
             </a:extLst>
           </p:cNvPr>
@@ -3741,7 +3742,7 @@
           <p:cNvPr id="2" name="source-11">
             <a:extLst xmlns:a="http://schemas.openxmlformats.org/drawingml/2006/main">
               <a:ext uri="{FF2B5EF4-FFF2-40B4-BE49-F238E27FC236}">
-                <a16:creationId xmlns:a16="http://schemas.microsoft.com/office/drawing/2014/main" id="{A1ED67E4-3683-4C5A-BACA-73D4F5F115C8}"/>
+                <a16:creationId xmlns:a16="http://schemas.microsoft.com/office/drawing/2014/main" id="{3043B9B6-E81A-4E43-BFCC-B4EAE7ABB70D}"/>
               </a:ext>
             </a:extLst>
           </p:cNvPr>
@@ -3786,7 +3787,7 @@
           <p:cNvPr id="3" name="page-11">
             <a:extLst xmlns:a="http://schemas.openxmlformats.org/drawingml/2006/main">
               <a:ext uri="{FF2B5EF4-FFF2-40B4-BE49-F238E27FC236}">
-                <a16:creationId xmlns:a16="http://schemas.microsoft.com/office/drawing/2014/main" id="{FA7BB8DF-83ED-4AE5-A729-61F959A6EF04}"/>
+                <a16:creationId xmlns:a16="http://schemas.microsoft.com/office/drawing/2014/main" id="{E6737DEE-5F9E-4F84-9877-535EEDA584D4}"/>
               </a:ext>
             </a:extLst>
           </p:cNvPr>
@@ -3831,7 +3832,7 @@
           <p:cNvPr id="4" name="limits-lead">
             <a:extLst xmlns:a="http://schemas.openxmlformats.org/drawingml/2006/main">
               <a:ext uri="{FF2B5EF4-FFF2-40B4-BE49-F238E27FC236}">
-                <a16:creationId xmlns:a16="http://schemas.microsoft.com/office/drawing/2014/main" id="{458E9E20-7FA8-494D-BB57-BDC2A4A6F056}"/>
+                <a16:creationId xmlns:a16="http://schemas.microsoft.com/office/drawing/2014/main" id="{BA51CD8B-A43F-414C-AA24-22A35706A6AA}"/>
               </a:ext>
             </a:extLst>
           </p:cNvPr>
@@ -3898,7 +3899,7 @@
           <p:cNvPr id="6" name="limits-left-title">
             <a:extLst xmlns:a="http://schemas.openxmlformats.org/drawingml/2006/main">
               <a:ext uri="{FF2B5EF4-FFF2-40B4-BE49-F238E27FC236}">
-                <a16:creationId xmlns:a16="http://schemas.microsoft.com/office/drawing/2014/main" id="{2B010F2C-CD01-4831-943E-D50EC248D429}"/>
+                <a16:creationId xmlns:a16="http://schemas.microsoft.com/office/drawing/2014/main" id="{4EB8064A-0538-41D2-B2B0-711AF12841AE}"/>
               </a:ext>
             </a:extLst>
           </p:cNvPr>
@@ -3943,7 +3944,7 @@
           <p:cNvPr id="7" name="limits-right-title">
             <a:extLst xmlns:a="http://schemas.openxmlformats.org/drawingml/2006/main">
               <a:ext uri="{FF2B5EF4-FFF2-40B4-BE49-F238E27FC236}">
-                <a16:creationId xmlns:a16="http://schemas.microsoft.com/office/drawing/2014/main" id="{F80A7937-AE6F-4883-A1C9-631E459A5D5C}"/>
+                <a16:creationId xmlns:a16="http://schemas.microsoft.com/office/drawing/2014/main" id="{8C3523F2-D224-4861-8E9A-D9414044347B}"/>
               </a:ext>
             </a:extLst>
           </p:cNvPr>
@@ -3988,7 +3989,7 @@
           <p:cNvPr id="8" name="limit-dot-0">
             <a:extLst xmlns:a="http://schemas.openxmlformats.org/drawingml/2006/main">
               <a:ext uri="{FF2B5EF4-FFF2-40B4-BE49-F238E27FC236}">
-                <a16:creationId xmlns:a16="http://schemas.microsoft.com/office/drawing/2014/main" id="{4B4CB273-96C9-4A7D-AD3F-1DB66B2D1664}"/>
+                <a16:creationId xmlns:a16="http://schemas.microsoft.com/office/drawing/2014/main" id="{8E41C597-41AA-4F1E-BA93-B39EF4B9C869}"/>
               </a:ext>
             </a:extLst>
           </p:cNvPr>
@@ -4021,7 +4022,7 @@
           <p:cNvPr id="9" name="limit-copy-0">
             <a:extLst xmlns:a="http://schemas.openxmlformats.org/drawingml/2006/main">
               <a:ext uri="{FF2B5EF4-FFF2-40B4-BE49-F238E27FC236}">
-                <a16:creationId xmlns:a16="http://schemas.microsoft.com/office/drawing/2014/main" id="{DADC4C46-CD09-4830-B207-AFFE631BD1A1}"/>
+                <a16:creationId xmlns:a16="http://schemas.microsoft.com/office/drawing/2014/main" id="{02000E97-5EA6-4596-97D2-92B05592A5E6}"/>
               </a:ext>
             </a:extLst>
           </p:cNvPr>
@@ -4066,7 +4067,7 @@
           <p:cNvPr id="10" name="mit-dot-0">
             <a:extLst xmlns:a="http://schemas.openxmlformats.org/drawingml/2006/main">
               <a:ext uri="{FF2B5EF4-FFF2-40B4-BE49-F238E27FC236}">
-                <a16:creationId xmlns:a16="http://schemas.microsoft.com/office/drawing/2014/main" id="{7DF84267-BB72-40BF-BCB7-78360A228851}"/>
+                <a16:creationId xmlns:a16="http://schemas.microsoft.com/office/drawing/2014/main" id="{3687C15A-B31F-4FB2-A8DB-DE4A273A6101}"/>
               </a:ext>
             </a:extLst>
           </p:cNvPr>
@@ -4099,7 +4100,7 @@
           <p:cNvPr id="11" name="mit-copy-0">
             <a:extLst xmlns:a="http://schemas.openxmlformats.org/drawingml/2006/main">
               <a:ext uri="{FF2B5EF4-FFF2-40B4-BE49-F238E27FC236}">
-                <a16:creationId xmlns:a16="http://schemas.microsoft.com/office/drawing/2014/main" id="{6FBECAE1-2BC3-47C3-A156-64EC6A683356}"/>
+                <a16:creationId xmlns:a16="http://schemas.microsoft.com/office/drawing/2014/main" id="{7D6624FC-2873-4AAF-ADF3-1282A9642382}"/>
               </a:ext>
             </a:extLst>
           </p:cNvPr>
@@ -4144,7 +4145,7 @@
           <p:cNvPr id="12" name="limit-dot-1">
             <a:extLst xmlns:a="http://schemas.openxmlformats.org/drawingml/2006/main">
               <a:ext uri="{FF2B5EF4-FFF2-40B4-BE49-F238E27FC236}">
-                <a16:creationId xmlns:a16="http://schemas.microsoft.com/office/drawing/2014/main" id="{AA4A3F48-4FB0-47DF-9EA6-A403CBA6BFCB}"/>
+                <a16:creationId xmlns:a16="http://schemas.microsoft.com/office/drawing/2014/main" id="{F1B494AD-B630-48F6-8564-49731A87029F}"/>
               </a:ext>
             </a:extLst>
           </p:cNvPr>
@@ -4177,7 +4178,7 @@
           <p:cNvPr id="13" name="limit-copy-1">
             <a:extLst xmlns:a="http://schemas.openxmlformats.org/drawingml/2006/main">
               <a:ext uri="{FF2B5EF4-FFF2-40B4-BE49-F238E27FC236}">
-                <a16:creationId xmlns:a16="http://schemas.microsoft.com/office/drawing/2014/main" id="{F7D00C48-914E-454D-89CB-9EBF5C9E3A8B}"/>
+                <a16:creationId xmlns:a16="http://schemas.microsoft.com/office/drawing/2014/main" id="{62879143-5950-4263-A6E2-519A1141F1F7}"/>
               </a:ext>
             </a:extLst>
           </p:cNvPr>
@@ -4222,7 +4223,7 @@
           <p:cNvPr id="14" name="mit-dot-1">
             <a:extLst xmlns:a="http://schemas.openxmlformats.org/drawingml/2006/main">
               <a:ext uri="{FF2B5EF4-FFF2-40B4-BE49-F238E27FC236}">
-                <a16:creationId xmlns:a16="http://schemas.microsoft.com/office/drawing/2014/main" id="{6EE432FE-82D6-493A-873C-B72EAB17E7FF}"/>
+                <a16:creationId xmlns:a16="http://schemas.microsoft.com/office/drawing/2014/main" id="{73D154C2-1319-4AD5-87B8-FDD31B55A068}"/>
               </a:ext>
             </a:extLst>
           </p:cNvPr>
@@ -4255,7 +4256,7 @@
           <p:cNvPr id="15" name="mit-copy-1">
             <a:extLst xmlns:a="http://schemas.openxmlformats.org/drawingml/2006/main">
               <a:ext uri="{FF2B5EF4-FFF2-40B4-BE49-F238E27FC236}">
-                <a16:creationId xmlns:a16="http://schemas.microsoft.com/office/drawing/2014/main" id="{ED4267F0-704D-4A72-BAEB-1D174DBE7A50}"/>
+                <a16:creationId xmlns:a16="http://schemas.microsoft.com/office/drawing/2014/main" id="{03BD5A2F-3CB4-4FC1-B19E-63216D91C620}"/>
               </a:ext>
             </a:extLst>
           </p:cNvPr>
@@ -4300,7 +4301,7 @@
           <p:cNvPr id="16" name="limit-dot-2">
             <a:extLst xmlns:a="http://schemas.openxmlformats.org/drawingml/2006/main">
               <a:ext uri="{FF2B5EF4-FFF2-40B4-BE49-F238E27FC236}">
-                <a16:creationId xmlns:a16="http://schemas.microsoft.com/office/drawing/2014/main" id="{3B21C23A-E168-481A-966F-031DAA995DF4}"/>
+                <a16:creationId xmlns:a16="http://schemas.microsoft.com/office/drawing/2014/main" id="{9C708776-07DD-49AA-AE4C-2E01EB4F39B4}"/>
               </a:ext>
             </a:extLst>
           </p:cNvPr>
@@ -4333,7 +4334,7 @@
           <p:cNvPr id="17" name="limit-copy-2">
             <a:extLst xmlns:a="http://schemas.openxmlformats.org/drawingml/2006/main">
               <a:ext uri="{FF2B5EF4-FFF2-40B4-BE49-F238E27FC236}">
-                <a16:creationId xmlns:a16="http://schemas.microsoft.com/office/drawing/2014/main" id="{EC936815-BBEA-461B-A016-EE78461B8C4C}"/>
+                <a16:creationId xmlns:a16="http://schemas.microsoft.com/office/drawing/2014/main" id="{DB854338-70CC-4528-B829-E22E6A446E45}"/>
               </a:ext>
             </a:extLst>
           </p:cNvPr>
@@ -4378,7 +4379,7 @@
           <p:cNvPr id="18" name="mit-dot-2">
             <a:extLst xmlns:a="http://schemas.openxmlformats.org/drawingml/2006/main">
               <a:ext uri="{FF2B5EF4-FFF2-40B4-BE49-F238E27FC236}">
-                <a16:creationId xmlns:a16="http://schemas.microsoft.com/office/drawing/2014/main" id="{79604495-474E-4179-8EDE-3BBA8CE5E137}"/>
+                <a16:creationId xmlns:a16="http://schemas.microsoft.com/office/drawing/2014/main" id="{13C097CF-CB30-44E8-925F-2C84637293C7}"/>
               </a:ext>
             </a:extLst>
           </p:cNvPr>
@@ -4411,7 +4412,7 @@
           <p:cNvPr id="19" name="mit-copy-2">
             <a:extLst xmlns:a="http://schemas.openxmlformats.org/drawingml/2006/main">
               <a:ext uri="{FF2B5EF4-FFF2-40B4-BE49-F238E27FC236}">
-                <a16:creationId xmlns:a16="http://schemas.microsoft.com/office/drawing/2014/main" id="{0E4E0922-2343-4572-9FC9-11F7B63E88C2}"/>
+                <a16:creationId xmlns:a16="http://schemas.microsoft.com/office/drawing/2014/main" id="{F94180CC-1BF2-4449-81E4-18C301440C7C}"/>
               </a:ext>
             </a:extLst>
           </p:cNvPr>
@@ -4456,7 +4457,7 @@
           <p:cNvPr id="20" name="limit-dot-3">
             <a:extLst xmlns:a="http://schemas.openxmlformats.org/drawingml/2006/main">
               <a:ext uri="{FF2B5EF4-FFF2-40B4-BE49-F238E27FC236}">
-                <a16:creationId xmlns:a16="http://schemas.microsoft.com/office/drawing/2014/main" id="{F058B7EB-37EE-44BF-A590-1D268A52DEE2}"/>
+                <a16:creationId xmlns:a16="http://schemas.microsoft.com/office/drawing/2014/main" id="{179EF765-3F3B-4FDB-B316-44C3F3C771E5}"/>
               </a:ext>
             </a:extLst>
           </p:cNvPr>
@@ -4489,7 +4490,7 @@
           <p:cNvPr id="21" name="limit-copy-3">
             <a:extLst xmlns:a="http://schemas.openxmlformats.org/drawingml/2006/main">
               <a:ext uri="{FF2B5EF4-FFF2-40B4-BE49-F238E27FC236}">
-                <a16:creationId xmlns:a16="http://schemas.microsoft.com/office/drawing/2014/main" id="{03AC0479-EAC2-4F90-BD08-B31BBF420521}"/>
+                <a16:creationId xmlns:a16="http://schemas.microsoft.com/office/drawing/2014/main" id="{A1BA1B03-3DC4-47C5-B4C7-F8D307BBE16E}"/>
               </a:ext>
             </a:extLst>
           </p:cNvPr>
@@ -4534,7 +4535,7 @@
           <p:cNvPr id="22" name="mit-dot-3">
             <a:extLst xmlns:a="http://schemas.openxmlformats.org/drawingml/2006/main">
               <a:ext uri="{FF2B5EF4-FFF2-40B4-BE49-F238E27FC236}">
-                <a16:creationId xmlns:a16="http://schemas.microsoft.com/office/drawing/2014/main" id="{98FA0BED-1842-4B25-9AE6-B9C807A5CAC3}"/>
+                <a16:creationId xmlns:a16="http://schemas.microsoft.com/office/drawing/2014/main" id="{0D90BAD7-5FB7-43BE-96BC-75C5F70B4C4C}"/>
               </a:ext>
             </a:extLst>
           </p:cNvPr>
@@ -4567,7 +4568,7 @@
           <p:cNvPr id="23" name="mit-copy-3">
             <a:extLst xmlns:a="http://schemas.openxmlformats.org/drawingml/2006/main">
               <a:ext uri="{FF2B5EF4-FFF2-40B4-BE49-F238E27FC236}">
-                <a16:creationId xmlns:a16="http://schemas.microsoft.com/office/drawing/2014/main" id="{8DB310D9-3BC1-4794-B741-EF256C4208A8}"/>
+                <a16:creationId xmlns:a16="http://schemas.microsoft.com/office/drawing/2014/main" id="{6C69A5D9-5AA0-4AA2-ADFE-79A5E8BA0457}"/>
               </a:ext>
             </a:extLst>
           </p:cNvPr>
@@ -4612,7 +4613,7 @@
           <p:cNvPr id="24" name="not-advice">
             <a:extLst xmlns:a="http://schemas.openxmlformats.org/drawingml/2006/main">
               <a:ext uri="{FF2B5EF4-FFF2-40B4-BE49-F238E27FC236}">
-                <a16:creationId xmlns:a16="http://schemas.microsoft.com/office/drawing/2014/main" id="{E341E591-6528-4876-9BC4-9D123655F69B}"/>
+                <a16:creationId xmlns:a16="http://schemas.microsoft.com/office/drawing/2014/main" id="{4A5D1CB5-11AC-4F57-BD9D-11A701D70129}"/>
               </a:ext>
             </a:extLst>
           </p:cNvPr>
@@ -4645,7 +4646,7 @@
           <p:cNvPr id="25" name="not-advice-text">
             <a:extLst xmlns:a="http://schemas.openxmlformats.org/drawingml/2006/main">
               <a:ext uri="{FF2B5EF4-FFF2-40B4-BE49-F238E27FC236}">
-                <a16:creationId xmlns:a16="http://schemas.microsoft.com/office/drawing/2014/main" id="{6EEDBEA8-D767-498C-B514-A6548A2BC235}"/>
+                <a16:creationId xmlns:a16="http://schemas.microsoft.com/office/drawing/2014/main" id="{35EEE9E7-5204-4228-9C05-DF358CBB88F1}"/>
               </a:ext>
             </a:extLst>
           </p:cNvPr>
@@ -4688,7 +4689,7 @@
     </p:spTree>
     <p:extLst>
       <p:ext uri="{BB962C8B-B14F-4D97-AF65-F5344CB8AC3E}">
-        <p14:creationId xmlns:p14="http://schemas.microsoft.com/office/powerpoint/2010/main" val="2060607795"/>
+        <p14:creationId xmlns:p14="http://schemas.microsoft.com/office/powerpoint/2010/main" val="916866484"/>
       </p:ext>
     </p:extLst>
   </p:cSld>
@@ -4719,7 +4720,7 @@
           <p:cNvPr id="7" name="conclusion-kicker">
             <a:extLst xmlns:a="http://schemas.openxmlformats.org/drawingml/2006/main">
               <a:ext uri="{FF2B5EF4-FFF2-40B4-BE49-F238E27FC236}">
-                <a16:creationId xmlns:a16="http://schemas.microsoft.com/office/drawing/2014/main" id="{9527694B-1903-4275-A679-9A94340EB5E9}"/>
+                <a16:creationId xmlns:a16="http://schemas.microsoft.com/office/drawing/2014/main" id="{B3FD4219-6ECA-4418-A85A-E17D7721E302}"/>
               </a:ext>
             </a:extLst>
           </p:cNvPr>
@@ -4764,7 +4765,7 @@
           <p:cNvPr id="2" name="conclusion-title">
             <a:extLst xmlns:a="http://schemas.openxmlformats.org/drawingml/2006/main">
               <a:ext uri="{FF2B5EF4-FFF2-40B4-BE49-F238E27FC236}">
-                <a16:creationId xmlns:a16="http://schemas.microsoft.com/office/drawing/2014/main" id="{08F4DD74-A46E-4D43-B356-8E5EB251FE7B}"/>
+                <a16:creationId xmlns:a16="http://schemas.microsoft.com/office/drawing/2014/main" id="{F9CF28D6-D87A-4C9F-B5BD-DDA8F4678FEC}"/>
               </a:ext>
             </a:extLst>
           </p:cNvPr>
@@ -4810,7 +4811,7 @@
           <p:cNvPr id="3" name="conclusion-proof">
             <a:extLst xmlns:a="http://schemas.openxmlformats.org/drawingml/2006/main">
               <a:ext uri="{FF2B5EF4-FFF2-40B4-BE49-F238E27FC236}">
-                <a16:creationId xmlns:a16="http://schemas.microsoft.com/office/drawing/2014/main" id="{4B54F1A7-18D8-46FB-9692-7FC3D574E41A}"/>
+                <a16:creationId xmlns:a16="http://schemas.microsoft.com/office/drawing/2014/main" id="{82832F94-88CF-4501-96D0-EC101EBAC9EB}"/>
               </a:ext>
             </a:extLst>
           </p:cNvPr>
@@ -4877,7 +4878,7 @@
           <p:cNvPr id="5" name="conclusion-close">
             <a:extLst xmlns:a="http://schemas.openxmlformats.org/drawingml/2006/main">
               <a:ext uri="{FF2B5EF4-FFF2-40B4-BE49-F238E27FC236}">
-                <a16:creationId xmlns:a16="http://schemas.microsoft.com/office/drawing/2014/main" id="{CCAE4B8C-9E84-4819-A9C1-C01A18C10CF5}"/>
+                <a16:creationId xmlns:a16="http://schemas.microsoft.com/office/drawing/2014/main" id="{B4865161-FB30-4C11-85FA-A764E3EDE539}"/>
               </a:ext>
             </a:extLst>
           </p:cNvPr>
@@ -4922,7 +4923,7 @@
           <p:cNvPr id="6" name="conclusion-page">
             <a:extLst xmlns:a="http://schemas.openxmlformats.org/drawingml/2006/main">
               <a:ext uri="{FF2B5EF4-FFF2-40B4-BE49-F238E27FC236}">
-                <a16:creationId xmlns:a16="http://schemas.microsoft.com/office/drawing/2014/main" id="{96D2B463-2AAB-42AF-BE55-1AC775682BBE}"/>
+                <a16:creationId xmlns:a16="http://schemas.microsoft.com/office/drawing/2014/main" id="{35EE5F8C-A8D1-485E-B79A-C2894CA368D0}"/>
               </a:ext>
             </a:extLst>
           </p:cNvPr>
@@ -4965,7 +4966,7 @@
     </p:spTree>
     <p:extLst>
       <p:ext uri="{BB962C8B-B14F-4D97-AF65-F5344CB8AC3E}">
-        <p14:creationId xmlns:p14="http://schemas.microsoft.com/office/powerpoint/2010/main" val="1478105598"/>
+        <p14:creationId xmlns:p14="http://schemas.microsoft.com/office/powerpoint/2010/main" val="1279290700"/>
       </p:ext>
     </p:extLst>
   </p:cSld>
@@ -4996,7 +4997,7 @@
           <p:cNvPr id="13" name="title-13">
             <a:extLst xmlns:a="http://schemas.openxmlformats.org/drawingml/2006/main">
               <a:ext uri="{FF2B5EF4-FFF2-40B4-BE49-F238E27FC236}">
-                <a16:creationId xmlns:a16="http://schemas.microsoft.com/office/drawing/2014/main" id="{93696119-DDA9-4A2C-9A48-982602F660AD}"/>
+                <a16:creationId xmlns:a16="http://schemas.microsoft.com/office/drawing/2014/main" id="{BEB0394B-702D-45B8-BD53-85E26D42040D}"/>
               </a:ext>
             </a:extLst>
           </p:cNvPr>
@@ -5041,7 +5042,7 @@
           <p:cNvPr id="2" name="source-13">
             <a:extLst xmlns:a="http://schemas.openxmlformats.org/drawingml/2006/main">
               <a:ext uri="{FF2B5EF4-FFF2-40B4-BE49-F238E27FC236}">
-                <a16:creationId xmlns:a16="http://schemas.microsoft.com/office/drawing/2014/main" id="{83707F87-5B9C-4B66-9D9C-29A20FD6797D}"/>
+                <a16:creationId xmlns:a16="http://schemas.microsoft.com/office/drawing/2014/main" id="{E531939F-152B-4C54-8CCD-D775035C327D}"/>
               </a:ext>
             </a:extLst>
           </p:cNvPr>
@@ -5086,7 +5087,7 @@
           <p:cNvPr id="3" name="page-13">
             <a:extLst xmlns:a="http://schemas.openxmlformats.org/drawingml/2006/main">
               <a:ext uri="{FF2B5EF4-FFF2-40B4-BE49-F238E27FC236}">
-                <a16:creationId xmlns:a16="http://schemas.microsoft.com/office/drawing/2014/main" id="{EA57FBD8-CDCA-44DD-91FA-4E6FE52127B6}"/>
+                <a16:creationId xmlns:a16="http://schemas.microsoft.com/office/drawing/2014/main" id="{1BA36FF2-778B-40BE-9CD4-34CCEE442688}"/>
               </a:ext>
             </a:extLst>
           </p:cNvPr>
@@ -5131,7 +5132,7 @@
           <p:cNvPr id="4" name="sources-one-title">
             <a:extLst xmlns:a="http://schemas.openxmlformats.org/drawingml/2006/main">
               <a:ext uri="{FF2B5EF4-FFF2-40B4-BE49-F238E27FC236}">
-                <a16:creationId xmlns:a16="http://schemas.microsoft.com/office/drawing/2014/main" id="{9D66DAA3-8D4C-473A-A299-284DDB9309E3}"/>
+                <a16:creationId xmlns:a16="http://schemas.microsoft.com/office/drawing/2014/main" id="{9E5DD94F-3496-40CF-9132-DBFF9A919E63}"/>
               </a:ext>
             </a:extLst>
           </p:cNvPr>
@@ -5176,7 +5177,7 @@
           <p:cNvPr id="5" name="sources-one-body">
             <a:extLst xmlns:a="http://schemas.openxmlformats.org/drawingml/2006/main">
               <a:ext uri="{FF2B5EF4-FFF2-40B4-BE49-F238E27FC236}">
-                <a16:creationId xmlns:a16="http://schemas.microsoft.com/office/drawing/2014/main" id="{4C5D4375-07B4-41A0-BE93-58DA547ADD4D}"/>
+                <a16:creationId xmlns:a16="http://schemas.microsoft.com/office/drawing/2014/main" id="{2742AB32-A755-4259-A019-003B8E9C0778}"/>
               </a:ext>
             </a:extLst>
           </p:cNvPr>
@@ -5223,7 +5224,7 @@
           <p:cNvPr id="6" name="sources-two-title">
             <a:extLst xmlns:a="http://schemas.openxmlformats.org/drawingml/2006/main">
               <a:ext uri="{FF2B5EF4-FFF2-40B4-BE49-F238E27FC236}">
-                <a16:creationId xmlns:a16="http://schemas.microsoft.com/office/drawing/2014/main" id="{BD00628D-D27A-4E7B-B080-0667B2553618}"/>
+                <a16:creationId xmlns:a16="http://schemas.microsoft.com/office/drawing/2014/main" id="{55F1DBB8-28E0-4456-8774-7C628A87B1B3}"/>
               </a:ext>
             </a:extLst>
           </p:cNvPr>
@@ -5268,7 +5269,7 @@
           <p:cNvPr id="7" name="sources-two-body">
             <a:extLst xmlns:a="http://schemas.openxmlformats.org/drawingml/2006/main">
               <a:ext uri="{FF2B5EF4-FFF2-40B4-BE49-F238E27FC236}">
-                <a16:creationId xmlns:a16="http://schemas.microsoft.com/office/drawing/2014/main" id="{CE03C17D-4814-4EA0-83A5-2BF38B9AE04F}"/>
+                <a16:creationId xmlns:a16="http://schemas.microsoft.com/office/drawing/2014/main" id="{E4103BF6-AE93-4ED1-8ED4-D23B3DDCC87C}"/>
               </a:ext>
             </a:extLst>
           </p:cNvPr>
@@ -5337,7 +5338,7 @@
           <p:cNvPr id="9" name="sources-repro-title">
             <a:extLst xmlns:a="http://schemas.openxmlformats.org/drawingml/2006/main">
               <a:ext uri="{FF2B5EF4-FFF2-40B4-BE49-F238E27FC236}">
-                <a16:creationId xmlns:a16="http://schemas.microsoft.com/office/drawing/2014/main" id="{7D30E10B-C1C0-4649-823C-19DCBA43DAAB}"/>
+                <a16:creationId xmlns:a16="http://schemas.microsoft.com/office/drawing/2014/main" id="{546C87BE-C9E6-4C7F-A6FB-776C6C4DFBCB}"/>
               </a:ext>
             </a:extLst>
           </p:cNvPr>
@@ -5382,7 +5383,7 @@
           <p:cNvPr id="10" name="sources-repro-body">
             <a:extLst xmlns:a="http://schemas.openxmlformats.org/drawingml/2006/main">
               <a:ext uri="{FF2B5EF4-FFF2-40B4-BE49-F238E27FC236}">
-                <a16:creationId xmlns:a16="http://schemas.microsoft.com/office/drawing/2014/main" id="{E05FECC3-DCE5-4817-9816-D3DBE01C33A9}"/>
+                <a16:creationId xmlns:a16="http://schemas.microsoft.com/office/drawing/2014/main" id="{CEC07F85-8AA3-4BEE-B45E-ED89E3D448C9}"/>
               </a:ext>
             </a:extLst>
           </p:cNvPr>
@@ -5427,7 +5428,7 @@
           <p:cNvPr id="11" name="sources-code">
             <a:extLst xmlns:a="http://schemas.openxmlformats.org/drawingml/2006/main">
               <a:ext uri="{FF2B5EF4-FFF2-40B4-BE49-F238E27FC236}">
-                <a16:creationId xmlns:a16="http://schemas.microsoft.com/office/drawing/2014/main" id="{4E41CA60-901F-4354-BD8F-60B8F01062E8}"/>
+                <a16:creationId xmlns:a16="http://schemas.microsoft.com/office/drawing/2014/main" id="{12AD8F1C-D4D0-4E2D-84C4-DEF78205EC3B}"/>
               </a:ext>
             </a:extLst>
           </p:cNvPr>
@@ -5460,7 +5461,7 @@
           <p:cNvPr id="12" name="sources-code-text">
             <a:extLst xmlns:a="http://schemas.openxmlformats.org/drawingml/2006/main">
               <a:ext uri="{FF2B5EF4-FFF2-40B4-BE49-F238E27FC236}">
-                <a16:creationId xmlns:a16="http://schemas.microsoft.com/office/drawing/2014/main" id="{FFA51586-FF4A-4DE9-9396-42997E71607C}"/>
+                <a16:creationId xmlns:a16="http://schemas.microsoft.com/office/drawing/2014/main" id="{4BB8B597-4D8A-4FD4-B84A-0F958678BC47}"/>
               </a:ext>
             </a:extLst>
           </p:cNvPr>
@@ -5503,7 +5504,7 @@
     </p:spTree>
     <p:extLst>
       <p:ext uri="{BB962C8B-B14F-4D97-AF65-F5344CB8AC3E}">
-        <p14:creationId xmlns:p14="http://schemas.microsoft.com/office/powerpoint/2010/main" val="484726908"/>
+        <p14:creationId xmlns:p14="http://schemas.microsoft.com/office/powerpoint/2010/main" val="747513772"/>
       </p:ext>
     </p:extLst>
   </p:cSld>
@@ -5534,7 +5535,7 @@
           <p:cNvPr id="7" name="title-14">
             <a:extLst xmlns:a="http://schemas.openxmlformats.org/drawingml/2006/main">
               <a:ext uri="{FF2B5EF4-FFF2-40B4-BE49-F238E27FC236}">
-                <a16:creationId xmlns:a16="http://schemas.microsoft.com/office/drawing/2014/main" id="{70EE301D-22A7-4C0A-B85F-C536BA243E6B}"/>
+                <a16:creationId xmlns:a16="http://schemas.microsoft.com/office/drawing/2014/main" id="{A24A7D28-A9C7-4580-A865-35AD7769F51B}"/>
               </a:ext>
             </a:extLst>
           </p:cNvPr>
@@ -5579,7 +5580,7 @@
           <p:cNvPr id="2" name="source-14">
             <a:extLst xmlns:a="http://schemas.openxmlformats.org/drawingml/2006/main">
               <a:ext uri="{FF2B5EF4-FFF2-40B4-BE49-F238E27FC236}">
-                <a16:creationId xmlns:a16="http://schemas.microsoft.com/office/drawing/2014/main" id="{25828580-A52B-43D5-B1A8-F105DAD304F3}"/>
+                <a16:creationId xmlns:a16="http://schemas.microsoft.com/office/drawing/2014/main" id="{2ABF3631-6D6A-4C2A-BDFC-EE21613870B8}"/>
               </a:ext>
             </a:extLst>
           </p:cNvPr>
@@ -5624,7 +5625,7 @@
           <p:cNvPr id="3" name="page-14">
             <a:extLst xmlns:a="http://schemas.openxmlformats.org/drawingml/2006/main">
               <a:ext uri="{FF2B5EF4-FFF2-40B4-BE49-F238E27FC236}">
-                <a16:creationId xmlns:a16="http://schemas.microsoft.com/office/drawing/2014/main" id="{CA090D69-9AC9-4B96-83BD-538A6A6C8E8D}"/>
+                <a16:creationId xmlns:a16="http://schemas.microsoft.com/office/drawing/2014/main" id="{5544BD15-CFC7-4F56-8C86-9D746950845D}"/>
               </a:ext>
             </a:extLst>
           </p:cNvPr>
@@ -5669,7 +5670,7 @@
           <p:cNvPr id="4" name="method-detail-lead">
             <a:extLst xmlns:a="http://schemas.openxmlformats.org/drawingml/2006/main">
               <a:ext uri="{FF2B5EF4-FFF2-40B4-BE49-F238E27FC236}">
-                <a16:creationId xmlns:a16="http://schemas.microsoft.com/office/drawing/2014/main" id="{0494C52F-47B3-439A-B14D-D8A3A7DDC374}"/>
+                <a16:creationId xmlns:a16="http://schemas.microsoft.com/office/drawing/2014/main" id="{C92C2A12-68B5-4B1C-A5F3-99CAF265623B}"/>
               </a:ext>
             </a:extLst>
           </p:cNvPr>
@@ -6136,7 +6137,7 @@
           <p:cNvPr id="6" name="method-detail-conclusion">
             <a:extLst xmlns:a="http://schemas.openxmlformats.org/drawingml/2006/main">
               <a:ext uri="{FF2B5EF4-FFF2-40B4-BE49-F238E27FC236}">
-                <a16:creationId xmlns:a16="http://schemas.microsoft.com/office/drawing/2014/main" id="{703B4447-B87B-4B15-A02D-CF08B288DAFD}"/>
+                <a16:creationId xmlns:a16="http://schemas.microsoft.com/office/drawing/2014/main" id="{BA5E43BA-78E6-466B-A2A3-167A4ABE0E7A}"/>
               </a:ext>
             </a:extLst>
           </p:cNvPr>
@@ -6179,7 +6180,7 @@
     </p:spTree>
     <p:extLst>
       <p:ext uri="{BB962C8B-B14F-4D97-AF65-F5344CB8AC3E}">
-        <p14:creationId xmlns:p14="http://schemas.microsoft.com/office/powerpoint/2010/main" val="1885169000"/>
+        <p14:creationId xmlns:p14="http://schemas.microsoft.com/office/powerpoint/2010/main" val="632947082"/>
       </p:ext>
     </p:extLst>
   </p:cSld>
@@ -6210,7 +6211,7 @@
           <p:cNvPr id="21" name="title-2">
             <a:extLst xmlns:a="http://schemas.openxmlformats.org/drawingml/2006/main">
               <a:ext uri="{FF2B5EF4-FFF2-40B4-BE49-F238E27FC236}">
-                <a16:creationId xmlns:a16="http://schemas.microsoft.com/office/drawing/2014/main" id="{5FAA324E-0DFB-4A56-B8C6-153098CD7E03}"/>
+                <a16:creationId xmlns:a16="http://schemas.microsoft.com/office/drawing/2014/main" id="{1B6F8710-3F68-40AC-8BCB-51DD842B0CE0}"/>
               </a:ext>
             </a:extLst>
           </p:cNvPr>
@@ -6255,7 +6256,7 @@
           <p:cNvPr id="2" name="source-2">
             <a:extLst xmlns:a="http://schemas.openxmlformats.org/drawingml/2006/main">
               <a:ext uri="{FF2B5EF4-FFF2-40B4-BE49-F238E27FC236}">
-                <a16:creationId xmlns:a16="http://schemas.microsoft.com/office/drawing/2014/main" id="{3CB24587-3765-4C73-8B08-3931D6B5ECCF}"/>
+                <a16:creationId xmlns:a16="http://schemas.microsoft.com/office/drawing/2014/main" id="{7103D617-DD69-43B5-A107-D2FE77C3CBDC}"/>
               </a:ext>
             </a:extLst>
           </p:cNvPr>
@@ -6300,7 +6301,7 @@
           <p:cNvPr id="3" name="page-2">
             <a:extLst xmlns:a="http://schemas.openxmlformats.org/drawingml/2006/main">
               <a:ext uri="{FF2B5EF4-FFF2-40B4-BE49-F238E27FC236}">
-                <a16:creationId xmlns:a16="http://schemas.microsoft.com/office/drawing/2014/main" id="{28E4AC30-8487-4A7F-AAC6-A972C4C5A6C1}"/>
+                <a16:creationId xmlns:a16="http://schemas.microsoft.com/office/drawing/2014/main" id="{9F3EB397-8F4E-455E-B897-19AB0E12902E}"/>
               </a:ext>
             </a:extLst>
           </p:cNvPr>
@@ -6345,7 +6346,7 @@
           <p:cNvPr id="4" name="three-lead">
             <a:extLst xmlns:a="http://schemas.openxmlformats.org/drawingml/2006/main">
               <a:ext uri="{FF2B5EF4-FFF2-40B4-BE49-F238E27FC236}">
-                <a16:creationId xmlns:a16="http://schemas.microsoft.com/office/drawing/2014/main" id="{281C62F7-95D5-4E3C-AAFD-87DDB7AA4671}"/>
+                <a16:creationId xmlns:a16="http://schemas.microsoft.com/office/drawing/2014/main" id="{32A6914D-DC33-472D-88EB-DE8262075941}"/>
               </a:ext>
             </a:extLst>
           </p:cNvPr>
@@ -6434,7 +6435,7 @@
           <p:cNvPr id="7" name="accent-0">
             <a:extLst xmlns:a="http://schemas.openxmlformats.org/drawingml/2006/main">
               <a:ext uri="{FF2B5EF4-FFF2-40B4-BE49-F238E27FC236}">
-                <a16:creationId xmlns:a16="http://schemas.microsoft.com/office/drawing/2014/main" id="{5B8BF3E1-641B-42A5-86E5-944EC3083CF3}"/>
+                <a16:creationId xmlns:a16="http://schemas.microsoft.com/office/drawing/2014/main" id="{346E8148-991E-4783-8E74-6F064FDA14E1}"/>
               </a:ext>
             </a:extLst>
           </p:cNvPr>
@@ -6467,7 +6468,7 @@
           <p:cNvPr id="8" name="reality-label-0">
             <a:extLst xmlns:a="http://schemas.openxmlformats.org/drawingml/2006/main">
               <a:ext uri="{FF2B5EF4-FFF2-40B4-BE49-F238E27FC236}">
-                <a16:creationId xmlns:a16="http://schemas.microsoft.com/office/drawing/2014/main" id="{0AB4AD9F-1936-49CA-B4D1-31E05223F695}"/>
+                <a16:creationId xmlns:a16="http://schemas.microsoft.com/office/drawing/2014/main" id="{D36E312E-B999-4D96-8E3A-AD6D5BDBC565}"/>
               </a:ext>
             </a:extLst>
           </p:cNvPr>
@@ -6512,7 +6513,7 @@
           <p:cNvPr id="9" name="reality-stat-0">
             <a:extLst xmlns:a="http://schemas.openxmlformats.org/drawingml/2006/main">
               <a:ext uri="{FF2B5EF4-FFF2-40B4-BE49-F238E27FC236}">
-                <a16:creationId xmlns:a16="http://schemas.microsoft.com/office/drawing/2014/main" id="{836CAD72-BF5F-439A-B7D6-4A88DA63AA6E}"/>
+                <a16:creationId xmlns:a16="http://schemas.microsoft.com/office/drawing/2014/main" id="{1BDE4B0C-52C4-4BA0-98C4-24C3C83656A2}"/>
               </a:ext>
             </a:extLst>
           </p:cNvPr>
@@ -6557,7 +6558,7 @@
           <p:cNvPr id="10" name="reality-body-0">
             <a:extLst xmlns:a="http://schemas.openxmlformats.org/drawingml/2006/main">
               <a:ext uri="{FF2B5EF4-FFF2-40B4-BE49-F238E27FC236}">
-                <a16:creationId xmlns:a16="http://schemas.microsoft.com/office/drawing/2014/main" id="{648F92E6-69B2-4F9A-8D68-B547EC10462E}"/>
+                <a16:creationId xmlns:a16="http://schemas.microsoft.com/office/drawing/2014/main" id="{F183CC51-04B9-4A22-B5FD-CEDA075F6A8F}"/>
               </a:ext>
             </a:extLst>
           </p:cNvPr>
@@ -6602,7 +6603,7 @@
           <p:cNvPr id="11" name="accent-1">
             <a:extLst xmlns:a="http://schemas.openxmlformats.org/drawingml/2006/main">
               <a:ext uri="{FF2B5EF4-FFF2-40B4-BE49-F238E27FC236}">
-                <a16:creationId xmlns:a16="http://schemas.microsoft.com/office/drawing/2014/main" id="{2EC37963-11E0-45E7-8789-DF272026B615}"/>
+                <a16:creationId xmlns:a16="http://schemas.microsoft.com/office/drawing/2014/main" id="{E31BB1CA-A8B8-4211-8FE2-8B83DE60AC3C}"/>
               </a:ext>
             </a:extLst>
           </p:cNvPr>
@@ -6635,7 +6636,7 @@
           <p:cNvPr id="12" name="reality-label-1">
             <a:extLst xmlns:a="http://schemas.openxmlformats.org/drawingml/2006/main">
               <a:ext uri="{FF2B5EF4-FFF2-40B4-BE49-F238E27FC236}">
-                <a16:creationId xmlns:a16="http://schemas.microsoft.com/office/drawing/2014/main" id="{86477400-0364-418E-89DD-8357BF1B39C5}"/>
+                <a16:creationId xmlns:a16="http://schemas.microsoft.com/office/drawing/2014/main" id="{F4D5F652-DA77-4096-B344-E4F2FC8DE36A}"/>
               </a:ext>
             </a:extLst>
           </p:cNvPr>
@@ -6680,7 +6681,7 @@
           <p:cNvPr id="13" name="reality-stat-1">
             <a:extLst xmlns:a="http://schemas.openxmlformats.org/drawingml/2006/main">
               <a:ext uri="{FF2B5EF4-FFF2-40B4-BE49-F238E27FC236}">
-                <a16:creationId xmlns:a16="http://schemas.microsoft.com/office/drawing/2014/main" id="{9C31B26C-9FF1-4026-96F1-3CFA865751F5}"/>
+                <a16:creationId xmlns:a16="http://schemas.microsoft.com/office/drawing/2014/main" id="{CA20D8C4-6EF2-4085-BE2B-2CD88EB65D7B}"/>
               </a:ext>
             </a:extLst>
           </p:cNvPr>
@@ -6725,7 +6726,7 @@
           <p:cNvPr id="14" name="reality-body-1">
             <a:extLst xmlns:a="http://schemas.openxmlformats.org/drawingml/2006/main">
               <a:ext uri="{FF2B5EF4-FFF2-40B4-BE49-F238E27FC236}">
-                <a16:creationId xmlns:a16="http://schemas.microsoft.com/office/drawing/2014/main" id="{E4D71CD3-15BE-4AC7-91D7-DCF614E0EEC9}"/>
+                <a16:creationId xmlns:a16="http://schemas.microsoft.com/office/drawing/2014/main" id="{B2489FD6-FCD1-4EBC-8BE2-76C64C12ABA5}"/>
               </a:ext>
             </a:extLst>
           </p:cNvPr>
@@ -6770,7 +6771,7 @@
           <p:cNvPr id="15" name="accent-2">
             <a:extLst xmlns:a="http://schemas.openxmlformats.org/drawingml/2006/main">
               <a:ext uri="{FF2B5EF4-FFF2-40B4-BE49-F238E27FC236}">
-                <a16:creationId xmlns:a16="http://schemas.microsoft.com/office/drawing/2014/main" id="{A156479A-3D15-4E55-89DF-232C4BF7F82C}"/>
+                <a16:creationId xmlns:a16="http://schemas.microsoft.com/office/drawing/2014/main" id="{09052263-7A2C-4758-A339-D646A5635053}"/>
               </a:ext>
             </a:extLst>
           </p:cNvPr>
@@ -6803,7 +6804,7 @@
           <p:cNvPr id="16" name="reality-label-2">
             <a:extLst xmlns:a="http://schemas.openxmlformats.org/drawingml/2006/main">
               <a:ext uri="{FF2B5EF4-FFF2-40B4-BE49-F238E27FC236}">
-                <a16:creationId xmlns:a16="http://schemas.microsoft.com/office/drawing/2014/main" id="{A352DE9D-41C9-45FB-8B70-A9EA637ED705}"/>
+                <a16:creationId xmlns:a16="http://schemas.microsoft.com/office/drawing/2014/main" id="{CCF5514B-5D8A-4F81-AA4A-6F563EFDD86C}"/>
               </a:ext>
             </a:extLst>
           </p:cNvPr>
@@ -6848,7 +6849,7 @@
           <p:cNvPr id="17" name="reality-stat-2">
             <a:extLst xmlns:a="http://schemas.openxmlformats.org/drawingml/2006/main">
               <a:ext uri="{FF2B5EF4-FFF2-40B4-BE49-F238E27FC236}">
-                <a16:creationId xmlns:a16="http://schemas.microsoft.com/office/drawing/2014/main" id="{50BA2036-C596-4974-B3BB-36281496351D}"/>
+                <a16:creationId xmlns:a16="http://schemas.microsoft.com/office/drawing/2014/main" id="{F4E6999A-C800-4C17-8DC7-BF3D6F39F714}"/>
               </a:ext>
             </a:extLst>
           </p:cNvPr>
@@ -6893,7 +6894,7 @@
           <p:cNvPr id="18" name="reality-body-2">
             <a:extLst xmlns:a="http://schemas.openxmlformats.org/drawingml/2006/main">
               <a:ext uri="{FF2B5EF4-FFF2-40B4-BE49-F238E27FC236}">
-                <a16:creationId xmlns:a16="http://schemas.microsoft.com/office/drawing/2014/main" id="{6DBBC3B1-681D-4797-A242-51AB12D994B5}"/>
+                <a16:creationId xmlns:a16="http://schemas.microsoft.com/office/drawing/2014/main" id="{38734978-386F-408D-9817-68B036A72658}"/>
               </a:ext>
             </a:extLst>
           </p:cNvPr>
@@ -6938,7 +6939,7 @@
           <p:cNvPr id="19" name="hook-band">
             <a:extLst xmlns:a="http://schemas.openxmlformats.org/drawingml/2006/main">
               <a:ext uri="{FF2B5EF4-FFF2-40B4-BE49-F238E27FC236}">
-                <a16:creationId xmlns:a16="http://schemas.microsoft.com/office/drawing/2014/main" id="{BDB4896C-CB8C-4F7D-8BA5-563B66C43188}"/>
+                <a16:creationId xmlns:a16="http://schemas.microsoft.com/office/drawing/2014/main" id="{6F24746E-E42E-4AFF-B356-D063B7139DC8}"/>
               </a:ext>
             </a:extLst>
           </p:cNvPr>
@@ -6971,7 +6972,7 @@
           <p:cNvPr id="20" name="hook-copy">
             <a:extLst xmlns:a="http://schemas.openxmlformats.org/drawingml/2006/main">
               <a:ext uri="{FF2B5EF4-FFF2-40B4-BE49-F238E27FC236}">
-                <a16:creationId xmlns:a16="http://schemas.microsoft.com/office/drawing/2014/main" id="{FE4FAEEC-A005-4EE8-B3F0-5826E1519BB3}"/>
+                <a16:creationId xmlns:a16="http://schemas.microsoft.com/office/drawing/2014/main" id="{7AE18D89-1FF2-48F2-9A35-6CFCC2AEA9C7}"/>
               </a:ext>
             </a:extLst>
           </p:cNvPr>
@@ -7014,7 +7015,7 @@
     </p:spTree>
     <p:extLst>
       <p:ext uri="{BB962C8B-B14F-4D97-AF65-F5344CB8AC3E}">
-        <p14:creationId xmlns:p14="http://schemas.microsoft.com/office/powerpoint/2010/main" val="1215554510"/>
+        <p14:creationId xmlns:p14="http://schemas.microsoft.com/office/powerpoint/2010/main" val="274063515"/>
       </p:ext>
     </p:extLst>
   </p:cSld>
@@ -7045,7 +7046,7 @@
           <p:cNvPr id="6" name="title-3">
             <a:extLst xmlns:a="http://schemas.openxmlformats.org/drawingml/2006/main">
               <a:ext uri="{FF2B5EF4-FFF2-40B4-BE49-F238E27FC236}">
-                <a16:creationId xmlns:a16="http://schemas.microsoft.com/office/drawing/2014/main" id="{344A33AD-324D-4C12-95F8-5F07399A6E63}"/>
+                <a16:creationId xmlns:a16="http://schemas.microsoft.com/office/drawing/2014/main" id="{14A479A9-E339-4F53-B341-510CB91C8B11}"/>
               </a:ext>
             </a:extLst>
           </p:cNvPr>
@@ -7090,7 +7091,7 @@
           <p:cNvPr id="2" name="source-3">
             <a:extLst xmlns:a="http://schemas.openxmlformats.org/drawingml/2006/main">
               <a:ext uri="{FF2B5EF4-FFF2-40B4-BE49-F238E27FC236}">
-                <a16:creationId xmlns:a16="http://schemas.microsoft.com/office/drawing/2014/main" id="{FD35377B-B123-460E-962F-5B9DAF1ED3FB}"/>
+                <a16:creationId xmlns:a16="http://schemas.microsoft.com/office/drawing/2014/main" id="{8CB95B97-BC70-45B1-A815-0BE5F3CD399A}"/>
               </a:ext>
             </a:extLst>
           </p:cNvPr>
@@ -7135,7 +7136,7 @@
           <p:cNvPr id="3" name="page-3">
             <a:extLst xmlns:a="http://schemas.openxmlformats.org/drawingml/2006/main">
               <a:ext uri="{FF2B5EF4-FFF2-40B4-BE49-F238E27FC236}">
-                <a16:creationId xmlns:a16="http://schemas.microsoft.com/office/drawing/2014/main" id="{C4BC6862-134C-460B-9F5D-A7672C0D5EA5}"/>
+                <a16:creationId xmlns:a16="http://schemas.microsoft.com/office/drawing/2014/main" id="{401AA314-FC7F-42E9-A105-585EFDC041FE}"/>
               </a:ext>
             </a:extLst>
           </p:cNvPr>
@@ -7180,7 +7181,7 @@
           <p:cNvPr id="4" name="competitor-lead">
             <a:extLst xmlns:a="http://schemas.openxmlformats.org/drawingml/2006/main">
               <a:ext uri="{FF2B5EF4-FFF2-40B4-BE49-F238E27FC236}">
-                <a16:creationId xmlns:a16="http://schemas.microsoft.com/office/drawing/2014/main" id="{94B49650-A259-48DB-B881-89A3164CB1FF}"/>
+                <a16:creationId xmlns:a16="http://schemas.microsoft.com/office/drawing/2014/main" id="{CE49B3D4-506D-4E78-A5DB-03BB83A3024C}"/>
               </a:ext>
             </a:extLst>
           </p:cNvPr>
@@ -7921,7 +7922,7 @@
     </p:spTree>
     <p:extLst>
       <p:ext uri="{BB962C8B-B14F-4D97-AF65-F5344CB8AC3E}">
-        <p14:creationId xmlns:p14="http://schemas.microsoft.com/office/powerpoint/2010/main" val="860729038"/>
+        <p14:creationId xmlns:p14="http://schemas.microsoft.com/office/powerpoint/2010/main" val="1912436972"/>
       </p:ext>
     </p:extLst>
   </p:cSld>
@@ -7952,7 +7953,7 @@
           <p:cNvPr id="22" name="title-4">
             <a:extLst xmlns:a="http://schemas.openxmlformats.org/drawingml/2006/main">
               <a:ext uri="{FF2B5EF4-FFF2-40B4-BE49-F238E27FC236}">
-                <a16:creationId xmlns:a16="http://schemas.microsoft.com/office/drawing/2014/main" id="{479E83E3-46DB-47E6-AE19-B892EB19FA21}"/>
+                <a16:creationId xmlns:a16="http://schemas.microsoft.com/office/drawing/2014/main" id="{C3F53B92-D432-40EF-B89B-D2AF3A8F94C3}"/>
               </a:ext>
             </a:extLst>
           </p:cNvPr>
@@ -7997,7 +7998,7 @@
           <p:cNvPr id="2" name="source-4">
             <a:extLst xmlns:a="http://schemas.openxmlformats.org/drawingml/2006/main">
               <a:ext uri="{FF2B5EF4-FFF2-40B4-BE49-F238E27FC236}">
-                <a16:creationId xmlns:a16="http://schemas.microsoft.com/office/drawing/2014/main" id="{23BB8AD7-5A80-4465-B404-E09345CB96C5}"/>
+                <a16:creationId xmlns:a16="http://schemas.microsoft.com/office/drawing/2014/main" id="{C48FCE65-ABAC-445D-AC6F-61B4BAA95986}"/>
               </a:ext>
             </a:extLst>
           </p:cNvPr>
@@ -8042,7 +8043,7 @@
           <p:cNvPr id="3" name="page-4">
             <a:extLst xmlns:a="http://schemas.openxmlformats.org/drawingml/2006/main">
               <a:ext uri="{FF2B5EF4-FFF2-40B4-BE49-F238E27FC236}">
-                <a16:creationId xmlns:a16="http://schemas.microsoft.com/office/drawing/2014/main" id="{F9C5ED72-C4EE-4CAA-A9AB-55C3663D86CB}"/>
+                <a16:creationId xmlns:a16="http://schemas.microsoft.com/office/drawing/2014/main" id="{4ABA5A1E-4998-4323-9349-79DB0B657CCC}"/>
               </a:ext>
             </a:extLst>
           </p:cNvPr>
@@ -8087,7 +8088,7 @@
           <p:cNvPr id="4" name="data-lead">
             <a:extLst xmlns:a="http://schemas.openxmlformats.org/drawingml/2006/main">
               <a:ext uri="{FF2B5EF4-FFF2-40B4-BE49-F238E27FC236}">
-                <a16:creationId xmlns:a16="http://schemas.microsoft.com/office/drawing/2014/main" id="{F5B55161-7B4F-45A2-BAD8-A4B961CA2E25}"/>
+                <a16:creationId xmlns:a16="http://schemas.microsoft.com/office/drawing/2014/main" id="{54D635F0-AE29-424D-B9E8-D49E32DA603D}"/>
               </a:ext>
             </a:extLst>
           </p:cNvPr>
@@ -8132,7 +8133,7 @@
           <p:cNvPr id="5" name="data-panel-0">
             <a:extLst xmlns:a="http://schemas.openxmlformats.org/drawingml/2006/main">
               <a:ext uri="{FF2B5EF4-FFF2-40B4-BE49-F238E27FC236}">
-                <a16:creationId xmlns:a16="http://schemas.microsoft.com/office/drawing/2014/main" id="{43F8DFC6-D341-44CA-A385-9891837FBFF2}"/>
+                <a16:creationId xmlns:a16="http://schemas.microsoft.com/office/drawing/2014/main" id="{AE5D5362-4FE2-4D35-845C-C5641617E5EC}"/>
               </a:ext>
             </a:extLst>
           </p:cNvPr>
@@ -8165,7 +8166,7 @@
           <p:cNvPr id="6" name="data-stat-0">
             <a:extLst xmlns:a="http://schemas.openxmlformats.org/drawingml/2006/main">
               <a:ext uri="{FF2B5EF4-FFF2-40B4-BE49-F238E27FC236}">
-                <a16:creationId xmlns:a16="http://schemas.microsoft.com/office/drawing/2014/main" id="{885472D8-CE89-4105-A871-5BC565561124}"/>
+                <a16:creationId xmlns:a16="http://schemas.microsoft.com/office/drawing/2014/main" id="{B37C9F24-9DF0-45CA-8893-3C57A182AE83}"/>
               </a:ext>
             </a:extLst>
           </p:cNvPr>
@@ -8210,7 +8211,7 @@
           <p:cNvPr id="7" name="data-label-0">
             <a:extLst xmlns:a="http://schemas.openxmlformats.org/drawingml/2006/main">
               <a:ext uri="{FF2B5EF4-FFF2-40B4-BE49-F238E27FC236}">
-                <a16:creationId xmlns:a16="http://schemas.microsoft.com/office/drawing/2014/main" id="{4FACC127-15CB-40D4-BEA2-DD2932FFBD86}"/>
+                <a16:creationId xmlns:a16="http://schemas.microsoft.com/office/drawing/2014/main" id="{66397C5D-C01C-41DC-A0DD-F30490CFD433}"/>
               </a:ext>
             </a:extLst>
           </p:cNvPr>
@@ -8255,7 +8256,7 @@
           <p:cNvPr id="8" name="data-detail-0">
             <a:extLst xmlns:a="http://schemas.openxmlformats.org/drawingml/2006/main">
               <a:ext uri="{FF2B5EF4-FFF2-40B4-BE49-F238E27FC236}">
-                <a16:creationId xmlns:a16="http://schemas.microsoft.com/office/drawing/2014/main" id="{E71A81B2-3B44-4978-ACD3-F30C10D25443}"/>
+                <a16:creationId xmlns:a16="http://schemas.microsoft.com/office/drawing/2014/main" id="{80A3FADD-115F-4BFA-B7D5-249EEAB06B62}"/>
               </a:ext>
             </a:extLst>
           </p:cNvPr>
@@ -8300,7 +8301,7 @@
           <p:cNvPr id="9" name="data-panel-1">
             <a:extLst xmlns:a="http://schemas.openxmlformats.org/drawingml/2006/main">
               <a:ext uri="{FF2B5EF4-FFF2-40B4-BE49-F238E27FC236}">
-                <a16:creationId xmlns:a16="http://schemas.microsoft.com/office/drawing/2014/main" id="{E56B163E-97E6-4FA2-993B-B9C56114F0AD}"/>
+                <a16:creationId xmlns:a16="http://schemas.microsoft.com/office/drawing/2014/main" id="{552FBC59-4CE0-4F70-8BBD-002E5766D7F6}"/>
               </a:ext>
             </a:extLst>
           </p:cNvPr>
@@ -8333,7 +8334,7 @@
           <p:cNvPr id="10" name="data-stat-1">
             <a:extLst xmlns:a="http://schemas.openxmlformats.org/drawingml/2006/main">
               <a:ext uri="{FF2B5EF4-FFF2-40B4-BE49-F238E27FC236}">
-                <a16:creationId xmlns:a16="http://schemas.microsoft.com/office/drawing/2014/main" id="{F8B0A15A-AC10-4328-934C-7CDA05340308}"/>
+                <a16:creationId xmlns:a16="http://schemas.microsoft.com/office/drawing/2014/main" id="{638B2965-528B-4F20-9E2F-23C32D7BBD37}"/>
               </a:ext>
             </a:extLst>
           </p:cNvPr>
@@ -8378,7 +8379,7 @@
           <p:cNvPr id="11" name="data-label-1">
             <a:extLst xmlns:a="http://schemas.openxmlformats.org/drawingml/2006/main">
               <a:ext uri="{FF2B5EF4-FFF2-40B4-BE49-F238E27FC236}">
-                <a16:creationId xmlns:a16="http://schemas.microsoft.com/office/drawing/2014/main" id="{547FC88A-99B1-49B4-9986-62DAAC8EEAC0}"/>
+                <a16:creationId xmlns:a16="http://schemas.microsoft.com/office/drawing/2014/main" id="{0E8768A3-3194-46A0-BB56-D876BFFD5F82}"/>
               </a:ext>
             </a:extLst>
           </p:cNvPr>
@@ -8423,7 +8424,7 @@
           <p:cNvPr id="12" name="data-detail-1">
             <a:extLst xmlns:a="http://schemas.openxmlformats.org/drawingml/2006/main">
               <a:ext uri="{FF2B5EF4-FFF2-40B4-BE49-F238E27FC236}">
-                <a16:creationId xmlns:a16="http://schemas.microsoft.com/office/drawing/2014/main" id="{0ABC5800-94B7-460D-A359-156D9A60933F}"/>
+                <a16:creationId xmlns:a16="http://schemas.microsoft.com/office/drawing/2014/main" id="{A70EE766-8D29-4323-856A-CC79144FAA9F}"/>
               </a:ext>
             </a:extLst>
           </p:cNvPr>
@@ -8468,7 +8469,7 @@
           <p:cNvPr id="13" name="data-panel-2">
             <a:extLst xmlns:a="http://schemas.openxmlformats.org/drawingml/2006/main">
               <a:ext uri="{FF2B5EF4-FFF2-40B4-BE49-F238E27FC236}">
-                <a16:creationId xmlns:a16="http://schemas.microsoft.com/office/drawing/2014/main" id="{70EB243C-7509-43F7-8EB9-B275A0D63D84}"/>
+                <a16:creationId xmlns:a16="http://schemas.microsoft.com/office/drawing/2014/main" id="{D29E0ED4-8793-4D8B-A8DD-EF6230C1C947}"/>
               </a:ext>
             </a:extLst>
           </p:cNvPr>
@@ -8501,7 +8502,7 @@
           <p:cNvPr id="14" name="data-stat-2">
             <a:extLst xmlns:a="http://schemas.openxmlformats.org/drawingml/2006/main">
               <a:ext uri="{FF2B5EF4-FFF2-40B4-BE49-F238E27FC236}">
-                <a16:creationId xmlns:a16="http://schemas.microsoft.com/office/drawing/2014/main" id="{85DB4DD1-03DC-4C08-9114-94DE0C0B437F}"/>
+                <a16:creationId xmlns:a16="http://schemas.microsoft.com/office/drawing/2014/main" id="{5172CC5D-18FD-4236-9751-88871ACD6DED}"/>
               </a:ext>
             </a:extLst>
           </p:cNvPr>
@@ -8546,7 +8547,7 @@
           <p:cNvPr id="15" name="data-label-2">
             <a:extLst xmlns:a="http://schemas.openxmlformats.org/drawingml/2006/main">
               <a:ext uri="{FF2B5EF4-FFF2-40B4-BE49-F238E27FC236}">
-                <a16:creationId xmlns:a16="http://schemas.microsoft.com/office/drawing/2014/main" id="{E7698AAA-5C32-418E-BDCD-4ACE967B07DC}"/>
+                <a16:creationId xmlns:a16="http://schemas.microsoft.com/office/drawing/2014/main" id="{7060F282-0511-44C7-A58C-B31E0DF3AD89}"/>
               </a:ext>
             </a:extLst>
           </p:cNvPr>
@@ -8591,7 +8592,7 @@
           <p:cNvPr id="16" name="data-detail-2">
             <a:extLst xmlns:a="http://schemas.openxmlformats.org/drawingml/2006/main">
               <a:ext uri="{FF2B5EF4-FFF2-40B4-BE49-F238E27FC236}">
-                <a16:creationId xmlns:a16="http://schemas.microsoft.com/office/drawing/2014/main" id="{9F8850F0-C8EB-43FA-B23C-0A3047459A7C}"/>
+                <a16:creationId xmlns:a16="http://schemas.microsoft.com/office/drawing/2014/main" id="{0C49A8FD-D319-4C20-9B0E-3C03220DEA00}"/>
               </a:ext>
             </a:extLst>
           </p:cNvPr>
@@ -8658,7 +8659,7 @@
           <p:cNvPr id="18" name="prov-1">
             <a:extLst xmlns:a="http://schemas.openxmlformats.org/drawingml/2006/main">
               <a:ext uri="{FF2B5EF4-FFF2-40B4-BE49-F238E27FC236}">
-                <a16:creationId xmlns:a16="http://schemas.microsoft.com/office/drawing/2014/main" id="{1B5DF4B0-D18B-4788-A0CD-41C5EAF143F3}"/>
+                <a16:creationId xmlns:a16="http://schemas.microsoft.com/office/drawing/2014/main" id="{479576FE-C323-40AA-B4E1-3BA8CC75717B}"/>
               </a:ext>
             </a:extLst>
           </p:cNvPr>
@@ -8703,7 +8704,7 @@
           <p:cNvPr id="19" name="prov-2">
             <a:extLst xmlns:a="http://schemas.openxmlformats.org/drawingml/2006/main">
               <a:ext uri="{FF2B5EF4-FFF2-40B4-BE49-F238E27FC236}">
-                <a16:creationId xmlns:a16="http://schemas.microsoft.com/office/drawing/2014/main" id="{69671826-0EB7-49E8-883B-491173657F74}"/>
+                <a16:creationId xmlns:a16="http://schemas.microsoft.com/office/drawing/2014/main" id="{EDBD8DAC-0EC1-41E7-8589-4155E2449FD1}"/>
               </a:ext>
             </a:extLst>
           </p:cNvPr>
@@ -8748,7 +8749,7 @@
           <p:cNvPr id="20" name="prov-3">
             <a:extLst xmlns:a="http://schemas.openxmlformats.org/drawingml/2006/main">
               <a:ext uri="{FF2B5EF4-FFF2-40B4-BE49-F238E27FC236}">
-                <a16:creationId xmlns:a16="http://schemas.microsoft.com/office/drawing/2014/main" id="{AAC86265-B275-4BA5-ACEF-5D2F7762329B}"/>
+                <a16:creationId xmlns:a16="http://schemas.microsoft.com/office/drawing/2014/main" id="{5DA8B677-BDE3-439C-AFD7-873E239E5276}"/>
               </a:ext>
             </a:extLst>
           </p:cNvPr>
@@ -8793,7 +8794,7 @@
           <p:cNvPr id="21" name="prov-4">
             <a:extLst xmlns:a="http://schemas.openxmlformats.org/drawingml/2006/main">
               <a:ext uri="{FF2B5EF4-FFF2-40B4-BE49-F238E27FC236}">
-                <a16:creationId xmlns:a16="http://schemas.microsoft.com/office/drawing/2014/main" id="{C7204973-CECE-4CF0-A2D3-EAF337FAC7D4}"/>
+                <a16:creationId xmlns:a16="http://schemas.microsoft.com/office/drawing/2014/main" id="{42FF99D7-CB7B-4567-A5BC-F642039D1087}"/>
               </a:ext>
             </a:extLst>
           </p:cNvPr>
@@ -8836,7 +8837,7 @@
     </p:spTree>
     <p:extLst>
       <p:ext uri="{BB962C8B-B14F-4D97-AF65-F5344CB8AC3E}">
-        <p14:creationId xmlns:p14="http://schemas.microsoft.com/office/powerpoint/2010/main" val="1584701513"/>
+        <p14:creationId xmlns:p14="http://schemas.microsoft.com/office/powerpoint/2010/main" val="2141241915"/>
       </p:ext>
     </p:extLst>
   </p:cSld>
@@ -8867,7 +8868,7 @@
           <p:cNvPr id="36" name="title-5">
             <a:extLst xmlns:a="http://schemas.openxmlformats.org/drawingml/2006/main">
               <a:ext uri="{FF2B5EF4-FFF2-40B4-BE49-F238E27FC236}">
-                <a16:creationId xmlns:a16="http://schemas.microsoft.com/office/drawing/2014/main" id="{F31215A4-CE5D-4213-9F95-3C35F1DC570A}"/>
+                <a16:creationId xmlns:a16="http://schemas.microsoft.com/office/drawing/2014/main" id="{3C3A82A8-CD44-4BBF-A597-A7CE1260A8AE}"/>
               </a:ext>
             </a:extLst>
           </p:cNvPr>
@@ -8912,7 +8913,7 @@
           <p:cNvPr id="2" name="source-5">
             <a:extLst xmlns:a="http://schemas.openxmlformats.org/drawingml/2006/main">
               <a:ext uri="{FF2B5EF4-FFF2-40B4-BE49-F238E27FC236}">
-                <a16:creationId xmlns:a16="http://schemas.microsoft.com/office/drawing/2014/main" id="{87591DCB-7CEA-4DB3-888A-C76DC9F4D8A7}"/>
+                <a16:creationId xmlns:a16="http://schemas.microsoft.com/office/drawing/2014/main" id="{BD87311A-B539-4D40-963B-9440F4A42EC5}"/>
               </a:ext>
             </a:extLst>
           </p:cNvPr>
@@ -8957,7 +8958,7 @@
           <p:cNvPr id="3" name="page-5">
             <a:extLst xmlns:a="http://schemas.openxmlformats.org/drawingml/2006/main">
               <a:ext uri="{FF2B5EF4-FFF2-40B4-BE49-F238E27FC236}">
-                <a16:creationId xmlns:a16="http://schemas.microsoft.com/office/drawing/2014/main" id="{E33FCFC7-5863-42C5-B894-ED86D5F9FC6C}"/>
+                <a16:creationId xmlns:a16="http://schemas.microsoft.com/office/drawing/2014/main" id="{776A9E0F-AF75-4B0E-BE4C-85191657E5D4}"/>
               </a:ext>
             </a:extLst>
           </p:cNvPr>
@@ -9002,7 +9003,7 @@
           <p:cNvPr id="4" name="qua-lead">
             <a:extLst xmlns:a="http://schemas.openxmlformats.org/drawingml/2006/main">
               <a:ext uri="{FF2B5EF4-FFF2-40B4-BE49-F238E27FC236}">
-                <a16:creationId xmlns:a16="http://schemas.microsoft.com/office/drawing/2014/main" id="{8809B4C2-632F-4C95-99E8-2A1F650F2DAC}"/>
+                <a16:creationId xmlns:a16="http://schemas.microsoft.com/office/drawing/2014/main" id="{3B9EFDB8-8DCA-426F-9DDA-2A9C9B21665F}"/>
               </a:ext>
             </a:extLst>
           </p:cNvPr>
@@ -9069,7 +9070,7 @@
           <p:cNvPr id="6" name="qua-node-0">
             <a:extLst xmlns:a="http://schemas.openxmlformats.org/drawingml/2006/main">
               <a:ext uri="{FF2B5EF4-FFF2-40B4-BE49-F238E27FC236}">
-                <a16:creationId xmlns:a16="http://schemas.microsoft.com/office/drawing/2014/main" id="{A6B791C4-9845-4290-8ACF-EF22879C5894}"/>
+                <a16:creationId xmlns:a16="http://schemas.microsoft.com/office/drawing/2014/main" id="{6959C6C8-D65C-4BE4-A5A3-4E0B7DEBBEA2}"/>
               </a:ext>
             </a:extLst>
           </p:cNvPr>
@@ -9102,7 +9103,7 @@
           <p:cNvPr id="7" name="qua-code-0">
             <a:extLst xmlns:a="http://schemas.openxmlformats.org/drawingml/2006/main">
               <a:ext uri="{FF2B5EF4-FFF2-40B4-BE49-F238E27FC236}">
-                <a16:creationId xmlns:a16="http://schemas.microsoft.com/office/drawing/2014/main" id="{7C26EFA0-BDA3-43AA-81D7-01B95D598D34}"/>
+                <a16:creationId xmlns:a16="http://schemas.microsoft.com/office/drawing/2014/main" id="{39B2D777-AF0D-4E47-92DA-F41E4B5F88F6}"/>
               </a:ext>
             </a:extLst>
           </p:cNvPr>
@@ -9147,7 +9148,7 @@
           <p:cNvPr id="8" name="qua-title-0">
             <a:extLst xmlns:a="http://schemas.openxmlformats.org/drawingml/2006/main">
               <a:ext uri="{FF2B5EF4-FFF2-40B4-BE49-F238E27FC236}">
-                <a16:creationId xmlns:a16="http://schemas.microsoft.com/office/drawing/2014/main" id="{4E37A3DC-17D3-4341-9FFE-906D0307D03A}"/>
+                <a16:creationId xmlns:a16="http://schemas.microsoft.com/office/drawing/2014/main" id="{406C2ECE-8511-4B7C-8FE1-FF65957719F6}"/>
               </a:ext>
             </a:extLst>
           </p:cNvPr>
@@ -9192,7 +9193,7 @@
           <p:cNvPr id="9" name="qua-body-0">
             <a:extLst xmlns:a="http://schemas.openxmlformats.org/drawingml/2006/main">
               <a:ext uri="{FF2B5EF4-FFF2-40B4-BE49-F238E27FC236}">
-                <a16:creationId xmlns:a16="http://schemas.microsoft.com/office/drawing/2014/main" id="{8C924F8E-A376-410F-BF0A-BFB591A787EF}"/>
+                <a16:creationId xmlns:a16="http://schemas.microsoft.com/office/drawing/2014/main" id="{8B072CF6-10A0-42AA-B9B5-921E56AE8925}"/>
               </a:ext>
             </a:extLst>
           </p:cNvPr>
@@ -9238,7 +9239,7 @@
           <p:cNvPr id="10" name="qua-node-1">
             <a:extLst xmlns:a="http://schemas.openxmlformats.org/drawingml/2006/main">
               <a:ext uri="{FF2B5EF4-FFF2-40B4-BE49-F238E27FC236}">
-                <a16:creationId xmlns:a16="http://schemas.microsoft.com/office/drawing/2014/main" id="{808437AE-DA35-45CF-AF1E-CB15CD23CC1B}"/>
+                <a16:creationId xmlns:a16="http://schemas.microsoft.com/office/drawing/2014/main" id="{E8AF20C0-81C2-495A-B4EE-A09A7257885F}"/>
               </a:ext>
             </a:extLst>
           </p:cNvPr>
@@ -9271,7 +9272,7 @@
           <p:cNvPr id="11" name="qua-code-1">
             <a:extLst xmlns:a="http://schemas.openxmlformats.org/drawingml/2006/main">
               <a:ext uri="{FF2B5EF4-FFF2-40B4-BE49-F238E27FC236}">
-                <a16:creationId xmlns:a16="http://schemas.microsoft.com/office/drawing/2014/main" id="{25213DBE-1ED6-49AA-B49D-35D5AE793405}"/>
+                <a16:creationId xmlns:a16="http://schemas.microsoft.com/office/drawing/2014/main" id="{4BB87973-4823-4762-AEA8-11696DAF95B7}"/>
               </a:ext>
             </a:extLst>
           </p:cNvPr>
@@ -9316,7 +9317,7 @@
           <p:cNvPr id="12" name="qua-title-1">
             <a:extLst xmlns:a="http://schemas.openxmlformats.org/drawingml/2006/main">
               <a:ext uri="{FF2B5EF4-FFF2-40B4-BE49-F238E27FC236}">
-                <a16:creationId xmlns:a16="http://schemas.microsoft.com/office/drawing/2014/main" id="{6B78B685-2F54-41B1-AD52-EB07E007CCBB}"/>
+                <a16:creationId xmlns:a16="http://schemas.microsoft.com/office/drawing/2014/main" id="{B7631F02-E2B3-41D6-B5A7-C4201F8DDA65}"/>
               </a:ext>
             </a:extLst>
           </p:cNvPr>
@@ -9361,7 +9362,7 @@
           <p:cNvPr id="13" name="qua-body-1">
             <a:extLst xmlns:a="http://schemas.openxmlformats.org/drawingml/2006/main">
               <a:ext uri="{FF2B5EF4-FFF2-40B4-BE49-F238E27FC236}">
-                <a16:creationId xmlns:a16="http://schemas.microsoft.com/office/drawing/2014/main" id="{5EC54B92-8AAA-42C4-8286-6C3225F901E3}"/>
+                <a16:creationId xmlns:a16="http://schemas.microsoft.com/office/drawing/2014/main" id="{07359966-173F-46DA-BE5D-350AFF5D3F78}"/>
               </a:ext>
             </a:extLst>
           </p:cNvPr>
@@ -9407,7 +9408,7 @@
           <p:cNvPr id="14" name="qua-node-2">
             <a:extLst xmlns:a="http://schemas.openxmlformats.org/drawingml/2006/main">
               <a:ext uri="{FF2B5EF4-FFF2-40B4-BE49-F238E27FC236}">
-                <a16:creationId xmlns:a16="http://schemas.microsoft.com/office/drawing/2014/main" id="{201EDF1B-2880-4CEE-95FC-BEA86D9AC1E3}"/>
+                <a16:creationId xmlns:a16="http://schemas.microsoft.com/office/drawing/2014/main" id="{25C4924A-A74B-4F17-B9C7-9D912FBF5A75}"/>
               </a:ext>
             </a:extLst>
           </p:cNvPr>
@@ -9440,7 +9441,7 @@
           <p:cNvPr id="15" name="qua-code-2">
             <a:extLst xmlns:a="http://schemas.openxmlformats.org/drawingml/2006/main">
               <a:ext uri="{FF2B5EF4-FFF2-40B4-BE49-F238E27FC236}">
-                <a16:creationId xmlns:a16="http://schemas.microsoft.com/office/drawing/2014/main" id="{F72D5A98-7002-45F6-84BF-3F7975C1101D}"/>
+                <a16:creationId xmlns:a16="http://schemas.microsoft.com/office/drawing/2014/main" id="{4CE57165-33A9-4481-A40D-E81B90B3A800}"/>
               </a:ext>
             </a:extLst>
           </p:cNvPr>
@@ -9485,7 +9486,7 @@
           <p:cNvPr id="16" name="qua-title-2">
             <a:extLst xmlns:a="http://schemas.openxmlformats.org/drawingml/2006/main">
               <a:ext uri="{FF2B5EF4-FFF2-40B4-BE49-F238E27FC236}">
-                <a16:creationId xmlns:a16="http://schemas.microsoft.com/office/drawing/2014/main" id="{1C6CCCF7-D0B3-4299-87D2-952D6ED50BE8}"/>
+                <a16:creationId xmlns:a16="http://schemas.microsoft.com/office/drawing/2014/main" id="{71F257DF-80AD-47C6-ACFD-8746A863D0A3}"/>
               </a:ext>
             </a:extLst>
           </p:cNvPr>
@@ -9530,7 +9531,7 @@
           <p:cNvPr id="17" name="qua-body-2">
             <a:extLst xmlns:a="http://schemas.openxmlformats.org/drawingml/2006/main">
               <a:ext uri="{FF2B5EF4-FFF2-40B4-BE49-F238E27FC236}">
-                <a16:creationId xmlns:a16="http://schemas.microsoft.com/office/drawing/2014/main" id="{F1418D42-A8AB-4E2F-8DB1-F15D5A23FC06}"/>
+                <a16:creationId xmlns:a16="http://schemas.microsoft.com/office/drawing/2014/main" id="{34A8FE05-3F05-4ACD-B83A-59B7ABB11AE7}"/>
               </a:ext>
             </a:extLst>
           </p:cNvPr>
@@ -9576,7 +9577,7 @@
           <p:cNvPr id="18" name="qua-node-3">
             <a:extLst xmlns:a="http://schemas.openxmlformats.org/drawingml/2006/main">
               <a:ext uri="{FF2B5EF4-FFF2-40B4-BE49-F238E27FC236}">
-                <a16:creationId xmlns:a16="http://schemas.microsoft.com/office/drawing/2014/main" id="{196F1E35-22B0-4895-8D96-EE699AD037FB}"/>
+                <a16:creationId xmlns:a16="http://schemas.microsoft.com/office/drawing/2014/main" id="{AEB46F4A-7D2A-46DF-B5BF-88952FA96863}"/>
               </a:ext>
             </a:extLst>
           </p:cNvPr>
@@ -9609,7 +9610,7 @@
           <p:cNvPr id="19" name="qua-code-3">
             <a:extLst xmlns:a="http://schemas.openxmlformats.org/drawingml/2006/main">
               <a:ext uri="{FF2B5EF4-FFF2-40B4-BE49-F238E27FC236}">
-                <a16:creationId xmlns:a16="http://schemas.microsoft.com/office/drawing/2014/main" id="{045A54CD-0B27-4DA5-BE39-50E0DBDDAA3C}"/>
+                <a16:creationId xmlns:a16="http://schemas.microsoft.com/office/drawing/2014/main" id="{0923F28E-B60A-4864-B25B-CA640F539BAA}"/>
               </a:ext>
             </a:extLst>
           </p:cNvPr>
@@ -9654,7 +9655,7 @@
           <p:cNvPr id="20" name="qua-title-3">
             <a:extLst xmlns:a="http://schemas.openxmlformats.org/drawingml/2006/main">
               <a:ext uri="{FF2B5EF4-FFF2-40B4-BE49-F238E27FC236}">
-                <a16:creationId xmlns:a16="http://schemas.microsoft.com/office/drawing/2014/main" id="{0D1D3419-BF59-428C-89A1-F9CF4A1080F9}"/>
+                <a16:creationId xmlns:a16="http://schemas.microsoft.com/office/drawing/2014/main" id="{1F580B97-71B5-4CAF-8648-CE828C16FB46}"/>
               </a:ext>
             </a:extLst>
           </p:cNvPr>
@@ -9699,7 +9700,7 @@
           <p:cNvPr id="21" name="qua-body-3">
             <a:extLst xmlns:a="http://schemas.openxmlformats.org/drawingml/2006/main">
               <a:ext uri="{FF2B5EF4-FFF2-40B4-BE49-F238E27FC236}">
-                <a16:creationId xmlns:a16="http://schemas.microsoft.com/office/drawing/2014/main" id="{D9760C0A-FFCA-4F96-B62B-E98234AF114C}"/>
+                <a16:creationId xmlns:a16="http://schemas.microsoft.com/office/drawing/2014/main" id="{049E6160-44CD-4792-8BDA-AAFEB20EAE4A}"/>
               </a:ext>
             </a:extLst>
           </p:cNvPr>
@@ -9745,7 +9746,7 @@
           <p:cNvPr id="22" name="qua-node-4">
             <a:extLst xmlns:a="http://schemas.openxmlformats.org/drawingml/2006/main">
               <a:ext uri="{FF2B5EF4-FFF2-40B4-BE49-F238E27FC236}">
-                <a16:creationId xmlns:a16="http://schemas.microsoft.com/office/drawing/2014/main" id="{B2E0407D-9BA0-4FAB-94CD-53CCE42D00D1}"/>
+                <a16:creationId xmlns:a16="http://schemas.microsoft.com/office/drawing/2014/main" id="{E5E4E6A3-2DEF-457E-9C34-53A675049F0E}"/>
               </a:ext>
             </a:extLst>
           </p:cNvPr>
@@ -9778,7 +9779,7 @@
           <p:cNvPr id="23" name="qua-code-4">
             <a:extLst xmlns:a="http://schemas.openxmlformats.org/drawingml/2006/main">
               <a:ext uri="{FF2B5EF4-FFF2-40B4-BE49-F238E27FC236}">
-                <a16:creationId xmlns:a16="http://schemas.microsoft.com/office/drawing/2014/main" id="{7B1A4B9A-CC75-4B22-9F00-D01465356853}"/>
+                <a16:creationId xmlns:a16="http://schemas.microsoft.com/office/drawing/2014/main" id="{EE9C3232-7395-43B5-8CCC-6032AA6A7652}"/>
               </a:ext>
             </a:extLst>
           </p:cNvPr>
@@ -9823,7 +9824,7 @@
           <p:cNvPr id="24" name="qua-title-4">
             <a:extLst xmlns:a="http://schemas.openxmlformats.org/drawingml/2006/main">
               <a:ext uri="{FF2B5EF4-FFF2-40B4-BE49-F238E27FC236}">
-                <a16:creationId xmlns:a16="http://schemas.microsoft.com/office/drawing/2014/main" id="{59D1F001-D476-4126-9BD5-E439B52044AE}"/>
+                <a16:creationId xmlns:a16="http://schemas.microsoft.com/office/drawing/2014/main" id="{8F76B851-D0EB-41FD-8056-9D17E3B4D55B}"/>
               </a:ext>
             </a:extLst>
           </p:cNvPr>
@@ -9868,7 +9869,7 @@
           <p:cNvPr id="25" name="qua-body-4">
             <a:extLst xmlns:a="http://schemas.openxmlformats.org/drawingml/2006/main">
               <a:ext uri="{FF2B5EF4-FFF2-40B4-BE49-F238E27FC236}">
-                <a16:creationId xmlns:a16="http://schemas.microsoft.com/office/drawing/2014/main" id="{3AD0DC6F-2EA8-49B9-A369-2B1EF9DC9993}"/>
+                <a16:creationId xmlns:a16="http://schemas.microsoft.com/office/drawing/2014/main" id="{6CFBC138-8353-4339-BB9A-CDE3EF1BC674}"/>
               </a:ext>
             </a:extLst>
           </p:cNvPr>
@@ -9914,7 +9915,7 @@
           <p:cNvPr id="26" name="qua-node-5">
             <a:extLst xmlns:a="http://schemas.openxmlformats.org/drawingml/2006/main">
               <a:ext uri="{FF2B5EF4-FFF2-40B4-BE49-F238E27FC236}">
-                <a16:creationId xmlns:a16="http://schemas.microsoft.com/office/drawing/2014/main" id="{C90F6A88-740A-4BA2-AFBA-EA96DC3A949F}"/>
+                <a16:creationId xmlns:a16="http://schemas.microsoft.com/office/drawing/2014/main" id="{20A67A14-0B06-45F0-AB16-55E6844F9110}"/>
               </a:ext>
             </a:extLst>
           </p:cNvPr>
@@ -9947,7 +9948,7 @@
           <p:cNvPr id="27" name="qua-code-5">
             <a:extLst xmlns:a="http://schemas.openxmlformats.org/drawingml/2006/main">
               <a:ext uri="{FF2B5EF4-FFF2-40B4-BE49-F238E27FC236}">
-                <a16:creationId xmlns:a16="http://schemas.microsoft.com/office/drawing/2014/main" id="{99509251-8305-479A-A33D-43955CB263FC}"/>
+                <a16:creationId xmlns:a16="http://schemas.microsoft.com/office/drawing/2014/main" id="{672BF717-7EA4-40BE-9FB2-047414F7EB0E}"/>
               </a:ext>
             </a:extLst>
           </p:cNvPr>
@@ -9992,7 +9993,7 @@
           <p:cNvPr id="28" name="qua-title-5">
             <a:extLst xmlns:a="http://schemas.openxmlformats.org/drawingml/2006/main">
               <a:ext uri="{FF2B5EF4-FFF2-40B4-BE49-F238E27FC236}">
-                <a16:creationId xmlns:a16="http://schemas.microsoft.com/office/drawing/2014/main" id="{E47FA6E2-E90F-408A-9575-BCF318DF8E9F}"/>
+                <a16:creationId xmlns:a16="http://schemas.microsoft.com/office/drawing/2014/main" id="{E61D3E07-8A1E-42B9-A1D9-A8B2709B445E}"/>
               </a:ext>
             </a:extLst>
           </p:cNvPr>
@@ -10037,7 +10038,7 @@
           <p:cNvPr id="29" name="qua-body-5">
             <a:extLst xmlns:a="http://schemas.openxmlformats.org/drawingml/2006/main">
               <a:ext uri="{FF2B5EF4-FFF2-40B4-BE49-F238E27FC236}">
-                <a16:creationId xmlns:a16="http://schemas.microsoft.com/office/drawing/2014/main" id="{49677FCC-B148-40BE-9C91-801485471E85}"/>
+                <a16:creationId xmlns:a16="http://schemas.microsoft.com/office/drawing/2014/main" id="{9C63FF74-B4EC-4099-AFD5-DA7FD34ACBBB}"/>
               </a:ext>
             </a:extLst>
           </p:cNvPr>
@@ -10083,7 +10084,7 @@
           <p:cNvPr id="30" name="qua-node-6">
             <a:extLst xmlns:a="http://schemas.openxmlformats.org/drawingml/2006/main">
               <a:ext uri="{FF2B5EF4-FFF2-40B4-BE49-F238E27FC236}">
-                <a16:creationId xmlns:a16="http://schemas.microsoft.com/office/drawing/2014/main" id="{0305275A-F453-476A-9105-588555D67000}"/>
+                <a16:creationId xmlns:a16="http://schemas.microsoft.com/office/drawing/2014/main" id="{8ADBCA57-B2B1-43E2-9DAB-DE91710F3258}"/>
               </a:ext>
             </a:extLst>
           </p:cNvPr>
@@ -10116,7 +10117,7 @@
           <p:cNvPr id="31" name="qua-code-6">
             <a:extLst xmlns:a="http://schemas.openxmlformats.org/drawingml/2006/main">
               <a:ext uri="{FF2B5EF4-FFF2-40B4-BE49-F238E27FC236}">
-                <a16:creationId xmlns:a16="http://schemas.microsoft.com/office/drawing/2014/main" id="{6B6AE767-95A8-4218-A02B-002AA112D629}"/>
+                <a16:creationId xmlns:a16="http://schemas.microsoft.com/office/drawing/2014/main" id="{AC7EF38C-745B-491C-8DF2-30334D8B7BC1}"/>
               </a:ext>
             </a:extLst>
           </p:cNvPr>
@@ -10161,7 +10162,7 @@
           <p:cNvPr id="32" name="qua-title-6">
             <a:extLst xmlns:a="http://schemas.openxmlformats.org/drawingml/2006/main">
               <a:ext uri="{FF2B5EF4-FFF2-40B4-BE49-F238E27FC236}">
-                <a16:creationId xmlns:a16="http://schemas.microsoft.com/office/drawing/2014/main" id="{E55CF6C3-51B2-449D-BDBF-B1DBB7BDD46C}"/>
+                <a16:creationId xmlns:a16="http://schemas.microsoft.com/office/drawing/2014/main" id="{C281CA9B-2676-492D-800F-853AF7B537CB}"/>
               </a:ext>
             </a:extLst>
           </p:cNvPr>
@@ -10206,7 +10207,7 @@
           <p:cNvPr id="33" name="qua-body-6">
             <a:extLst xmlns:a="http://schemas.openxmlformats.org/drawingml/2006/main">
               <a:ext uri="{FF2B5EF4-FFF2-40B4-BE49-F238E27FC236}">
-                <a16:creationId xmlns:a16="http://schemas.microsoft.com/office/drawing/2014/main" id="{6481681E-1E60-486E-BE14-38C2E3D2E2BF}"/>
+                <a16:creationId xmlns:a16="http://schemas.microsoft.com/office/drawing/2014/main" id="{BF5CBD95-5119-4187-ACD1-3DBE4258D4E2}"/>
               </a:ext>
             </a:extLst>
           </p:cNvPr>
@@ -10252,7 +10253,7 @@
           <p:cNvPr id="34" name="qua-proof">
             <a:extLst xmlns:a="http://schemas.openxmlformats.org/drawingml/2006/main">
               <a:ext uri="{FF2B5EF4-FFF2-40B4-BE49-F238E27FC236}">
-                <a16:creationId xmlns:a16="http://schemas.microsoft.com/office/drawing/2014/main" id="{297E1E9A-CC61-4996-9E73-BE9800AE003F}"/>
+                <a16:creationId xmlns:a16="http://schemas.microsoft.com/office/drawing/2014/main" id="{17371D18-AC5A-42C1-8A7B-4FD1D38D74A2}"/>
               </a:ext>
             </a:extLst>
           </p:cNvPr>
@@ -10285,7 +10286,7 @@
           <p:cNvPr id="35" name="qua-proof-text">
             <a:extLst xmlns:a="http://schemas.openxmlformats.org/drawingml/2006/main">
               <a:ext uri="{FF2B5EF4-FFF2-40B4-BE49-F238E27FC236}">
-                <a16:creationId xmlns:a16="http://schemas.microsoft.com/office/drawing/2014/main" id="{ED71B806-9F27-4B6B-89D0-0BC4C995D583}"/>
+                <a16:creationId xmlns:a16="http://schemas.microsoft.com/office/drawing/2014/main" id="{44401676-FF3D-4A0F-876E-87171D9072A8}"/>
               </a:ext>
             </a:extLst>
           </p:cNvPr>
@@ -10328,7 +10329,7 @@
     </p:spTree>
     <p:extLst>
       <p:ext uri="{BB962C8B-B14F-4D97-AF65-F5344CB8AC3E}">
-        <p14:creationId xmlns:p14="http://schemas.microsoft.com/office/powerpoint/2010/main" val="1060054947"/>
+        <p14:creationId xmlns:p14="http://schemas.microsoft.com/office/powerpoint/2010/main" val="203850756"/>
       </p:ext>
     </p:extLst>
   </p:cSld>
@@ -10359,7 +10360,7 @@
           <p:cNvPr id="26" name="title-6">
             <a:extLst xmlns:a="http://schemas.openxmlformats.org/drawingml/2006/main">
               <a:ext uri="{FF2B5EF4-FFF2-40B4-BE49-F238E27FC236}">
-                <a16:creationId xmlns:a16="http://schemas.microsoft.com/office/drawing/2014/main" id="{269CDC5D-10D1-4458-9026-7DC26ABC6830}"/>
+                <a16:creationId xmlns:a16="http://schemas.microsoft.com/office/drawing/2014/main" id="{50005EA8-3442-4ADA-A6FE-B369229271B0}"/>
               </a:ext>
             </a:extLst>
           </p:cNvPr>
@@ -10404,7 +10405,7 @@
           <p:cNvPr id="2" name="source-6">
             <a:extLst xmlns:a="http://schemas.openxmlformats.org/drawingml/2006/main">
               <a:ext uri="{FF2B5EF4-FFF2-40B4-BE49-F238E27FC236}">
-                <a16:creationId xmlns:a16="http://schemas.microsoft.com/office/drawing/2014/main" id="{300A5C6B-7D67-4092-A1FA-326C55C3E1AA}"/>
+                <a16:creationId xmlns:a16="http://schemas.microsoft.com/office/drawing/2014/main" id="{94B0BF1A-73FB-48B3-87FF-342524546AEE}"/>
               </a:ext>
             </a:extLst>
           </p:cNvPr>
@@ -10449,7 +10450,7 @@
           <p:cNvPr id="3" name="page-6">
             <a:extLst xmlns:a="http://schemas.openxmlformats.org/drawingml/2006/main">
               <a:ext uri="{FF2B5EF4-FFF2-40B4-BE49-F238E27FC236}">
-                <a16:creationId xmlns:a16="http://schemas.microsoft.com/office/drawing/2014/main" id="{5D7A9F77-30EF-4597-9262-B3742DF0385F}"/>
+                <a16:creationId xmlns:a16="http://schemas.microsoft.com/office/drawing/2014/main" id="{7CA99323-1B87-4FC0-8548-CF2E703E9721}"/>
               </a:ext>
             </a:extLst>
           </p:cNvPr>
@@ -10494,7 +10495,7 @@
           <p:cNvPr id="4" name="spatial-lead">
             <a:extLst xmlns:a="http://schemas.openxmlformats.org/drawingml/2006/main">
               <a:ext uri="{FF2B5EF4-FFF2-40B4-BE49-F238E27FC236}">
-                <a16:creationId xmlns:a16="http://schemas.microsoft.com/office/drawing/2014/main" id="{148E5136-FC5C-44F8-BE9F-736A3D0BEF03}"/>
+                <a16:creationId xmlns:a16="http://schemas.microsoft.com/office/drawing/2014/main" id="{A5AFC7EF-084B-4217-8C94-C011E70C6863}"/>
               </a:ext>
             </a:extLst>
           </p:cNvPr>
@@ -10561,7 +10562,7 @@
           <p:cNvPr id="6" name="spatial-panel-0">
             <a:extLst xmlns:a="http://schemas.openxmlformats.org/drawingml/2006/main">
               <a:ext uri="{FF2B5EF4-FFF2-40B4-BE49-F238E27FC236}">
-                <a16:creationId xmlns:a16="http://schemas.microsoft.com/office/drawing/2014/main" id="{E117E14D-B6BB-4353-B150-AB02D01F4762}"/>
+                <a16:creationId xmlns:a16="http://schemas.microsoft.com/office/drawing/2014/main" id="{83184A07-EF94-4409-8C71-1B82177819C1}"/>
               </a:ext>
             </a:extLst>
           </p:cNvPr>
@@ -10594,7 +10595,7 @@
           <p:cNvPr id="7" name="spatial-bar-0">
             <a:extLst xmlns:a="http://schemas.openxmlformats.org/drawingml/2006/main">
               <a:ext uri="{FF2B5EF4-FFF2-40B4-BE49-F238E27FC236}">
-                <a16:creationId xmlns:a16="http://schemas.microsoft.com/office/drawing/2014/main" id="{C1C80CA7-9B85-435F-9C01-102CCF18C76B}"/>
+                <a16:creationId xmlns:a16="http://schemas.microsoft.com/office/drawing/2014/main" id="{C9AE9321-C22E-4C26-A6B5-285089EBA4E2}"/>
               </a:ext>
             </a:extLst>
           </p:cNvPr>
@@ -10627,7 +10628,7 @@
           <p:cNvPr id="8" name="spatial-title-0">
             <a:extLst xmlns:a="http://schemas.openxmlformats.org/drawingml/2006/main">
               <a:ext uri="{FF2B5EF4-FFF2-40B4-BE49-F238E27FC236}">
-                <a16:creationId xmlns:a16="http://schemas.microsoft.com/office/drawing/2014/main" id="{CD7FF3A2-A3ED-4EF2-A81A-912A8CB2F051}"/>
+                <a16:creationId xmlns:a16="http://schemas.microsoft.com/office/drawing/2014/main" id="{69B44284-EA46-4E34-A1FD-C8D0C37D03F4}"/>
               </a:ext>
             </a:extLst>
           </p:cNvPr>
@@ -10672,7 +10673,7 @@
           <p:cNvPr id="9" name="spatial-rows-0">
             <a:extLst xmlns:a="http://schemas.openxmlformats.org/drawingml/2006/main">
               <a:ext uri="{FF2B5EF4-FFF2-40B4-BE49-F238E27FC236}">
-                <a16:creationId xmlns:a16="http://schemas.microsoft.com/office/drawing/2014/main" id="{EB3F9650-5411-4196-9016-544697534148}"/>
+                <a16:creationId xmlns:a16="http://schemas.microsoft.com/office/drawing/2014/main" id="{A8127BFD-EB9F-4D2E-B75A-064B16F2B05C}"/>
               </a:ext>
             </a:extLst>
           </p:cNvPr>
@@ -10717,7 +10718,7 @@
           <p:cNvPr id="10" name="spatial-blocks-0">
             <a:extLst xmlns:a="http://schemas.openxmlformats.org/drawingml/2006/main">
               <a:ext uri="{FF2B5EF4-FFF2-40B4-BE49-F238E27FC236}">
-                <a16:creationId xmlns:a16="http://schemas.microsoft.com/office/drawing/2014/main" id="{D717487A-3308-41DA-AA71-109D5C101CED}"/>
+                <a16:creationId xmlns:a16="http://schemas.microsoft.com/office/drawing/2014/main" id="{4D3659E3-5693-4081-AEFA-DFF116E3C7A3}"/>
               </a:ext>
             </a:extLst>
           </p:cNvPr>
@@ -10762,7 +10763,7 @@
           <p:cNvPr id="11" name="spatial-body-0">
             <a:extLst xmlns:a="http://schemas.openxmlformats.org/drawingml/2006/main">
               <a:ext uri="{FF2B5EF4-FFF2-40B4-BE49-F238E27FC236}">
-                <a16:creationId xmlns:a16="http://schemas.microsoft.com/office/drawing/2014/main" id="{CF315AAF-FF0C-46F1-94BF-C41396B3A53D}"/>
+                <a16:creationId xmlns:a16="http://schemas.microsoft.com/office/drawing/2014/main" id="{2603BD95-019C-4DDE-A99E-4F39C31864BC}"/>
               </a:ext>
             </a:extLst>
           </p:cNvPr>
@@ -10807,7 +10808,7 @@
           <p:cNvPr id="12" name="spatial-panel-1">
             <a:extLst xmlns:a="http://schemas.openxmlformats.org/drawingml/2006/main">
               <a:ext uri="{FF2B5EF4-FFF2-40B4-BE49-F238E27FC236}">
-                <a16:creationId xmlns:a16="http://schemas.microsoft.com/office/drawing/2014/main" id="{F67AC26A-BCBD-44B1-86ED-2AB6DF65068F}"/>
+                <a16:creationId xmlns:a16="http://schemas.microsoft.com/office/drawing/2014/main" id="{ED654561-A5DD-4DF0-9A23-5BAB2E4801BC}"/>
               </a:ext>
             </a:extLst>
           </p:cNvPr>
@@ -10840,7 +10841,7 @@
           <p:cNvPr id="13" name="spatial-bar-1">
             <a:extLst xmlns:a="http://schemas.openxmlformats.org/drawingml/2006/main">
               <a:ext uri="{FF2B5EF4-FFF2-40B4-BE49-F238E27FC236}">
-                <a16:creationId xmlns:a16="http://schemas.microsoft.com/office/drawing/2014/main" id="{0F2A520F-434D-497E-A185-6A6D9887E407}"/>
+                <a16:creationId xmlns:a16="http://schemas.microsoft.com/office/drawing/2014/main" id="{3B64230C-7FE8-4872-A980-A0553AE7578C}"/>
               </a:ext>
             </a:extLst>
           </p:cNvPr>
@@ -10873,7 +10874,7 @@
           <p:cNvPr id="14" name="spatial-title-1">
             <a:extLst xmlns:a="http://schemas.openxmlformats.org/drawingml/2006/main">
               <a:ext uri="{FF2B5EF4-FFF2-40B4-BE49-F238E27FC236}">
-                <a16:creationId xmlns:a16="http://schemas.microsoft.com/office/drawing/2014/main" id="{13AAF135-375D-4982-BE24-1247DC30FA91}"/>
+                <a16:creationId xmlns:a16="http://schemas.microsoft.com/office/drawing/2014/main" id="{551E5C9F-DB3A-42ED-B2B0-D462719620DA}"/>
               </a:ext>
             </a:extLst>
           </p:cNvPr>
@@ -10918,7 +10919,7 @@
           <p:cNvPr id="15" name="spatial-rows-1">
             <a:extLst xmlns:a="http://schemas.openxmlformats.org/drawingml/2006/main">
               <a:ext uri="{FF2B5EF4-FFF2-40B4-BE49-F238E27FC236}">
-                <a16:creationId xmlns:a16="http://schemas.microsoft.com/office/drawing/2014/main" id="{1938720D-C4BD-4C2B-82E9-189DAB5B8DAF}"/>
+                <a16:creationId xmlns:a16="http://schemas.microsoft.com/office/drawing/2014/main" id="{27FF2603-70F2-4DA5-BA56-5F826288AA92}"/>
               </a:ext>
             </a:extLst>
           </p:cNvPr>
@@ -10963,7 +10964,7 @@
           <p:cNvPr id="16" name="spatial-blocks-1">
             <a:extLst xmlns:a="http://schemas.openxmlformats.org/drawingml/2006/main">
               <a:ext uri="{FF2B5EF4-FFF2-40B4-BE49-F238E27FC236}">
-                <a16:creationId xmlns:a16="http://schemas.microsoft.com/office/drawing/2014/main" id="{842D2001-B0E7-4699-987B-D3BA44862631}"/>
+                <a16:creationId xmlns:a16="http://schemas.microsoft.com/office/drawing/2014/main" id="{3805DBC7-B593-4193-BA37-8CADC52A5854}"/>
               </a:ext>
             </a:extLst>
           </p:cNvPr>
@@ -11008,7 +11009,7 @@
           <p:cNvPr id="17" name="spatial-body-1">
             <a:extLst xmlns:a="http://schemas.openxmlformats.org/drawingml/2006/main">
               <a:ext uri="{FF2B5EF4-FFF2-40B4-BE49-F238E27FC236}">
-                <a16:creationId xmlns:a16="http://schemas.microsoft.com/office/drawing/2014/main" id="{8E611AB0-4A7F-4F55-8074-232172FA99F1}"/>
+                <a16:creationId xmlns:a16="http://schemas.microsoft.com/office/drawing/2014/main" id="{D7DDC511-9324-46E1-AFF4-31858528FC25}"/>
               </a:ext>
             </a:extLst>
           </p:cNvPr>
@@ -11053,7 +11054,7 @@
           <p:cNvPr id="18" name="spatial-panel-2">
             <a:extLst xmlns:a="http://schemas.openxmlformats.org/drawingml/2006/main">
               <a:ext uri="{FF2B5EF4-FFF2-40B4-BE49-F238E27FC236}">
-                <a16:creationId xmlns:a16="http://schemas.microsoft.com/office/drawing/2014/main" id="{A5C272F3-2BCF-4FE2-A122-C5F3FA638CC4}"/>
+                <a16:creationId xmlns:a16="http://schemas.microsoft.com/office/drawing/2014/main" id="{F15C104B-962B-4FD9-9763-C954EE057ECA}"/>
               </a:ext>
             </a:extLst>
           </p:cNvPr>
@@ -11086,7 +11087,7 @@
           <p:cNvPr id="19" name="spatial-bar-2">
             <a:extLst xmlns:a="http://schemas.openxmlformats.org/drawingml/2006/main">
               <a:ext uri="{FF2B5EF4-FFF2-40B4-BE49-F238E27FC236}">
-                <a16:creationId xmlns:a16="http://schemas.microsoft.com/office/drawing/2014/main" id="{4FB2AADC-3763-44B5-85C6-954CDE97BF5A}"/>
+                <a16:creationId xmlns:a16="http://schemas.microsoft.com/office/drawing/2014/main" id="{0D8577BD-B191-41AD-B7CA-5CDDD19DB673}"/>
               </a:ext>
             </a:extLst>
           </p:cNvPr>
@@ -11119,7 +11120,7 @@
           <p:cNvPr id="20" name="spatial-title-2">
             <a:extLst xmlns:a="http://schemas.openxmlformats.org/drawingml/2006/main">
               <a:ext uri="{FF2B5EF4-FFF2-40B4-BE49-F238E27FC236}">
-                <a16:creationId xmlns:a16="http://schemas.microsoft.com/office/drawing/2014/main" id="{AB78CD1F-37E1-4F74-94B7-AA2239B09A6B}"/>
+                <a16:creationId xmlns:a16="http://schemas.microsoft.com/office/drawing/2014/main" id="{6A92D06E-9715-4BAF-B1FD-9F9F3CEF2CC9}"/>
               </a:ext>
             </a:extLst>
           </p:cNvPr>
@@ -11164,7 +11165,7 @@
           <p:cNvPr id="21" name="spatial-rows-2">
             <a:extLst xmlns:a="http://schemas.openxmlformats.org/drawingml/2006/main">
               <a:ext uri="{FF2B5EF4-FFF2-40B4-BE49-F238E27FC236}">
-                <a16:creationId xmlns:a16="http://schemas.microsoft.com/office/drawing/2014/main" id="{4C7B6950-52E0-45D4-AD0E-823CB89349BA}"/>
+                <a16:creationId xmlns:a16="http://schemas.microsoft.com/office/drawing/2014/main" id="{7F67D915-E199-4785-83D4-5E3558040B7E}"/>
               </a:ext>
             </a:extLst>
           </p:cNvPr>
@@ -11209,7 +11210,7 @@
           <p:cNvPr id="22" name="spatial-blocks-2">
             <a:extLst xmlns:a="http://schemas.openxmlformats.org/drawingml/2006/main">
               <a:ext uri="{FF2B5EF4-FFF2-40B4-BE49-F238E27FC236}">
-                <a16:creationId xmlns:a16="http://schemas.microsoft.com/office/drawing/2014/main" id="{320C8E59-74D7-4FF0-AA77-979CD3CC687C}"/>
+                <a16:creationId xmlns:a16="http://schemas.microsoft.com/office/drawing/2014/main" id="{4200C609-8B87-4C58-B103-CC4A23A607B2}"/>
               </a:ext>
             </a:extLst>
           </p:cNvPr>
@@ -11254,7 +11255,7 @@
           <p:cNvPr id="23" name="spatial-body-2">
             <a:extLst xmlns:a="http://schemas.openxmlformats.org/drawingml/2006/main">
               <a:ext uri="{FF2B5EF4-FFF2-40B4-BE49-F238E27FC236}">
-                <a16:creationId xmlns:a16="http://schemas.microsoft.com/office/drawing/2014/main" id="{F2DEF1A2-1F6B-44B1-B880-84A5F90F046E}"/>
+                <a16:creationId xmlns:a16="http://schemas.microsoft.com/office/drawing/2014/main" id="{05767D46-28B8-44C5-9C56-B9996CC35C45}"/>
               </a:ext>
             </a:extLst>
           </p:cNvPr>
@@ -11299,7 +11300,7 @@
           <p:cNvPr id="24" name="zero-overlap">
             <a:extLst xmlns:a="http://schemas.openxmlformats.org/drawingml/2006/main">
               <a:ext uri="{FF2B5EF4-FFF2-40B4-BE49-F238E27FC236}">
-                <a16:creationId xmlns:a16="http://schemas.microsoft.com/office/drawing/2014/main" id="{34ECEC5E-6CBD-48E1-A9C1-BC0D90F4FDF9}"/>
+                <a16:creationId xmlns:a16="http://schemas.microsoft.com/office/drawing/2014/main" id="{27168938-AD1D-444B-812F-CAB25DBCE3E5}"/>
               </a:ext>
             </a:extLst>
           </p:cNvPr>
@@ -11332,7 +11333,7 @@
           <p:cNvPr id="25" name="zero-overlap-text">
             <a:extLst xmlns:a="http://schemas.openxmlformats.org/drawingml/2006/main">
               <a:ext uri="{FF2B5EF4-FFF2-40B4-BE49-F238E27FC236}">
-                <a16:creationId xmlns:a16="http://schemas.microsoft.com/office/drawing/2014/main" id="{177B73BB-A1A0-4B58-A56D-FDD29323D26B}"/>
+                <a16:creationId xmlns:a16="http://schemas.microsoft.com/office/drawing/2014/main" id="{4D018353-2DA6-4EF6-98D4-DBECF275002A}"/>
               </a:ext>
             </a:extLst>
           </p:cNvPr>
@@ -11375,7 +11376,7 @@
     </p:spTree>
     <p:extLst>
       <p:ext uri="{BB962C8B-B14F-4D97-AF65-F5344CB8AC3E}">
-        <p14:creationId xmlns:p14="http://schemas.microsoft.com/office/powerpoint/2010/main" val="293564384"/>
+        <p14:creationId xmlns:p14="http://schemas.microsoft.com/office/powerpoint/2010/main" val="1721180713"/>
       </p:ext>
     </p:extLst>
   </p:cSld>
@@ -11406,7 +11407,7 @@
           <p:cNvPr id="12" name="title-7">
             <a:extLst xmlns:a="http://schemas.openxmlformats.org/drawingml/2006/main">
               <a:ext uri="{FF2B5EF4-FFF2-40B4-BE49-F238E27FC236}">
-                <a16:creationId xmlns:a16="http://schemas.microsoft.com/office/drawing/2014/main" id="{CD2000E0-140D-46DD-AB88-D83C73DF4C64}"/>
+                <a16:creationId xmlns:a16="http://schemas.microsoft.com/office/drawing/2014/main" id="{E990B8BA-D406-4187-B7A8-9F59A684C9AB}"/>
               </a:ext>
             </a:extLst>
           </p:cNvPr>
@@ -11451,7 +11452,7 @@
           <p:cNvPr id="2" name="source-7">
             <a:extLst xmlns:a="http://schemas.openxmlformats.org/drawingml/2006/main">
               <a:ext uri="{FF2B5EF4-FFF2-40B4-BE49-F238E27FC236}">
-                <a16:creationId xmlns:a16="http://schemas.microsoft.com/office/drawing/2014/main" id="{699EB310-5A70-46F6-93DA-2A3B1B1BF82B}"/>
+                <a16:creationId xmlns:a16="http://schemas.microsoft.com/office/drawing/2014/main" id="{300D2DA8-E580-43A8-AFF9-659A2E23E135}"/>
               </a:ext>
             </a:extLst>
           </p:cNvPr>
@@ -11496,7 +11497,7 @@
           <p:cNvPr id="3" name="page-7">
             <a:extLst xmlns:a="http://schemas.openxmlformats.org/drawingml/2006/main">
               <a:ext uri="{FF2B5EF4-FFF2-40B4-BE49-F238E27FC236}">
-                <a16:creationId xmlns:a16="http://schemas.microsoft.com/office/drawing/2014/main" id="{D7D95732-C78F-47A6-8956-E1C3B4797FE6}"/>
+                <a16:creationId xmlns:a16="http://schemas.microsoft.com/office/drawing/2014/main" id="{2A378912-C2B2-482B-B14C-6366426ABC5F}"/>
               </a:ext>
             </a:extLst>
           </p:cNvPr>
@@ -11541,7 +11542,7 @@
           <p:cNvPr id="4" name="benchmark-callout-one">
             <a:extLst xmlns:a="http://schemas.openxmlformats.org/drawingml/2006/main">
               <a:ext uri="{FF2B5EF4-FFF2-40B4-BE49-F238E27FC236}">
-                <a16:creationId xmlns:a16="http://schemas.microsoft.com/office/drawing/2014/main" id="{C726DE14-ED9E-4204-8FA2-8ADA5CD0DF08}"/>
+                <a16:creationId xmlns:a16="http://schemas.microsoft.com/office/drawing/2014/main" id="{E2897885-8EBD-4C01-888B-5ACC0378806F}"/>
               </a:ext>
             </a:extLst>
           </p:cNvPr>
@@ -11574,7 +11575,7 @@
           <p:cNvPr id="5" name="benchmark-callout-one-title">
             <a:extLst xmlns:a="http://schemas.openxmlformats.org/drawingml/2006/main">
               <a:ext uri="{FF2B5EF4-FFF2-40B4-BE49-F238E27FC236}">
-                <a16:creationId xmlns:a16="http://schemas.microsoft.com/office/drawing/2014/main" id="{9E1DC7F9-94DC-4485-B4CE-D5BFDEC7A23F}"/>
+                <a16:creationId xmlns:a16="http://schemas.microsoft.com/office/drawing/2014/main" id="{DFDC6295-5015-4E56-BA04-FDDAA14F2154}"/>
               </a:ext>
             </a:extLst>
           </p:cNvPr>
@@ -11619,7 +11620,7 @@
           <p:cNvPr id="6" name="benchmark-callout-one-body">
             <a:extLst xmlns:a="http://schemas.openxmlformats.org/drawingml/2006/main">
               <a:ext uri="{FF2B5EF4-FFF2-40B4-BE49-F238E27FC236}">
-                <a16:creationId xmlns:a16="http://schemas.microsoft.com/office/drawing/2014/main" id="{E8DC41BB-2DCE-4F10-95D2-89DFB8509086}"/>
+                <a16:creationId xmlns:a16="http://schemas.microsoft.com/office/drawing/2014/main" id="{5F0429CE-C9BD-4B8F-94E2-F48A9C3B1B76}"/>
               </a:ext>
             </a:extLst>
           </p:cNvPr>
@@ -11664,7 +11665,7 @@
           <p:cNvPr id="7" name="benchmark-callout-two">
             <a:extLst xmlns:a="http://schemas.openxmlformats.org/drawingml/2006/main">
               <a:ext uri="{FF2B5EF4-FFF2-40B4-BE49-F238E27FC236}">
-                <a16:creationId xmlns:a16="http://schemas.microsoft.com/office/drawing/2014/main" id="{DF0BD567-5D01-4635-AD64-BF89D921FF11}"/>
+                <a16:creationId xmlns:a16="http://schemas.microsoft.com/office/drawing/2014/main" id="{9F0F4947-4F5E-46D6-9F4A-4D280836A4C1}"/>
               </a:ext>
             </a:extLst>
           </p:cNvPr>
@@ -11697,7 +11698,7 @@
           <p:cNvPr id="8" name="benchmark-callout-two-title">
             <a:extLst xmlns:a="http://schemas.openxmlformats.org/drawingml/2006/main">
               <a:ext uri="{FF2B5EF4-FFF2-40B4-BE49-F238E27FC236}">
-                <a16:creationId xmlns:a16="http://schemas.microsoft.com/office/drawing/2014/main" id="{8A5CE399-EBB0-435C-89EA-74592B238789}"/>
+                <a16:creationId xmlns:a16="http://schemas.microsoft.com/office/drawing/2014/main" id="{E388F04C-C860-4FAF-A470-DFC3433722C1}"/>
               </a:ext>
             </a:extLst>
           </p:cNvPr>
@@ -11742,7 +11743,7 @@
           <p:cNvPr id="9" name="benchmark-callout-two-body">
             <a:extLst xmlns:a="http://schemas.openxmlformats.org/drawingml/2006/main">
               <a:ext uri="{FF2B5EF4-FFF2-40B4-BE49-F238E27FC236}">
-                <a16:creationId xmlns:a16="http://schemas.microsoft.com/office/drawing/2014/main" id="{B942740B-FA9F-46D4-80F6-2A18C81BFB82}"/>
+                <a16:creationId xmlns:a16="http://schemas.microsoft.com/office/drawing/2014/main" id="{FC3A05ED-92ED-4645-891C-74F73AFC8946}"/>
               </a:ext>
             </a:extLst>
           </p:cNvPr>
@@ -11787,7 +11788,7 @@
           <p:cNvPr id="10" name="benchmark-interpretation">
             <a:extLst xmlns:a="http://schemas.openxmlformats.org/drawingml/2006/main">
               <a:ext uri="{FF2B5EF4-FFF2-40B4-BE49-F238E27FC236}">
-                <a16:creationId xmlns:a16="http://schemas.microsoft.com/office/drawing/2014/main" id="{CE3780BF-7C42-4004-860C-09B399913515}"/>
+                <a16:creationId xmlns:a16="http://schemas.microsoft.com/office/drawing/2014/main" id="{B8BDAEB3-47EF-4F6B-A558-306BD39B2DA0}"/>
               </a:ext>
             </a:extLst>
           </p:cNvPr>
@@ -11839,14 +11840,14 @@
         </p:xfrm>
         <a:graphic xmlns:a="http://schemas.openxmlformats.org/drawingml/2006/main">
           <a:graphicData uri="http://schemas.openxmlformats.org/drawingml/2006/chart">
-            <c:chart xmlns:r="http://schemas.openxmlformats.org/officeDocument/2006/relationships" xmlns:c="http://schemas.openxmlformats.org/drawingml/2006/chart" r:id="R9dad57064fe64ac6"/>
+            <c:chart xmlns:r="http://schemas.openxmlformats.org/officeDocument/2006/relationships" xmlns:c="http://schemas.openxmlformats.org/drawingml/2006/chart" r:id="R3db4e6f74d2d496c"/>
           </a:graphicData>
         </a:graphic>
       </p:graphicFrame>
     </p:spTree>
     <p:extLst>
       <p:ext uri="{BB962C8B-B14F-4D97-AF65-F5344CB8AC3E}">
-        <p14:creationId xmlns:p14="http://schemas.microsoft.com/office/powerpoint/2010/main" val="1695182741"/>
+        <p14:creationId xmlns:p14="http://schemas.microsoft.com/office/powerpoint/2010/main" val="334940402"/>
       </p:ext>
     </p:extLst>
   </p:cSld>
@@ -11877,7 +11878,7 @@
           <p:cNvPr id="14" name="title-8">
             <a:extLst xmlns:a="http://schemas.openxmlformats.org/drawingml/2006/main">
               <a:ext uri="{FF2B5EF4-FFF2-40B4-BE49-F238E27FC236}">
-                <a16:creationId xmlns:a16="http://schemas.microsoft.com/office/drawing/2014/main" id="{5EF18D27-C117-4201-B0D3-714B6D57CF52}"/>
+                <a16:creationId xmlns:a16="http://schemas.microsoft.com/office/drawing/2014/main" id="{5A1BC00A-3C91-4993-B839-44E203B628EB}"/>
               </a:ext>
             </a:extLst>
           </p:cNvPr>
@@ -11922,7 +11923,7 @@
           <p:cNvPr id="2" name="source-8">
             <a:extLst xmlns:a="http://schemas.openxmlformats.org/drawingml/2006/main">
               <a:ext uri="{FF2B5EF4-FFF2-40B4-BE49-F238E27FC236}">
-                <a16:creationId xmlns:a16="http://schemas.microsoft.com/office/drawing/2014/main" id="{B1A72826-F67D-43E7-B01F-BB5D527D182A}"/>
+                <a16:creationId xmlns:a16="http://schemas.microsoft.com/office/drawing/2014/main" id="{99D9CD9B-4925-4BF1-BC72-C1EE510D0EB7}"/>
               </a:ext>
             </a:extLst>
           </p:cNvPr>
@@ -11967,7 +11968,7 @@
           <p:cNvPr id="3" name="page-8">
             <a:extLst xmlns:a="http://schemas.openxmlformats.org/drawingml/2006/main">
               <a:ext uri="{FF2B5EF4-FFF2-40B4-BE49-F238E27FC236}">
-                <a16:creationId xmlns:a16="http://schemas.microsoft.com/office/drawing/2014/main" id="{C60C5534-7E77-448F-9CC5-0FE021F575B0}"/>
+                <a16:creationId xmlns:a16="http://schemas.microsoft.com/office/drawing/2014/main" id="{CD3BDDA6-FE34-4473-826F-702762C78827}"/>
               </a:ext>
             </a:extLst>
           </p:cNvPr>
@@ -12012,7 +12013,7 @@
           <p:cNvPr id="4" name="final-lead">
             <a:extLst xmlns:a="http://schemas.openxmlformats.org/drawingml/2006/main">
               <a:ext uri="{FF2B5EF4-FFF2-40B4-BE49-F238E27FC236}">
-                <a16:creationId xmlns:a16="http://schemas.microsoft.com/office/drawing/2014/main" id="{1BCBDD14-6987-48BF-B6B6-5357C1A2F1BB}"/>
+                <a16:creationId xmlns:a16="http://schemas.microsoft.com/office/drawing/2014/main" id="{9DBDE320-C1A1-4B6E-AB98-475092237BE3}"/>
               </a:ext>
             </a:extLst>
           </p:cNvPr>
@@ -12057,7 +12058,7 @@
           <p:cNvPr id="5" name="final-chart-title">
             <a:extLst xmlns:a="http://schemas.openxmlformats.org/drawingml/2006/main">
               <a:ext uri="{FF2B5EF4-FFF2-40B4-BE49-F238E27FC236}">
-                <a16:creationId xmlns:a16="http://schemas.microsoft.com/office/drawing/2014/main" id="{12A3E849-6FE7-432A-AD8A-F7BEFCD07989}"/>
+                <a16:creationId xmlns:a16="http://schemas.microsoft.com/office/drawing/2014/main" id="{660F3D57-D395-4713-9D30-5283801E4E68}"/>
               </a:ext>
             </a:extLst>
           </p:cNvPr>
@@ -12102,7 +12103,7 @@
           <p:cNvPr id="6" name="final-metric-one">
             <a:extLst xmlns:a="http://schemas.openxmlformats.org/drawingml/2006/main">
               <a:ext uri="{FF2B5EF4-FFF2-40B4-BE49-F238E27FC236}">
-                <a16:creationId xmlns:a16="http://schemas.microsoft.com/office/drawing/2014/main" id="{819608CE-74B9-40F6-A6C6-0B0D040955AE}"/>
+                <a16:creationId xmlns:a16="http://schemas.microsoft.com/office/drawing/2014/main" id="{0B1823AF-C7D8-45C8-9136-34A7ADEC4D81}"/>
               </a:ext>
             </a:extLst>
           </p:cNvPr>
@@ -12135,7 +12136,7 @@
           <p:cNvPr id="7" name="final-metric-one-stat">
             <a:extLst xmlns:a="http://schemas.openxmlformats.org/drawingml/2006/main">
               <a:ext uri="{FF2B5EF4-FFF2-40B4-BE49-F238E27FC236}">
-                <a16:creationId xmlns:a16="http://schemas.microsoft.com/office/drawing/2014/main" id="{F17895AF-5EE6-40C7-848F-9A2B5D73EE06}"/>
+                <a16:creationId xmlns:a16="http://schemas.microsoft.com/office/drawing/2014/main" id="{02C2B236-09BA-47C5-B704-8445D32A1158}"/>
               </a:ext>
             </a:extLst>
           </p:cNvPr>
@@ -12180,7 +12181,7 @@
           <p:cNvPr id="8" name="final-metric-one-body">
             <a:extLst xmlns:a="http://schemas.openxmlformats.org/drawingml/2006/main">
               <a:ext uri="{FF2B5EF4-FFF2-40B4-BE49-F238E27FC236}">
-                <a16:creationId xmlns:a16="http://schemas.microsoft.com/office/drawing/2014/main" id="{E7BB7297-1C37-46DF-8F58-83C864D4C57A}"/>
+                <a16:creationId xmlns:a16="http://schemas.microsoft.com/office/drawing/2014/main" id="{CF6395FF-9F43-4CF6-8862-0719A650B4AB}"/>
               </a:ext>
             </a:extLst>
           </p:cNvPr>
@@ -12225,7 +12226,7 @@
           <p:cNvPr id="9" name="final-metric-two">
             <a:extLst xmlns:a="http://schemas.openxmlformats.org/drawingml/2006/main">
               <a:ext uri="{FF2B5EF4-FFF2-40B4-BE49-F238E27FC236}">
-                <a16:creationId xmlns:a16="http://schemas.microsoft.com/office/drawing/2014/main" id="{B211FB01-69E3-4B52-88D9-810C6644AC01}"/>
+                <a16:creationId xmlns:a16="http://schemas.microsoft.com/office/drawing/2014/main" id="{83E8F88A-46E2-411C-84C7-504EF22734A8}"/>
               </a:ext>
             </a:extLst>
           </p:cNvPr>
@@ -12258,7 +12259,7 @@
           <p:cNvPr id="10" name="final-metric-two-stat">
             <a:extLst xmlns:a="http://schemas.openxmlformats.org/drawingml/2006/main">
               <a:ext uri="{FF2B5EF4-FFF2-40B4-BE49-F238E27FC236}">
-                <a16:creationId xmlns:a16="http://schemas.microsoft.com/office/drawing/2014/main" id="{23481738-E7BC-43E1-822A-7B8C81976774}"/>
+                <a16:creationId xmlns:a16="http://schemas.microsoft.com/office/drawing/2014/main" id="{06126204-2B1A-497B-B29F-5B395624FE58}"/>
               </a:ext>
             </a:extLst>
           </p:cNvPr>
@@ -12303,7 +12304,7 @@
           <p:cNvPr id="11" name="final-metric-two-body">
             <a:extLst xmlns:a="http://schemas.openxmlformats.org/drawingml/2006/main">
               <a:ext uri="{FF2B5EF4-FFF2-40B4-BE49-F238E27FC236}">
-                <a16:creationId xmlns:a16="http://schemas.microsoft.com/office/drawing/2014/main" id="{63D9C7DC-2BC8-4AD5-9DD4-C5ABF61B239A}"/>
+                <a16:creationId xmlns:a16="http://schemas.microsoft.com/office/drawing/2014/main" id="{D9E72225-8EE5-4976-BBBB-C6C6BFAF7580}"/>
               </a:ext>
             </a:extLst>
           </p:cNvPr>
@@ -12348,7 +12349,7 @@
           <p:cNvPr id="12" name="final-warning">
             <a:extLst xmlns:a="http://schemas.openxmlformats.org/drawingml/2006/main">
               <a:ext uri="{FF2B5EF4-FFF2-40B4-BE49-F238E27FC236}">
-                <a16:creationId xmlns:a16="http://schemas.microsoft.com/office/drawing/2014/main" id="{14A5A0F6-413C-4FC2-ADA6-616CC3E0382F}"/>
+                <a16:creationId xmlns:a16="http://schemas.microsoft.com/office/drawing/2014/main" id="{58EAE273-2BFF-423A-9F74-D1E0F70529D4}"/>
               </a:ext>
             </a:extLst>
           </p:cNvPr>
@@ -12400,14 +12401,14 @@
         </p:xfrm>
         <a:graphic xmlns:a="http://schemas.openxmlformats.org/drawingml/2006/main">
           <a:graphicData uri="http://schemas.openxmlformats.org/drawingml/2006/chart">
-            <c:chart xmlns:r="http://schemas.openxmlformats.org/officeDocument/2006/relationships" xmlns:c="http://schemas.openxmlformats.org/drawingml/2006/chart" r:id="Ra7aee7af29d541bf"/>
+            <c:chart xmlns:r="http://schemas.openxmlformats.org/officeDocument/2006/relationships" xmlns:c="http://schemas.openxmlformats.org/drawingml/2006/chart" r:id="Rd1ae6056a4d64e54"/>
           </a:graphicData>
         </a:graphic>
       </p:graphicFrame>
     </p:spTree>
     <p:extLst>
       <p:ext uri="{BB962C8B-B14F-4D97-AF65-F5344CB8AC3E}">
-        <p14:creationId xmlns:p14="http://schemas.microsoft.com/office/powerpoint/2010/main" val="719555260"/>
+        <p14:creationId xmlns:p14="http://schemas.microsoft.com/office/powerpoint/2010/main" val="2093405202"/>
       </p:ext>
     </p:extLst>
   </p:cSld>
@@ -12438,7 +12439,7 @@
           <p:cNvPr id="15" name="title-9">
             <a:extLst xmlns:a="http://schemas.openxmlformats.org/drawingml/2006/main">
               <a:ext uri="{FF2B5EF4-FFF2-40B4-BE49-F238E27FC236}">
-                <a16:creationId xmlns:a16="http://schemas.microsoft.com/office/drawing/2014/main" id="{172E5AF7-75A2-413B-9E39-29E4C6976B36}"/>
+                <a16:creationId xmlns:a16="http://schemas.microsoft.com/office/drawing/2014/main" id="{9FBCE0A1-F775-4AEC-AA89-9F33708537FE}"/>
               </a:ext>
             </a:extLst>
           </p:cNvPr>
@@ -12483,7 +12484,7 @@
           <p:cNvPr id="2" name="source-9">
             <a:extLst xmlns:a="http://schemas.openxmlformats.org/drawingml/2006/main">
               <a:ext uri="{FF2B5EF4-FFF2-40B4-BE49-F238E27FC236}">
-                <a16:creationId xmlns:a16="http://schemas.microsoft.com/office/drawing/2014/main" id="{7A61F4CC-10C0-4AFD-8625-4530D34BADA2}"/>
+                <a16:creationId xmlns:a16="http://schemas.microsoft.com/office/drawing/2014/main" id="{AA7F9863-0584-4030-8747-656A42E0F0A5}"/>
               </a:ext>
             </a:extLst>
           </p:cNvPr>
@@ -12528,7 +12529,7 @@
           <p:cNvPr id="3" name="page-9">
             <a:extLst xmlns:a="http://schemas.openxmlformats.org/drawingml/2006/main">
               <a:ext uri="{FF2B5EF4-FFF2-40B4-BE49-F238E27FC236}">
-                <a16:creationId xmlns:a16="http://schemas.microsoft.com/office/drawing/2014/main" id="{FA5F541D-6325-4958-A24E-28C91438DB7E}"/>
+                <a16:creationId xmlns:a16="http://schemas.microsoft.com/office/drawing/2014/main" id="{19E453A8-EDB0-4E91-A27A-1268EA2EAC26}"/>
               </a:ext>
             </a:extLst>
           </p:cNvPr>
@@ -12573,7 +12574,7 @@
           <p:cNvPr id="4" name="berlin-chart-title">
             <a:extLst xmlns:a="http://schemas.openxmlformats.org/drawingml/2006/main">
               <a:ext uri="{FF2B5EF4-FFF2-40B4-BE49-F238E27FC236}">
-                <a16:creationId xmlns:a16="http://schemas.microsoft.com/office/drawing/2014/main" id="{C244159F-C262-431D-9638-CEFDDC8411AD}"/>
+                <a16:creationId xmlns:a16="http://schemas.microsoft.com/office/drawing/2014/main" id="{B8DAD2EA-E836-4A48-BE8C-AC6A270C954B}"/>
               </a:ext>
             </a:extLst>
           </p:cNvPr>
@@ -12618,7 +12619,7 @@
           <p:cNvPr id="5" name="berlin-stock">
             <a:extLst xmlns:a="http://schemas.openxmlformats.org/drawingml/2006/main">
               <a:ext uri="{FF2B5EF4-FFF2-40B4-BE49-F238E27FC236}">
-                <a16:creationId xmlns:a16="http://schemas.microsoft.com/office/drawing/2014/main" id="{9E6C409E-39C8-449C-9281-C1F88E60E856}"/>
+                <a16:creationId xmlns:a16="http://schemas.microsoft.com/office/drawing/2014/main" id="{AB082D93-FBF8-4875-A737-65873FD43A88}"/>
               </a:ext>
             </a:extLst>
           </p:cNvPr>
@@ -12651,7 +12652,7 @@
           <p:cNvPr id="6" name="berlin-stock-stat">
             <a:extLst xmlns:a="http://schemas.openxmlformats.org/drawingml/2006/main">
               <a:ext uri="{FF2B5EF4-FFF2-40B4-BE49-F238E27FC236}">
-                <a16:creationId xmlns:a16="http://schemas.microsoft.com/office/drawing/2014/main" id="{10B43C9A-B296-4938-B3EA-B3CBE14BAEC7}"/>
+                <a16:creationId xmlns:a16="http://schemas.microsoft.com/office/drawing/2014/main" id="{B7C54161-1D3B-436B-BD7E-ED6AE1EE1039}"/>
               </a:ext>
             </a:extLst>
           </p:cNvPr>
@@ -12696,7 +12697,7 @@
           <p:cNvPr id="7" name="berlin-stock-body">
             <a:extLst xmlns:a="http://schemas.openxmlformats.org/drawingml/2006/main">
               <a:ext uri="{FF2B5EF4-FFF2-40B4-BE49-F238E27FC236}">
-                <a16:creationId xmlns:a16="http://schemas.microsoft.com/office/drawing/2014/main" id="{5FA07464-12CF-4FF5-9121-F7C5F3897146}"/>
+                <a16:creationId xmlns:a16="http://schemas.microsoft.com/office/drawing/2014/main" id="{CD3DA0DE-4AAA-4AEA-BA23-D64028048020}"/>
               </a:ext>
             </a:extLst>
           </p:cNvPr>
@@ -12741,7 +12742,7 @@
           <p:cNvPr id="8" name="berlin-market">
             <a:extLst xmlns:a="http://schemas.openxmlformats.org/drawingml/2006/main">
               <a:ext uri="{FF2B5EF4-FFF2-40B4-BE49-F238E27FC236}">
-                <a16:creationId xmlns:a16="http://schemas.microsoft.com/office/drawing/2014/main" id="{D7A24E9E-B9BB-4AC5-8EB0-9BDE4BCF7223}"/>
+                <a16:creationId xmlns:a16="http://schemas.microsoft.com/office/drawing/2014/main" id="{FB35482C-826D-4B93-8B95-C3DB319A9A0D}"/>
               </a:ext>
             </a:extLst>
           </p:cNvPr>
@@ -12774,7 +12775,7 @@
           <p:cNvPr id="9" name="berlin-market-stat">
             <a:extLst xmlns:a="http://schemas.openxmlformats.org/drawingml/2006/main">
               <a:ext uri="{FF2B5EF4-FFF2-40B4-BE49-F238E27FC236}">
-                <a16:creationId xmlns:a16="http://schemas.microsoft.com/office/drawing/2014/main" id="{47C3C0E2-1382-4A2B-A66D-50C0313FF5A6}"/>
+                <a16:creationId xmlns:a16="http://schemas.microsoft.com/office/drawing/2014/main" id="{B350EF5B-6D57-481D-883D-3EB4241349FF}"/>
               </a:ext>
             </a:extLst>
           </p:cNvPr>
@@ -12819,7 +12820,7 @@
           <p:cNvPr id="10" name="berlin-market-body">
             <a:extLst xmlns:a="http://schemas.openxmlformats.org/drawingml/2006/main">
               <a:ext uri="{FF2B5EF4-FFF2-40B4-BE49-F238E27FC236}">
-                <a16:creationId xmlns:a16="http://schemas.microsoft.com/office/drawing/2014/main" id="{67CC61D2-6CC0-4E3D-A84F-0E363F65C0B8}"/>
+                <a16:creationId xmlns:a16="http://schemas.microsoft.com/office/drawing/2014/main" id="{F16D010A-33FB-4666-B3FB-C5324A8C0794}"/>
               </a:ext>
             </a:extLst>
           </p:cNvPr>
@@ -12864,7 +12865,7 @@
           <p:cNvPr id="11" name="berlin-premium">
             <a:extLst xmlns:a="http://schemas.openxmlformats.org/drawingml/2006/main">
               <a:ext uri="{FF2B5EF4-FFF2-40B4-BE49-F238E27FC236}">
-                <a16:creationId xmlns:a16="http://schemas.microsoft.com/office/drawing/2014/main" id="{C63D4638-33E2-44B7-8D88-364B9398F8E6}"/>
+                <a16:creationId xmlns:a16="http://schemas.microsoft.com/office/drawing/2014/main" id="{8AFF188C-67AC-4A78-86BB-6E60B51D5F72}"/>
               </a:ext>
             </a:extLst>
           </p:cNvPr>
@@ -12897,7 +12898,7 @@
           <p:cNvPr id="12" name="berlin-premium-stat">
             <a:extLst xmlns:a="http://schemas.openxmlformats.org/drawingml/2006/main">
               <a:ext uri="{FF2B5EF4-FFF2-40B4-BE49-F238E27FC236}">
-                <a16:creationId xmlns:a16="http://schemas.microsoft.com/office/drawing/2014/main" id="{3F510D24-0291-42FF-9394-6D465A8A5532}"/>
+                <a16:creationId xmlns:a16="http://schemas.microsoft.com/office/drawing/2014/main" id="{BA8E2AEE-7E69-4B52-8109-840A8DC684E3}"/>
               </a:ext>
             </a:extLst>
           </p:cNvPr>
@@ -12942,7 +12943,7 @@
           <p:cNvPr id="13" name="berlin-premium-body">
             <a:extLst xmlns:a="http://schemas.openxmlformats.org/drawingml/2006/main">
               <a:ext uri="{FF2B5EF4-FFF2-40B4-BE49-F238E27FC236}">
-                <a16:creationId xmlns:a16="http://schemas.microsoft.com/office/drawing/2014/main" id="{1282808E-F6BC-4CD7-82DA-7551A6897DC9}"/>
+                <a16:creationId xmlns:a16="http://schemas.microsoft.com/office/drawing/2014/main" id="{B12357BF-06CB-4B24-9434-1FEE70D02B33}"/>
               </a:ext>
             </a:extLst>
           </p:cNvPr>
@@ -12994,14 +12995,14 @@
         </p:xfrm>
         <a:graphic xmlns:a="http://schemas.openxmlformats.org/drawingml/2006/main">
           <a:graphicData uri="http://schemas.openxmlformats.org/drawingml/2006/chart">
-            <c:chart xmlns:r="http://schemas.openxmlformats.org/officeDocument/2006/relationships" xmlns:c="http://schemas.openxmlformats.org/drawingml/2006/chart" r:id="R9d942f04fe354b26"/>
+            <c:chart xmlns:r="http://schemas.openxmlformats.org/officeDocument/2006/relationships" xmlns:c="http://schemas.openxmlformats.org/drawingml/2006/chart" r:id="R7e541d23dfdf479b"/>
           </a:graphicData>
         </a:graphic>
       </p:graphicFrame>
     </p:spTree>
     <p:extLst>
       <p:ext uri="{BB962C8B-B14F-4D97-AF65-F5344CB8AC3E}">
-        <p14:creationId xmlns:p14="http://schemas.microsoft.com/office/powerpoint/2010/main" val="1033701092"/>
+        <p14:creationId xmlns:p14="http://schemas.microsoft.com/office/powerpoint/2010/main" val="813791167"/>
       </p:ext>
     </p:extLst>
   </p:cSld>

</xml_diff>

<commit_message>
Refresh final presentation screenshots
</commit_message>
<xml_diff>
--- a/deliverables/MietCheck_Praesentation.pptx
+++ b/deliverables/MietCheck_Praesentation.pptx
@@ -2,27 +2,27 @@
 <file path=ppt/presentation.xml><?xml version="1.0" encoding="utf-8"?>
 <p:presentation xmlns:p="http://schemas.openxmlformats.org/presentationml/2006/main">
   <p:sldMasterIdLst>
-    <p:sldMasterId xmlns:r="http://schemas.openxmlformats.org/officeDocument/2006/relationships" id="2147483648" r:id="Rd74af7b903c94f74"/>
+    <p:sldMasterId xmlns:r="http://schemas.openxmlformats.org/officeDocument/2006/relationships" id="2147483648" r:id="R486ac3c18ef747c1"/>
   </p:sldMasterIdLst>
   <p:notesMasterIdLst>
-    <p:notesMasterId xmlns:r="http://schemas.openxmlformats.org/officeDocument/2006/relationships" r:id="R6a9eccaec81749cf"/>
+    <p:notesMasterId xmlns:r="http://schemas.openxmlformats.org/officeDocument/2006/relationships" r:id="R95560cb828384f37"/>
   </p:notesMasterIdLst>
   <p:sldIdLst>
-    <p:sldId xmlns:r="http://schemas.openxmlformats.org/officeDocument/2006/relationships" id="256" r:id="R59f82947c98749bf"/>
-    <p:sldId xmlns:r="http://schemas.openxmlformats.org/officeDocument/2006/relationships" id="257" r:id="Rf95952049be54bdc"/>
-    <p:sldId xmlns:r="http://schemas.openxmlformats.org/officeDocument/2006/relationships" id="258" r:id="Rf3a063a0d7ab49c1"/>
-    <p:sldId xmlns:r="http://schemas.openxmlformats.org/officeDocument/2006/relationships" id="259" r:id="Rc2787b436e65461f"/>
-    <p:sldId xmlns:r="http://schemas.openxmlformats.org/officeDocument/2006/relationships" id="260" r:id="Ra51d294c4efe48ae"/>
-    <p:sldId xmlns:r="http://schemas.openxmlformats.org/officeDocument/2006/relationships" id="261" r:id="Ra6e422a3cf984d78"/>
-    <p:sldId xmlns:r="http://schemas.openxmlformats.org/officeDocument/2006/relationships" id="262" r:id="R8fd5b83a351d44d9"/>
-    <p:sldId xmlns:r="http://schemas.openxmlformats.org/officeDocument/2006/relationships" id="263" r:id="R63c68c28d7b54be2"/>
-    <p:sldId xmlns:r="http://schemas.openxmlformats.org/officeDocument/2006/relationships" id="264" r:id="R24d527aeb4fc4a27"/>
-    <p:sldId xmlns:r="http://schemas.openxmlformats.org/officeDocument/2006/relationships" id="265" r:id="R7d0a6b7aa5e6412d"/>
-    <p:sldId xmlns:r="http://schemas.openxmlformats.org/officeDocument/2006/relationships" id="266" r:id="Rca0b0f4d5b9148da"/>
-    <p:sldId xmlns:r="http://schemas.openxmlformats.org/officeDocument/2006/relationships" id="267" r:id="R0b1141bb46c74302"/>
-    <p:sldId xmlns:r="http://schemas.openxmlformats.org/officeDocument/2006/relationships" id="268" r:id="Re54bd115386f448f"/>
-    <p:sldId xmlns:r="http://schemas.openxmlformats.org/officeDocument/2006/relationships" id="269" r:id="Re1b9434ea07247c3"/>
-    <p:sldId xmlns:r="http://schemas.openxmlformats.org/officeDocument/2006/relationships" id="270" r:id="R3b45aeb1fe1e4740"/>
+    <p:sldId xmlns:r="http://schemas.openxmlformats.org/officeDocument/2006/relationships" id="256" r:id="Rcb7a82c4884e465c"/>
+    <p:sldId xmlns:r="http://schemas.openxmlformats.org/officeDocument/2006/relationships" id="257" r:id="R7a267605e68e477f"/>
+    <p:sldId xmlns:r="http://schemas.openxmlformats.org/officeDocument/2006/relationships" id="258" r:id="R53095540859e438d"/>
+    <p:sldId xmlns:r="http://schemas.openxmlformats.org/officeDocument/2006/relationships" id="259" r:id="Rd52ec514c6ba4e89"/>
+    <p:sldId xmlns:r="http://schemas.openxmlformats.org/officeDocument/2006/relationships" id="260" r:id="R700a27651aa14cb2"/>
+    <p:sldId xmlns:r="http://schemas.openxmlformats.org/officeDocument/2006/relationships" id="261" r:id="Rfcf8e8dfd7ae402c"/>
+    <p:sldId xmlns:r="http://schemas.openxmlformats.org/officeDocument/2006/relationships" id="262" r:id="R5506b5c180e245f2"/>
+    <p:sldId xmlns:r="http://schemas.openxmlformats.org/officeDocument/2006/relationships" id="263" r:id="R6dbc020b071a418c"/>
+    <p:sldId xmlns:r="http://schemas.openxmlformats.org/officeDocument/2006/relationships" id="264" r:id="R5a35ccdff2a7428d"/>
+    <p:sldId xmlns:r="http://schemas.openxmlformats.org/officeDocument/2006/relationships" id="265" r:id="R5530bae41cbe4178"/>
+    <p:sldId xmlns:r="http://schemas.openxmlformats.org/officeDocument/2006/relationships" id="266" r:id="Red7fcff715104c62"/>
+    <p:sldId xmlns:r="http://schemas.openxmlformats.org/officeDocument/2006/relationships" id="267" r:id="Rdacf3dae28e445cc"/>
+    <p:sldId xmlns:r="http://schemas.openxmlformats.org/officeDocument/2006/relationships" id="268" r:id="Re1860da7128d45d7"/>
+    <p:sldId xmlns:r="http://schemas.openxmlformats.org/officeDocument/2006/relationships" id="269" r:id="R6c91d26415024273"/>
+    <p:sldId xmlns:r="http://schemas.openxmlformats.org/officeDocument/2006/relationships" id="270" r:id="Ra0469c87642540fc"/>
   </p:sldIdLst>
   <p:sldSz cx="12192000" cy="6858000"/>
   <p:notesSz cx="6858000" cy="9144000"/>
@@ -1669,7 +1669,7 @@
   </p:cSld>
   <p:clrMap bg1="lt1" tx1="dk1" bg2="lt2" tx2="dk2" accent1="accent1" accent2="accent2" accent3="accent3" accent4="accent4" accent5="accent5" accent6="accent6" hlink="hlink" folHlink="folHlink"/>
   <p:sldLayoutIdLst>
-    <p:sldLayoutId xmlns:r="http://schemas.openxmlformats.org/officeDocument/2006/relationships" id="2147483649" r:id="R164199c1b63e4da9"/>
+    <p:sldLayoutId xmlns:r="http://schemas.openxmlformats.org/officeDocument/2006/relationships" id="2147483649" r:id="R96432a40a01040fb"/>
   </p:sldLayoutIdLst>
   <p:txStyles>
     <p:titleStyle>
@@ -3280,18 +3280,43 @@
       </p:sp>
       <p:pic>
         <p:nvPicPr>
-          <p:cNvPr id="22" name=""/>
+          <p:cNvPr id="23" name=""/>
           <p:cNvPicPr>
             <a:picLocks xmlns:a="http://schemas.openxmlformats.org/drawingml/2006/main" noChangeAspect="1"/>
           </p:cNvPicPr>
           <p:nvPr/>
         </p:nvPicPr>
         <p:blipFill>
-          <a:blip xmlns:r="http://schemas.openxmlformats.org/officeDocument/2006/relationships" xmlns:a="http://schemas.openxmlformats.org/drawingml/2006/main" r:embed="R4498b7bb4f214c20"/>
+          <a:blip xmlns:r="http://schemas.openxmlformats.org/officeDocument/2006/relationships" xmlns:a="http://schemas.openxmlformats.org/drawingml/2006/main" r:embed="R14d5faa2807547c8"/>
           <a:srcRect xmlns:a="http://schemas.openxmlformats.org/drawingml/2006/main" l="13781" t="0" r="13781" b="0"/>
           <a:stretch xmlns:a="http://schemas.openxmlformats.org/drawingml/2006/main">
             <a:fillRect l="0" t="0" r="0" b="0"/>
           </a:stretch>
+        </p:blipFill>
+        <p:spPr>
+          <a:xfrm xmlns:a="http://schemas.openxmlformats.org/drawingml/2006/main">
+            <a:off x="6343650" y="495300"/>
+            <a:ext cx="5238750" cy="5524500"/>
+          </a:xfrm>
+          <a:prstGeom xmlns:a="http://schemas.openxmlformats.org/drawingml/2006/main" prst="roundRect">
+            <a:avLst>
+              <a:gd name="adj" fmla="val 2909"/>
+            </a:avLst>
+          </a:prstGeom>
+        </p:spPr>
+      </p:pic>
+      <p:pic>
+        <p:nvPicPr>
+          <p:cNvPr id="24" name=""/>
+          <p:cNvPicPr>
+            <a:picLocks xmlns:a="http://schemas.openxmlformats.org/drawingml/2006/main" noChangeAspect="1"/>
+          </p:cNvPicPr>
+          <p:nvPr/>
+        </p:nvPicPr>
+        <p:blipFill>
+          <a:blip xmlns:r="http://schemas.openxmlformats.org/officeDocument/2006/relationships" xmlns:a="http://schemas.openxmlformats.org/drawingml/2006/main" r:embed="R0e7732814023415b"/>
+          <a:srcRect xmlns:a="http://schemas.openxmlformats.org/drawingml/2006/main" l="13781" t="0" r="13781" b="0"/>
+          <a:stretch xmlns:a="http://schemas.openxmlformats.org/drawingml/2006/main"/>
         </p:blipFill>
         <p:spPr>
           <a:xfrm xmlns:a="http://schemas.openxmlformats.org/drawingml/2006/main" flipH="0" flipV="0">
@@ -3742,21 +3767,21 @@
       </p:sp>
       <p:pic>
         <p:nvPicPr>
-          <p:cNvPr id="27" name=""/>
+          <p:cNvPr id="28" name=""/>
           <p:cNvPicPr>
             <a:picLocks xmlns:a="http://schemas.openxmlformats.org/drawingml/2006/main" noChangeAspect="1"/>
           </p:cNvPicPr>
           <p:nvPr/>
         </p:nvPicPr>
         <p:blipFill>
-          <a:blip xmlns:r="http://schemas.openxmlformats.org/officeDocument/2006/relationships" xmlns:a="http://schemas.openxmlformats.org/drawingml/2006/main" r:embed="R70b145f3195e4925"/>
+          <a:blip xmlns:r="http://schemas.openxmlformats.org/officeDocument/2006/relationships" xmlns:a="http://schemas.openxmlformats.org/drawingml/2006/main" r:embed="Rf30716deb4ce4a81"/>
           <a:srcRect xmlns:a="http://schemas.openxmlformats.org/drawingml/2006/main" l="0" t="24967" r="0" b="24967"/>
           <a:stretch xmlns:a="http://schemas.openxmlformats.org/drawingml/2006/main">
             <a:fillRect l="0" t="0" r="0" b="0"/>
           </a:stretch>
         </p:blipFill>
         <p:spPr>
-          <a:xfrm xmlns:a="http://schemas.openxmlformats.org/drawingml/2006/main" flipH="0" flipV="0">
+          <a:xfrm xmlns:a="http://schemas.openxmlformats.org/drawingml/2006/main">
             <a:off x="552450" y="1485900"/>
             <a:ext cx="10858500" cy="4152900"/>
           </a:xfrm>
@@ -3890,6 +3915,29 @@
           </a:p>
         </p:txBody>
       </p:sp>
+      <p:pic>
+        <p:nvPicPr>
+          <p:cNvPr id="32" name=""/>
+          <p:cNvPicPr>
+            <a:picLocks xmlns:a="http://schemas.openxmlformats.org/drawingml/2006/main" noChangeAspect="1"/>
+          </p:cNvPicPr>
+          <p:nvPr/>
+        </p:nvPicPr>
+        <p:blipFill>
+          <a:blip xmlns:r="http://schemas.openxmlformats.org/officeDocument/2006/relationships" xmlns:a="http://schemas.openxmlformats.org/drawingml/2006/main" r:embed="Rbf96ecff7d2b44d1"/>
+          <a:srcRect xmlns:a="http://schemas.openxmlformats.org/drawingml/2006/main" l="0" t="24967" r="0" b="24967"/>
+          <a:stretch xmlns:a="http://schemas.openxmlformats.org/drawingml/2006/main"/>
+        </p:blipFill>
+        <p:spPr>
+          <a:xfrm xmlns:a="http://schemas.openxmlformats.org/drawingml/2006/main" flipH="0" flipV="0">
+            <a:off x="552450" y="1485900"/>
+            <a:ext cx="10858500" cy="4152900"/>
+          </a:xfrm>
+          <a:prstGeom xmlns:a="http://schemas.openxmlformats.org/drawingml/2006/main" prst="rect">
+            <a:avLst/>
+          </a:prstGeom>
+        </p:spPr>
+      </p:pic>
     </p:spTree>
     <p:extLst>
       <p:ext uri="{BB962C8B-B14F-4D97-AF65-F5344CB8AC3E}">
@@ -4329,21 +4377,21 @@
       </p:sp>
       <p:pic>
         <p:nvPicPr>
-          <p:cNvPr id="27" name=""/>
+          <p:cNvPr id="28" name=""/>
           <p:cNvPicPr>
             <a:picLocks xmlns:a="http://schemas.openxmlformats.org/drawingml/2006/main" noChangeAspect="1"/>
           </p:cNvPicPr>
           <p:nvPr/>
         </p:nvPicPr>
         <p:blipFill>
-          <a:blip xmlns:r="http://schemas.openxmlformats.org/officeDocument/2006/relationships" xmlns:a="http://schemas.openxmlformats.org/drawingml/2006/main" r:embed="R2216b5a7a3184ff2"/>
+          <a:blip xmlns:r="http://schemas.openxmlformats.org/officeDocument/2006/relationships" xmlns:a="http://schemas.openxmlformats.org/drawingml/2006/main" r:embed="Re4be06e879584ceb"/>
           <a:srcRect xmlns:a="http://schemas.openxmlformats.org/drawingml/2006/main" l="0" t="24967" r="0" b="24967"/>
           <a:stretch xmlns:a="http://schemas.openxmlformats.org/drawingml/2006/main">
             <a:fillRect l="0" t="0" r="0" b="0"/>
           </a:stretch>
         </p:blipFill>
         <p:spPr>
-          <a:xfrm xmlns:a="http://schemas.openxmlformats.org/drawingml/2006/main" flipH="0" flipV="0">
+          <a:xfrm xmlns:a="http://schemas.openxmlformats.org/drawingml/2006/main">
             <a:off x="552450" y="1485900"/>
             <a:ext cx="10858500" cy="4152900"/>
           </a:xfrm>
@@ -4477,6 +4525,29 @@
           </a:p>
         </p:txBody>
       </p:sp>
+      <p:pic>
+        <p:nvPicPr>
+          <p:cNvPr id="32" name=""/>
+          <p:cNvPicPr>
+            <a:picLocks xmlns:a="http://schemas.openxmlformats.org/drawingml/2006/main" noChangeAspect="1"/>
+          </p:cNvPicPr>
+          <p:nvPr/>
+        </p:nvPicPr>
+        <p:blipFill>
+          <a:blip xmlns:r="http://schemas.openxmlformats.org/officeDocument/2006/relationships" xmlns:a="http://schemas.openxmlformats.org/drawingml/2006/main" r:embed="R5bd64cf3d9394ebe"/>
+          <a:srcRect xmlns:a="http://schemas.openxmlformats.org/drawingml/2006/main" l="0" t="24967" r="0" b="24967"/>
+          <a:stretch xmlns:a="http://schemas.openxmlformats.org/drawingml/2006/main"/>
+        </p:blipFill>
+        <p:spPr>
+          <a:xfrm xmlns:a="http://schemas.openxmlformats.org/drawingml/2006/main" flipH="0" flipV="0">
+            <a:off x="552450" y="1485900"/>
+            <a:ext cx="10858500" cy="4152900"/>
+          </a:xfrm>
+          <a:prstGeom xmlns:a="http://schemas.openxmlformats.org/drawingml/2006/main" prst="rect">
+            <a:avLst/>
+          </a:prstGeom>
+        </p:spPr>
+      </p:pic>
     </p:spTree>
     <p:extLst>
       <p:ext uri="{BB962C8B-B14F-4D97-AF65-F5344CB8AC3E}">
@@ -4916,21 +4987,21 @@
       </p:sp>
       <p:pic>
         <p:nvPicPr>
-          <p:cNvPr id="27" name=""/>
+          <p:cNvPr id="28" name=""/>
           <p:cNvPicPr>
             <a:picLocks xmlns:a="http://schemas.openxmlformats.org/drawingml/2006/main" noChangeAspect="1"/>
           </p:cNvPicPr>
           <p:nvPr/>
         </p:nvPicPr>
         <p:blipFill>
-          <a:blip xmlns:r="http://schemas.openxmlformats.org/officeDocument/2006/relationships" xmlns:a="http://schemas.openxmlformats.org/drawingml/2006/main" r:embed="R43eb2a6d3d1e4257"/>
+          <a:blip xmlns:r="http://schemas.openxmlformats.org/officeDocument/2006/relationships" xmlns:a="http://schemas.openxmlformats.org/drawingml/2006/main" r:embed="Rca38efdbcdac4d5c"/>
           <a:srcRect xmlns:a="http://schemas.openxmlformats.org/drawingml/2006/main" l="0" t="24967" r="0" b="24967"/>
           <a:stretch xmlns:a="http://schemas.openxmlformats.org/drawingml/2006/main">
             <a:fillRect l="0" t="0" r="0" b="0"/>
           </a:stretch>
         </p:blipFill>
         <p:spPr>
-          <a:xfrm xmlns:a="http://schemas.openxmlformats.org/drawingml/2006/main" flipH="0" flipV="0">
+          <a:xfrm xmlns:a="http://schemas.openxmlformats.org/drawingml/2006/main">
             <a:off x="552450" y="1485900"/>
             <a:ext cx="10858500" cy="4152900"/>
           </a:xfrm>
@@ -5064,6 +5135,29 @@
           </a:p>
         </p:txBody>
       </p:sp>
+      <p:pic>
+        <p:nvPicPr>
+          <p:cNvPr id="32" name=""/>
+          <p:cNvPicPr>
+            <a:picLocks xmlns:a="http://schemas.openxmlformats.org/drawingml/2006/main" noChangeAspect="1"/>
+          </p:cNvPicPr>
+          <p:nvPr/>
+        </p:nvPicPr>
+        <p:blipFill>
+          <a:blip xmlns:r="http://schemas.openxmlformats.org/officeDocument/2006/relationships" xmlns:a="http://schemas.openxmlformats.org/drawingml/2006/main" r:embed="R616d979630954547"/>
+          <a:srcRect xmlns:a="http://schemas.openxmlformats.org/drawingml/2006/main" l="0" t="24967" r="0" b="24967"/>
+          <a:stretch xmlns:a="http://schemas.openxmlformats.org/drawingml/2006/main"/>
+        </p:blipFill>
+        <p:spPr>
+          <a:xfrm xmlns:a="http://schemas.openxmlformats.org/drawingml/2006/main" flipH="0" flipV="0">
+            <a:off x="552450" y="1485900"/>
+            <a:ext cx="10858500" cy="4152900"/>
+          </a:xfrm>
+          <a:prstGeom xmlns:a="http://schemas.openxmlformats.org/drawingml/2006/main" prst="rect">
+            <a:avLst/>
+          </a:prstGeom>
+        </p:spPr>
+      </p:pic>
     </p:spTree>
     <p:extLst>
       <p:ext uri="{BB962C8B-B14F-4D97-AF65-F5344CB8AC3E}">
@@ -13475,7 +13569,7 @@
         </p:xfrm>
         <a:graphic xmlns:a="http://schemas.openxmlformats.org/drawingml/2006/main">
           <a:graphicData uri="http://schemas.openxmlformats.org/drawingml/2006/chart">
-            <c:chart xmlns:r="http://schemas.openxmlformats.org/officeDocument/2006/relationships" xmlns:c="http://schemas.openxmlformats.org/drawingml/2006/chart" r:id="R5701dbc3da0640c0"/>
+            <c:chart xmlns:r="http://schemas.openxmlformats.org/officeDocument/2006/relationships" xmlns:c="http://schemas.openxmlformats.org/drawingml/2006/chart" r:id="Rfec4d31512b34c71"/>
           </a:graphicData>
         </a:graphic>
       </p:graphicFrame>
@@ -14145,7 +14239,7 @@
         </p:xfrm>
         <a:graphic xmlns:a="http://schemas.openxmlformats.org/drawingml/2006/main">
           <a:graphicData uri="http://schemas.openxmlformats.org/drawingml/2006/chart">
-            <c:chart xmlns:r="http://schemas.openxmlformats.org/officeDocument/2006/relationships" xmlns:c="http://schemas.openxmlformats.org/drawingml/2006/chart" r:id="Rff0d65f5e92d4918"/>
+            <c:chart xmlns:r="http://schemas.openxmlformats.org/officeDocument/2006/relationships" xmlns:c="http://schemas.openxmlformats.org/drawingml/2006/chart" r:id="R0bf4d8e300bc4a56"/>
           </a:graphicData>
         </a:graphic>
       </p:graphicFrame>
@@ -14815,7 +14909,7 @@
         </p:xfrm>
         <a:graphic xmlns:a="http://schemas.openxmlformats.org/drawingml/2006/main">
           <a:graphicData uri="http://schemas.openxmlformats.org/drawingml/2006/chart">
-            <c:chart xmlns:r="http://schemas.openxmlformats.org/officeDocument/2006/relationships" xmlns:c="http://schemas.openxmlformats.org/drawingml/2006/chart" r:id="Re0b9e2f89c794bcb"/>
+            <c:chart xmlns:r="http://schemas.openxmlformats.org/officeDocument/2006/relationships" xmlns:c="http://schemas.openxmlformats.org/drawingml/2006/chart" r:id="Rc8a65d3d12c4478f"/>
           </a:graphicData>
         </a:graphic>
       </p:graphicFrame>

</xml_diff>

<commit_message>
Refresh final presentation screenshots (#5)
</commit_message>
<xml_diff>
--- a/deliverables/MietCheck_Praesentation.pptx
+++ b/deliverables/MietCheck_Praesentation.pptx
@@ -2,27 +2,27 @@
 <file path=ppt/presentation.xml><?xml version="1.0" encoding="utf-8"?>
 <p:presentation xmlns:p="http://schemas.openxmlformats.org/presentationml/2006/main">
   <p:sldMasterIdLst>
-    <p:sldMasterId xmlns:r="http://schemas.openxmlformats.org/officeDocument/2006/relationships" id="2147483648" r:id="Rd74af7b903c94f74"/>
+    <p:sldMasterId xmlns:r="http://schemas.openxmlformats.org/officeDocument/2006/relationships" id="2147483648" r:id="R486ac3c18ef747c1"/>
   </p:sldMasterIdLst>
   <p:notesMasterIdLst>
-    <p:notesMasterId xmlns:r="http://schemas.openxmlformats.org/officeDocument/2006/relationships" r:id="R6a9eccaec81749cf"/>
+    <p:notesMasterId xmlns:r="http://schemas.openxmlformats.org/officeDocument/2006/relationships" r:id="R95560cb828384f37"/>
   </p:notesMasterIdLst>
   <p:sldIdLst>
-    <p:sldId xmlns:r="http://schemas.openxmlformats.org/officeDocument/2006/relationships" id="256" r:id="R59f82947c98749bf"/>
-    <p:sldId xmlns:r="http://schemas.openxmlformats.org/officeDocument/2006/relationships" id="257" r:id="Rf95952049be54bdc"/>
-    <p:sldId xmlns:r="http://schemas.openxmlformats.org/officeDocument/2006/relationships" id="258" r:id="Rf3a063a0d7ab49c1"/>
-    <p:sldId xmlns:r="http://schemas.openxmlformats.org/officeDocument/2006/relationships" id="259" r:id="Rc2787b436e65461f"/>
-    <p:sldId xmlns:r="http://schemas.openxmlformats.org/officeDocument/2006/relationships" id="260" r:id="Ra51d294c4efe48ae"/>
-    <p:sldId xmlns:r="http://schemas.openxmlformats.org/officeDocument/2006/relationships" id="261" r:id="Ra6e422a3cf984d78"/>
-    <p:sldId xmlns:r="http://schemas.openxmlformats.org/officeDocument/2006/relationships" id="262" r:id="R8fd5b83a351d44d9"/>
-    <p:sldId xmlns:r="http://schemas.openxmlformats.org/officeDocument/2006/relationships" id="263" r:id="R63c68c28d7b54be2"/>
-    <p:sldId xmlns:r="http://schemas.openxmlformats.org/officeDocument/2006/relationships" id="264" r:id="R24d527aeb4fc4a27"/>
-    <p:sldId xmlns:r="http://schemas.openxmlformats.org/officeDocument/2006/relationships" id="265" r:id="R7d0a6b7aa5e6412d"/>
-    <p:sldId xmlns:r="http://schemas.openxmlformats.org/officeDocument/2006/relationships" id="266" r:id="Rca0b0f4d5b9148da"/>
-    <p:sldId xmlns:r="http://schemas.openxmlformats.org/officeDocument/2006/relationships" id="267" r:id="R0b1141bb46c74302"/>
-    <p:sldId xmlns:r="http://schemas.openxmlformats.org/officeDocument/2006/relationships" id="268" r:id="Re54bd115386f448f"/>
-    <p:sldId xmlns:r="http://schemas.openxmlformats.org/officeDocument/2006/relationships" id="269" r:id="Re1b9434ea07247c3"/>
-    <p:sldId xmlns:r="http://schemas.openxmlformats.org/officeDocument/2006/relationships" id="270" r:id="R3b45aeb1fe1e4740"/>
+    <p:sldId xmlns:r="http://schemas.openxmlformats.org/officeDocument/2006/relationships" id="256" r:id="Rcb7a82c4884e465c"/>
+    <p:sldId xmlns:r="http://schemas.openxmlformats.org/officeDocument/2006/relationships" id="257" r:id="R7a267605e68e477f"/>
+    <p:sldId xmlns:r="http://schemas.openxmlformats.org/officeDocument/2006/relationships" id="258" r:id="R53095540859e438d"/>
+    <p:sldId xmlns:r="http://schemas.openxmlformats.org/officeDocument/2006/relationships" id="259" r:id="Rd52ec514c6ba4e89"/>
+    <p:sldId xmlns:r="http://schemas.openxmlformats.org/officeDocument/2006/relationships" id="260" r:id="R700a27651aa14cb2"/>
+    <p:sldId xmlns:r="http://schemas.openxmlformats.org/officeDocument/2006/relationships" id="261" r:id="Rfcf8e8dfd7ae402c"/>
+    <p:sldId xmlns:r="http://schemas.openxmlformats.org/officeDocument/2006/relationships" id="262" r:id="R5506b5c180e245f2"/>
+    <p:sldId xmlns:r="http://schemas.openxmlformats.org/officeDocument/2006/relationships" id="263" r:id="R6dbc020b071a418c"/>
+    <p:sldId xmlns:r="http://schemas.openxmlformats.org/officeDocument/2006/relationships" id="264" r:id="R5a35ccdff2a7428d"/>
+    <p:sldId xmlns:r="http://schemas.openxmlformats.org/officeDocument/2006/relationships" id="265" r:id="R5530bae41cbe4178"/>
+    <p:sldId xmlns:r="http://schemas.openxmlformats.org/officeDocument/2006/relationships" id="266" r:id="Red7fcff715104c62"/>
+    <p:sldId xmlns:r="http://schemas.openxmlformats.org/officeDocument/2006/relationships" id="267" r:id="Rdacf3dae28e445cc"/>
+    <p:sldId xmlns:r="http://schemas.openxmlformats.org/officeDocument/2006/relationships" id="268" r:id="Re1860da7128d45d7"/>
+    <p:sldId xmlns:r="http://schemas.openxmlformats.org/officeDocument/2006/relationships" id="269" r:id="R6c91d26415024273"/>
+    <p:sldId xmlns:r="http://schemas.openxmlformats.org/officeDocument/2006/relationships" id="270" r:id="Ra0469c87642540fc"/>
   </p:sldIdLst>
   <p:sldSz cx="12192000" cy="6858000"/>
   <p:notesSz cx="6858000" cy="9144000"/>
@@ -1669,7 +1669,7 @@
   </p:cSld>
   <p:clrMap bg1="lt1" tx1="dk1" bg2="lt2" tx2="dk2" accent1="accent1" accent2="accent2" accent3="accent3" accent4="accent4" accent5="accent5" accent6="accent6" hlink="hlink" folHlink="folHlink"/>
   <p:sldLayoutIdLst>
-    <p:sldLayoutId xmlns:r="http://schemas.openxmlformats.org/officeDocument/2006/relationships" id="2147483649" r:id="R164199c1b63e4da9"/>
+    <p:sldLayoutId xmlns:r="http://schemas.openxmlformats.org/officeDocument/2006/relationships" id="2147483649" r:id="R96432a40a01040fb"/>
   </p:sldLayoutIdLst>
   <p:txStyles>
     <p:titleStyle>
@@ -3280,18 +3280,43 @@
       </p:sp>
       <p:pic>
         <p:nvPicPr>
-          <p:cNvPr id="22" name=""/>
+          <p:cNvPr id="23" name=""/>
           <p:cNvPicPr>
             <a:picLocks xmlns:a="http://schemas.openxmlformats.org/drawingml/2006/main" noChangeAspect="1"/>
           </p:cNvPicPr>
           <p:nvPr/>
         </p:nvPicPr>
         <p:blipFill>
-          <a:blip xmlns:r="http://schemas.openxmlformats.org/officeDocument/2006/relationships" xmlns:a="http://schemas.openxmlformats.org/drawingml/2006/main" r:embed="R4498b7bb4f214c20"/>
+          <a:blip xmlns:r="http://schemas.openxmlformats.org/officeDocument/2006/relationships" xmlns:a="http://schemas.openxmlformats.org/drawingml/2006/main" r:embed="R14d5faa2807547c8"/>
           <a:srcRect xmlns:a="http://schemas.openxmlformats.org/drawingml/2006/main" l="13781" t="0" r="13781" b="0"/>
           <a:stretch xmlns:a="http://schemas.openxmlformats.org/drawingml/2006/main">
             <a:fillRect l="0" t="0" r="0" b="0"/>
           </a:stretch>
+        </p:blipFill>
+        <p:spPr>
+          <a:xfrm xmlns:a="http://schemas.openxmlformats.org/drawingml/2006/main">
+            <a:off x="6343650" y="495300"/>
+            <a:ext cx="5238750" cy="5524500"/>
+          </a:xfrm>
+          <a:prstGeom xmlns:a="http://schemas.openxmlformats.org/drawingml/2006/main" prst="roundRect">
+            <a:avLst>
+              <a:gd name="adj" fmla="val 2909"/>
+            </a:avLst>
+          </a:prstGeom>
+        </p:spPr>
+      </p:pic>
+      <p:pic>
+        <p:nvPicPr>
+          <p:cNvPr id="24" name=""/>
+          <p:cNvPicPr>
+            <a:picLocks xmlns:a="http://schemas.openxmlformats.org/drawingml/2006/main" noChangeAspect="1"/>
+          </p:cNvPicPr>
+          <p:nvPr/>
+        </p:nvPicPr>
+        <p:blipFill>
+          <a:blip xmlns:r="http://schemas.openxmlformats.org/officeDocument/2006/relationships" xmlns:a="http://schemas.openxmlformats.org/drawingml/2006/main" r:embed="R0e7732814023415b"/>
+          <a:srcRect xmlns:a="http://schemas.openxmlformats.org/drawingml/2006/main" l="13781" t="0" r="13781" b="0"/>
+          <a:stretch xmlns:a="http://schemas.openxmlformats.org/drawingml/2006/main"/>
         </p:blipFill>
         <p:spPr>
           <a:xfrm xmlns:a="http://schemas.openxmlformats.org/drawingml/2006/main" flipH="0" flipV="0">
@@ -3742,21 +3767,21 @@
       </p:sp>
       <p:pic>
         <p:nvPicPr>
-          <p:cNvPr id="27" name=""/>
+          <p:cNvPr id="28" name=""/>
           <p:cNvPicPr>
             <a:picLocks xmlns:a="http://schemas.openxmlformats.org/drawingml/2006/main" noChangeAspect="1"/>
           </p:cNvPicPr>
           <p:nvPr/>
         </p:nvPicPr>
         <p:blipFill>
-          <a:blip xmlns:r="http://schemas.openxmlformats.org/officeDocument/2006/relationships" xmlns:a="http://schemas.openxmlformats.org/drawingml/2006/main" r:embed="R70b145f3195e4925"/>
+          <a:blip xmlns:r="http://schemas.openxmlformats.org/officeDocument/2006/relationships" xmlns:a="http://schemas.openxmlformats.org/drawingml/2006/main" r:embed="Rf30716deb4ce4a81"/>
           <a:srcRect xmlns:a="http://schemas.openxmlformats.org/drawingml/2006/main" l="0" t="24967" r="0" b="24967"/>
           <a:stretch xmlns:a="http://schemas.openxmlformats.org/drawingml/2006/main">
             <a:fillRect l="0" t="0" r="0" b="0"/>
           </a:stretch>
         </p:blipFill>
         <p:spPr>
-          <a:xfrm xmlns:a="http://schemas.openxmlformats.org/drawingml/2006/main" flipH="0" flipV="0">
+          <a:xfrm xmlns:a="http://schemas.openxmlformats.org/drawingml/2006/main">
             <a:off x="552450" y="1485900"/>
             <a:ext cx="10858500" cy="4152900"/>
           </a:xfrm>
@@ -3890,6 +3915,29 @@
           </a:p>
         </p:txBody>
       </p:sp>
+      <p:pic>
+        <p:nvPicPr>
+          <p:cNvPr id="32" name=""/>
+          <p:cNvPicPr>
+            <a:picLocks xmlns:a="http://schemas.openxmlformats.org/drawingml/2006/main" noChangeAspect="1"/>
+          </p:cNvPicPr>
+          <p:nvPr/>
+        </p:nvPicPr>
+        <p:blipFill>
+          <a:blip xmlns:r="http://schemas.openxmlformats.org/officeDocument/2006/relationships" xmlns:a="http://schemas.openxmlformats.org/drawingml/2006/main" r:embed="Rbf96ecff7d2b44d1"/>
+          <a:srcRect xmlns:a="http://schemas.openxmlformats.org/drawingml/2006/main" l="0" t="24967" r="0" b="24967"/>
+          <a:stretch xmlns:a="http://schemas.openxmlformats.org/drawingml/2006/main"/>
+        </p:blipFill>
+        <p:spPr>
+          <a:xfrm xmlns:a="http://schemas.openxmlformats.org/drawingml/2006/main" flipH="0" flipV="0">
+            <a:off x="552450" y="1485900"/>
+            <a:ext cx="10858500" cy="4152900"/>
+          </a:xfrm>
+          <a:prstGeom xmlns:a="http://schemas.openxmlformats.org/drawingml/2006/main" prst="rect">
+            <a:avLst/>
+          </a:prstGeom>
+        </p:spPr>
+      </p:pic>
     </p:spTree>
     <p:extLst>
       <p:ext uri="{BB962C8B-B14F-4D97-AF65-F5344CB8AC3E}">
@@ -4329,21 +4377,21 @@
       </p:sp>
       <p:pic>
         <p:nvPicPr>
-          <p:cNvPr id="27" name=""/>
+          <p:cNvPr id="28" name=""/>
           <p:cNvPicPr>
             <a:picLocks xmlns:a="http://schemas.openxmlformats.org/drawingml/2006/main" noChangeAspect="1"/>
           </p:cNvPicPr>
           <p:nvPr/>
         </p:nvPicPr>
         <p:blipFill>
-          <a:blip xmlns:r="http://schemas.openxmlformats.org/officeDocument/2006/relationships" xmlns:a="http://schemas.openxmlformats.org/drawingml/2006/main" r:embed="R2216b5a7a3184ff2"/>
+          <a:blip xmlns:r="http://schemas.openxmlformats.org/officeDocument/2006/relationships" xmlns:a="http://schemas.openxmlformats.org/drawingml/2006/main" r:embed="Re4be06e879584ceb"/>
           <a:srcRect xmlns:a="http://schemas.openxmlformats.org/drawingml/2006/main" l="0" t="24967" r="0" b="24967"/>
           <a:stretch xmlns:a="http://schemas.openxmlformats.org/drawingml/2006/main">
             <a:fillRect l="0" t="0" r="0" b="0"/>
           </a:stretch>
         </p:blipFill>
         <p:spPr>
-          <a:xfrm xmlns:a="http://schemas.openxmlformats.org/drawingml/2006/main" flipH="0" flipV="0">
+          <a:xfrm xmlns:a="http://schemas.openxmlformats.org/drawingml/2006/main">
             <a:off x="552450" y="1485900"/>
             <a:ext cx="10858500" cy="4152900"/>
           </a:xfrm>
@@ -4477,6 +4525,29 @@
           </a:p>
         </p:txBody>
       </p:sp>
+      <p:pic>
+        <p:nvPicPr>
+          <p:cNvPr id="32" name=""/>
+          <p:cNvPicPr>
+            <a:picLocks xmlns:a="http://schemas.openxmlformats.org/drawingml/2006/main" noChangeAspect="1"/>
+          </p:cNvPicPr>
+          <p:nvPr/>
+        </p:nvPicPr>
+        <p:blipFill>
+          <a:blip xmlns:r="http://schemas.openxmlformats.org/officeDocument/2006/relationships" xmlns:a="http://schemas.openxmlformats.org/drawingml/2006/main" r:embed="R5bd64cf3d9394ebe"/>
+          <a:srcRect xmlns:a="http://schemas.openxmlformats.org/drawingml/2006/main" l="0" t="24967" r="0" b="24967"/>
+          <a:stretch xmlns:a="http://schemas.openxmlformats.org/drawingml/2006/main"/>
+        </p:blipFill>
+        <p:spPr>
+          <a:xfrm xmlns:a="http://schemas.openxmlformats.org/drawingml/2006/main" flipH="0" flipV="0">
+            <a:off x="552450" y="1485900"/>
+            <a:ext cx="10858500" cy="4152900"/>
+          </a:xfrm>
+          <a:prstGeom xmlns:a="http://schemas.openxmlformats.org/drawingml/2006/main" prst="rect">
+            <a:avLst/>
+          </a:prstGeom>
+        </p:spPr>
+      </p:pic>
     </p:spTree>
     <p:extLst>
       <p:ext uri="{BB962C8B-B14F-4D97-AF65-F5344CB8AC3E}">
@@ -4916,21 +4987,21 @@
       </p:sp>
       <p:pic>
         <p:nvPicPr>
-          <p:cNvPr id="27" name=""/>
+          <p:cNvPr id="28" name=""/>
           <p:cNvPicPr>
             <a:picLocks xmlns:a="http://schemas.openxmlformats.org/drawingml/2006/main" noChangeAspect="1"/>
           </p:cNvPicPr>
           <p:nvPr/>
         </p:nvPicPr>
         <p:blipFill>
-          <a:blip xmlns:r="http://schemas.openxmlformats.org/officeDocument/2006/relationships" xmlns:a="http://schemas.openxmlformats.org/drawingml/2006/main" r:embed="R43eb2a6d3d1e4257"/>
+          <a:blip xmlns:r="http://schemas.openxmlformats.org/officeDocument/2006/relationships" xmlns:a="http://schemas.openxmlformats.org/drawingml/2006/main" r:embed="Rca38efdbcdac4d5c"/>
           <a:srcRect xmlns:a="http://schemas.openxmlformats.org/drawingml/2006/main" l="0" t="24967" r="0" b="24967"/>
           <a:stretch xmlns:a="http://schemas.openxmlformats.org/drawingml/2006/main">
             <a:fillRect l="0" t="0" r="0" b="0"/>
           </a:stretch>
         </p:blipFill>
         <p:spPr>
-          <a:xfrm xmlns:a="http://schemas.openxmlformats.org/drawingml/2006/main" flipH="0" flipV="0">
+          <a:xfrm xmlns:a="http://schemas.openxmlformats.org/drawingml/2006/main">
             <a:off x="552450" y="1485900"/>
             <a:ext cx="10858500" cy="4152900"/>
           </a:xfrm>
@@ -5064,6 +5135,29 @@
           </a:p>
         </p:txBody>
       </p:sp>
+      <p:pic>
+        <p:nvPicPr>
+          <p:cNvPr id="32" name=""/>
+          <p:cNvPicPr>
+            <a:picLocks xmlns:a="http://schemas.openxmlformats.org/drawingml/2006/main" noChangeAspect="1"/>
+          </p:cNvPicPr>
+          <p:nvPr/>
+        </p:nvPicPr>
+        <p:blipFill>
+          <a:blip xmlns:r="http://schemas.openxmlformats.org/officeDocument/2006/relationships" xmlns:a="http://schemas.openxmlformats.org/drawingml/2006/main" r:embed="R616d979630954547"/>
+          <a:srcRect xmlns:a="http://schemas.openxmlformats.org/drawingml/2006/main" l="0" t="24967" r="0" b="24967"/>
+          <a:stretch xmlns:a="http://schemas.openxmlformats.org/drawingml/2006/main"/>
+        </p:blipFill>
+        <p:spPr>
+          <a:xfrm xmlns:a="http://schemas.openxmlformats.org/drawingml/2006/main" flipH="0" flipV="0">
+            <a:off x="552450" y="1485900"/>
+            <a:ext cx="10858500" cy="4152900"/>
+          </a:xfrm>
+          <a:prstGeom xmlns:a="http://schemas.openxmlformats.org/drawingml/2006/main" prst="rect">
+            <a:avLst/>
+          </a:prstGeom>
+        </p:spPr>
+      </p:pic>
     </p:spTree>
     <p:extLst>
       <p:ext uri="{BB962C8B-B14F-4D97-AF65-F5344CB8AC3E}">
@@ -13475,7 +13569,7 @@
         </p:xfrm>
         <a:graphic xmlns:a="http://schemas.openxmlformats.org/drawingml/2006/main">
           <a:graphicData uri="http://schemas.openxmlformats.org/drawingml/2006/chart">
-            <c:chart xmlns:r="http://schemas.openxmlformats.org/officeDocument/2006/relationships" xmlns:c="http://schemas.openxmlformats.org/drawingml/2006/chart" r:id="R5701dbc3da0640c0"/>
+            <c:chart xmlns:r="http://schemas.openxmlformats.org/officeDocument/2006/relationships" xmlns:c="http://schemas.openxmlformats.org/drawingml/2006/chart" r:id="Rfec4d31512b34c71"/>
           </a:graphicData>
         </a:graphic>
       </p:graphicFrame>
@@ -14145,7 +14239,7 @@
         </p:xfrm>
         <a:graphic xmlns:a="http://schemas.openxmlformats.org/drawingml/2006/main">
           <a:graphicData uri="http://schemas.openxmlformats.org/drawingml/2006/chart">
-            <c:chart xmlns:r="http://schemas.openxmlformats.org/officeDocument/2006/relationships" xmlns:c="http://schemas.openxmlformats.org/drawingml/2006/chart" r:id="Rff0d65f5e92d4918"/>
+            <c:chart xmlns:r="http://schemas.openxmlformats.org/officeDocument/2006/relationships" xmlns:c="http://schemas.openxmlformats.org/drawingml/2006/chart" r:id="R0bf4d8e300bc4a56"/>
           </a:graphicData>
         </a:graphic>
       </p:graphicFrame>
@@ -14815,7 +14909,7 @@
         </p:xfrm>
         <a:graphic xmlns:a="http://schemas.openxmlformats.org/drawingml/2006/main">
           <a:graphicData uri="http://schemas.openxmlformats.org/drawingml/2006/chart">
-            <c:chart xmlns:r="http://schemas.openxmlformats.org/officeDocument/2006/relationships" xmlns:c="http://schemas.openxmlformats.org/drawingml/2006/chart" r:id="Re0b9e2f89c794bcb"/>
+            <c:chart xmlns:r="http://schemas.openxmlformats.org/officeDocument/2006/relationships" xmlns:c="http://schemas.openxmlformats.org/drawingml/2006/chart" r:id="Rc8a65d3d12c4478f"/>
           </a:graphicData>
         </a:graphic>
       </p:graphicFrame>

</xml_diff>